<commit_message>
Updating 073 New Relic hack to get rid of 'gameday'
Signed-off-by: Harry Kimpel <harrykimpel@hotmail.com>
</commit_message>
<xml_diff>
--- a/073-NewRelicAgentObservability/Coach/Lectures.pptx
+++ b/073-NewRelicAgentObservability/Coach/Lectures.pptx
@@ -5,44 +5,45 @@
     <p:sldMasterId id="2147483986" r:id="rId4"/>
   </p:sldMasterIdLst>
   <p:notesMasterIdLst>
-    <p:notesMasterId r:id="rId37"/>
+    <p:notesMasterId r:id="rId38"/>
   </p:notesMasterIdLst>
   <p:handoutMasterIdLst>
-    <p:handoutMasterId r:id="rId38"/>
+    <p:handoutMasterId r:id="rId39"/>
   </p:handoutMasterIdLst>
   <p:sldIdLst>
     <p:sldId id="3635" r:id="rId5"/>
     <p:sldId id="3676" r:id="rId6"/>
     <p:sldId id="3700" r:id="rId7"/>
     <p:sldId id="3699" r:id="rId8"/>
-    <p:sldId id="3636" r:id="rId9"/>
-    <p:sldId id="509" r:id="rId10"/>
-    <p:sldId id="3673" r:id="rId11"/>
-    <p:sldId id="3660" r:id="rId12"/>
-    <p:sldId id="528" r:id="rId13"/>
-    <p:sldId id="3695" r:id="rId14"/>
-    <p:sldId id="3677" r:id="rId15"/>
-    <p:sldId id="3678" r:id="rId16"/>
-    <p:sldId id="3679" r:id="rId17"/>
-    <p:sldId id="3680" r:id="rId18"/>
-    <p:sldId id="3681" r:id="rId19"/>
-    <p:sldId id="3682" r:id="rId20"/>
-    <p:sldId id="3683" r:id="rId21"/>
-    <p:sldId id="3684" r:id="rId22"/>
-    <p:sldId id="3685" r:id="rId23"/>
-    <p:sldId id="3686" r:id="rId24"/>
-    <p:sldId id="3687" r:id="rId25"/>
-    <p:sldId id="3688" r:id="rId26"/>
-    <p:sldId id="3689" r:id="rId27"/>
-    <p:sldId id="3690" r:id="rId28"/>
-    <p:sldId id="3691" r:id="rId29"/>
-    <p:sldId id="3692" r:id="rId30"/>
-    <p:sldId id="3697" r:id="rId31"/>
-    <p:sldId id="3698" r:id="rId32"/>
-    <p:sldId id="3696" r:id="rId33"/>
-    <p:sldId id="3693" r:id="rId34"/>
-    <p:sldId id="3694" r:id="rId35"/>
-    <p:sldId id="3663" r:id="rId36"/>
+    <p:sldId id="3701" r:id="rId9"/>
+    <p:sldId id="3636" r:id="rId10"/>
+    <p:sldId id="509" r:id="rId11"/>
+    <p:sldId id="3673" r:id="rId12"/>
+    <p:sldId id="3660" r:id="rId13"/>
+    <p:sldId id="528" r:id="rId14"/>
+    <p:sldId id="3695" r:id="rId15"/>
+    <p:sldId id="3677" r:id="rId16"/>
+    <p:sldId id="3678" r:id="rId17"/>
+    <p:sldId id="3679" r:id="rId18"/>
+    <p:sldId id="3680" r:id="rId19"/>
+    <p:sldId id="3681" r:id="rId20"/>
+    <p:sldId id="3682" r:id="rId21"/>
+    <p:sldId id="3683" r:id="rId22"/>
+    <p:sldId id="3684" r:id="rId23"/>
+    <p:sldId id="3685" r:id="rId24"/>
+    <p:sldId id="3686" r:id="rId25"/>
+    <p:sldId id="3687" r:id="rId26"/>
+    <p:sldId id="3688" r:id="rId27"/>
+    <p:sldId id="3689" r:id="rId28"/>
+    <p:sldId id="3690" r:id="rId29"/>
+    <p:sldId id="3691" r:id="rId30"/>
+    <p:sldId id="3692" r:id="rId31"/>
+    <p:sldId id="3697" r:id="rId32"/>
+    <p:sldId id="3698" r:id="rId33"/>
+    <p:sldId id="3696" r:id="rId34"/>
+    <p:sldId id="3693" r:id="rId35"/>
+    <p:sldId id="3694" r:id="rId36"/>
+    <p:sldId id="3663" r:id="rId37"/>
   </p:sldIdLst>
   <p:sldSz cx="12192000" cy="6858000"/>
   <p:notesSz cx="6858000" cy="9144000"/>
@@ -1200,7 +1201,7 @@
           <a:p>
             <a:fld id="{D2F29697-4A6D-AC4B-B035-E737BE26C24F}" type="datetimeFigureOut">
               <a:rPr lang="en-US" smtClean="0"/>
-              <a:t>3/24/26</a:t>
+              <a:t>3/27/26</a:t>
             </a:fld>
             <a:endParaRPr lang="en-US"/>
           </a:p>
@@ -1365,7 +1366,7 @@
           <a:p>
             <a:fld id="{3B795838-E26F-BF4F-AF40-5695E293B9BE}" type="datetimeFigureOut">
               <a:rPr lang="en-US" smtClean="0"/>
-              <a:t>3/24/26</a:t>
+              <a:t>3/27/26</a:t>
             </a:fld>
             <a:endParaRPr lang="en-US"/>
           </a:p>
@@ -1811,6 +1812,183 @@
         <p:cNvPr id="1" name="">
           <a:extLst>
             <a:ext uri="{FF2B5EF4-FFF2-40B4-BE49-F238E27FC236}">
+              <a16:creationId xmlns:a16="http://schemas.microsoft.com/office/drawing/2014/main" id="{A9203B94-A0D1-8BA2-52CA-BA275829F031}"/>
+            </a:ext>
+          </a:extLst>
+        </p:cNvPr>
+        <p:cNvGrpSpPr/>
+        <p:nvPr/>
+      </p:nvGrpSpPr>
+      <p:grpSpPr>
+        <a:xfrm>
+          <a:off x="0" y="0"/>
+          <a:ext cx="0" cy="0"/>
+          <a:chOff x="0" y="0"/>
+          <a:chExt cx="0" cy="0"/>
+        </a:xfrm>
+      </p:grpSpPr>
+      <p:sp>
+        <p:nvSpPr>
+          <p:cNvPr id="2" name="Slide Image Placeholder 1">
+            <a:extLst>
+              <a:ext uri="{FF2B5EF4-FFF2-40B4-BE49-F238E27FC236}">
+                <a16:creationId xmlns:a16="http://schemas.microsoft.com/office/drawing/2014/main" id="{5874A54C-C3B9-1419-2C5D-F1862ED9DE2C}"/>
+              </a:ext>
+            </a:extLst>
+          </p:cNvPr>
+          <p:cNvSpPr>
+            <a:spLocks noGrp="1" noRot="1" noChangeAspect="1"/>
+          </p:cNvSpPr>
+          <p:nvPr>
+            <p:ph type="sldImg"/>
+          </p:nvPr>
+        </p:nvSpPr>
+        <p:spPr/>
+      </p:sp>
+      <p:sp>
+        <p:nvSpPr>
+          <p:cNvPr id="3" name="Notes Placeholder 2">
+            <a:extLst>
+              <a:ext uri="{FF2B5EF4-FFF2-40B4-BE49-F238E27FC236}">
+                <a16:creationId xmlns:a16="http://schemas.microsoft.com/office/drawing/2014/main" id="{2AACAF55-006E-189E-33FF-B208890EB903}"/>
+              </a:ext>
+            </a:extLst>
+          </p:cNvPr>
+          <p:cNvSpPr>
+            <a:spLocks noGrp="1"/>
+          </p:cNvSpPr>
+          <p:nvPr>
+            <p:ph type="body" idx="1"/>
+          </p:nvPr>
+        </p:nvSpPr>
+        <p:spPr/>
+        <p:txBody>
+          <a:bodyPr/>
+          <a:lstStyle/>
+          <a:p>
+            <a:r>
+              <a:rPr lang="en-US" dirty="0"/>
+              <a:t>For each challenge, list out the key high-level goals.</a:t>
+            </a:r>
+          </a:p>
+          <a:p>
+            <a:r>
+              <a:rPr lang="en-US" dirty="0"/>
+              <a:t>If there are important specifications, list them here, or remind students to “read the student guide!” </a:t>
+            </a:r>
+          </a:p>
+        </p:txBody>
+      </p:sp>
+      <p:sp>
+        <p:nvSpPr>
+          <p:cNvPr id="4" name="Slide Number Placeholder 3">
+            <a:extLst>
+              <a:ext uri="{FF2B5EF4-FFF2-40B4-BE49-F238E27FC236}">
+                <a16:creationId xmlns:a16="http://schemas.microsoft.com/office/drawing/2014/main" id="{29AB6E74-35AF-E136-F99A-BB2162FFF253}"/>
+              </a:ext>
+            </a:extLst>
+          </p:cNvPr>
+          <p:cNvSpPr>
+            <a:spLocks noGrp="1"/>
+          </p:cNvSpPr>
+          <p:nvPr>
+            <p:ph type="sldNum" sz="quarter" idx="10"/>
+          </p:nvPr>
+        </p:nvSpPr>
+        <p:spPr/>
+        <p:txBody>
+          <a:bodyPr/>
+          <a:lstStyle/>
+          <a:p>
+            <a:pPr marL="0" marR="0" lvl="0" indent="0" algn="r" defTabSz="914400" rtl="0" eaLnBrk="1" fontAlgn="auto" latinLnBrk="0" hangingPunct="1">
+              <a:lnSpc>
+                <a:spcPct val="100000"/>
+              </a:lnSpc>
+              <a:spcBef>
+                <a:spcPts val="0"/>
+              </a:spcBef>
+              <a:spcAft>
+                <a:spcPts val="0"/>
+              </a:spcAft>
+              <a:buClrTx/>
+              <a:buSzTx/>
+              <a:buFontTx/>
+              <a:buNone/>
+              <a:tabLst/>
+              <a:defRPr/>
+            </a:pPr>
+            <a:fld id="{871D71AE-08D6-4951-B1CF-CF97299DB5EB}" type="slidenum">
+              <a:rPr kumimoji="0" lang="en-US" sz="1200" b="0" i="0" u="none" strike="noStrike" kern="1200" cap="none" spc="0" normalizeH="0" baseline="0" noProof="0" smtClean="0">
+                <a:ln>
+                  <a:noFill/>
+                </a:ln>
+                <a:solidFill>
+                  <a:prstClr val="black"/>
+                </a:solidFill>
+                <a:effectLst/>
+                <a:uLnTx/>
+                <a:uFillTx/>
+                <a:latin typeface="Calibri" panose="020F0502020204030204"/>
+                <a:ea typeface="+mn-ea"/>
+                <a:cs typeface="+mn-cs"/>
+              </a:rPr>
+              <a:pPr marL="0" marR="0" lvl="0" indent="0" algn="r" defTabSz="914400" rtl="0" eaLnBrk="1" fontAlgn="auto" latinLnBrk="0" hangingPunct="1">
+                <a:lnSpc>
+                  <a:spcPct val="100000"/>
+                </a:lnSpc>
+                <a:spcBef>
+                  <a:spcPts val="0"/>
+                </a:spcBef>
+                <a:spcAft>
+                  <a:spcPts val="0"/>
+                </a:spcAft>
+                <a:buClrTx/>
+                <a:buSzTx/>
+                <a:buFontTx/>
+                <a:buNone/>
+                <a:tabLst/>
+                <a:defRPr/>
+              </a:pPr>
+              <a:t>11</a:t>
+            </a:fld>
+            <a:endParaRPr kumimoji="0" lang="en-US" sz="1200" b="0" i="0" u="none" strike="noStrike" kern="1200" cap="none" spc="0" normalizeH="0" baseline="0" noProof="0">
+              <a:ln>
+                <a:noFill/>
+              </a:ln>
+              <a:solidFill>
+                <a:prstClr val="black"/>
+              </a:solidFill>
+              <a:effectLst/>
+              <a:uLnTx/>
+              <a:uFillTx/>
+              <a:latin typeface="Calibri" panose="020F0502020204030204"/>
+              <a:ea typeface="+mn-ea"/>
+              <a:cs typeface="+mn-cs"/>
+            </a:endParaRPr>
+          </a:p>
+        </p:txBody>
+      </p:sp>
+    </p:spTree>
+    <p:extLst>
+      <p:ext uri="{BB962C8B-B14F-4D97-AF65-F5344CB8AC3E}">
+        <p14:creationId xmlns:p14="http://schemas.microsoft.com/office/powerpoint/2010/main" val="769841124"/>
+      </p:ext>
+    </p:extLst>
+  </p:cSld>
+  <p:clrMapOvr>
+    <a:masterClrMapping/>
+  </p:clrMapOvr>
+</p:notes>
+</file>
+
+<file path=ppt/notesSlides/notesSlide11.xml><?xml version="1.0" encoding="utf-8"?>
+<p:notes xmlns:a="http://schemas.openxmlformats.org/drawingml/2006/main" xmlns:r="http://schemas.openxmlformats.org/officeDocument/2006/relationships" xmlns:p="http://schemas.openxmlformats.org/presentationml/2006/main">
+  <p:cSld>
+    <p:spTree>
+      <p:nvGrpSpPr>
+        <p:cNvPr id="1" name="">
+          <a:extLst>
+            <a:ext uri="{FF2B5EF4-FFF2-40B4-BE49-F238E27FC236}">
               <a16:creationId xmlns:a16="http://schemas.microsoft.com/office/drawing/2014/main" id="{5865634C-F96E-C8F4-B1BF-DFD904DACBA5}"/>
             </a:ext>
           </a:extLst>
@@ -1972,7 +2150,7 @@
                 <a:tabLst/>
                 <a:defRPr/>
               </a:pPr>
-              <a:t>12</a:t>
+              <a:t>13</a:t>
             </a:fld>
             <a:endParaRPr kumimoji="0" lang="en-US" sz="1200" b="0" i="0" u="none" strike="noStrike" kern="1200" cap="none" spc="0" normalizeH="0" baseline="0" noProof="0">
               <a:ln>
@@ -2004,7 +2182,7 @@
 </p:notes>
 </file>
 
-<file path=ppt/notesSlides/notesSlide11.xml><?xml version="1.0" encoding="utf-8"?>
+<file path=ppt/notesSlides/notesSlide12.xml><?xml version="1.0" encoding="utf-8"?>
 <p:notes xmlns:a="http://schemas.openxmlformats.org/drawingml/2006/main" xmlns:r="http://schemas.openxmlformats.org/officeDocument/2006/relationships" xmlns:p="http://schemas.openxmlformats.org/presentationml/2006/main">
   <p:cSld>
     <p:spTree>
@@ -2149,7 +2327,7 @@
                 <a:tabLst/>
                 <a:defRPr/>
               </a:pPr>
-              <a:t>13</a:t>
+              <a:t>14</a:t>
             </a:fld>
             <a:endParaRPr kumimoji="0" lang="en-US" sz="1200" b="0" i="0" u="none" strike="noStrike" kern="1200" cap="none" spc="0" normalizeH="0" baseline="0" noProof="0">
               <a:ln>
@@ -2181,7 +2359,7 @@
 </p:notes>
 </file>
 
-<file path=ppt/notesSlides/notesSlide12.xml><?xml version="1.0" encoding="utf-8"?>
+<file path=ppt/notesSlides/notesSlide13.xml><?xml version="1.0" encoding="utf-8"?>
 <p:notes xmlns:a="http://schemas.openxmlformats.org/drawingml/2006/main" xmlns:r="http://schemas.openxmlformats.org/officeDocument/2006/relationships" xmlns:p="http://schemas.openxmlformats.org/presentationml/2006/main">
   <p:cSld>
     <p:spTree>
@@ -2350,7 +2528,7 @@
                 <a:tabLst/>
                 <a:defRPr/>
               </a:pPr>
-              <a:t>15</a:t>
+              <a:t>16</a:t>
             </a:fld>
             <a:endParaRPr kumimoji="0" lang="en-US" sz="1200" b="0" i="0" u="none" strike="noStrike" kern="1200" cap="none" spc="0" normalizeH="0" baseline="0" noProof="0">
               <a:ln>
@@ -2382,7 +2560,7 @@
 </p:notes>
 </file>
 
-<file path=ppt/notesSlides/notesSlide13.xml><?xml version="1.0" encoding="utf-8"?>
+<file path=ppt/notesSlides/notesSlide14.xml><?xml version="1.0" encoding="utf-8"?>
 <p:notes xmlns:a="http://schemas.openxmlformats.org/drawingml/2006/main" xmlns:r="http://schemas.openxmlformats.org/officeDocument/2006/relationships" xmlns:p="http://schemas.openxmlformats.org/presentationml/2006/main">
   <p:cSld>
     <p:spTree>
@@ -2527,7 +2705,7 @@
                 <a:tabLst/>
                 <a:defRPr/>
               </a:pPr>
-              <a:t>16</a:t>
+              <a:t>17</a:t>
             </a:fld>
             <a:endParaRPr kumimoji="0" lang="en-US" sz="1200" b="0" i="0" u="none" strike="noStrike" kern="1200" cap="none" spc="0" normalizeH="0" baseline="0" noProof="0">
               <a:ln>
@@ -2559,7 +2737,7 @@
 </p:notes>
 </file>
 
-<file path=ppt/notesSlides/notesSlide14.xml><?xml version="1.0" encoding="utf-8"?>
+<file path=ppt/notesSlides/notesSlide15.xml><?xml version="1.0" encoding="utf-8"?>
 <p:notes xmlns:a="http://schemas.openxmlformats.org/drawingml/2006/main" xmlns:r="http://schemas.openxmlformats.org/officeDocument/2006/relationships" xmlns:p="http://schemas.openxmlformats.org/presentationml/2006/main">
   <p:cSld>
     <p:spTree>
@@ -2728,7 +2906,7 @@
                 <a:tabLst/>
                 <a:defRPr/>
               </a:pPr>
-              <a:t>18</a:t>
+              <a:t>19</a:t>
             </a:fld>
             <a:endParaRPr kumimoji="0" lang="en-US" sz="1200" b="0" i="0" u="none" strike="noStrike" kern="1200" cap="none" spc="0" normalizeH="0" baseline="0" noProof="0">
               <a:ln>
@@ -2760,7 +2938,7 @@
 </p:notes>
 </file>
 
-<file path=ppt/notesSlides/notesSlide15.xml><?xml version="1.0" encoding="utf-8"?>
+<file path=ppt/notesSlides/notesSlide16.xml><?xml version="1.0" encoding="utf-8"?>
 <p:notes xmlns:a="http://schemas.openxmlformats.org/drawingml/2006/main" xmlns:r="http://schemas.openxmlformats.org/officeDocument/2006/relationships" xmlns:p="http://schemas.openxmlformats.org/presentationml/2006/main">
   <p:cSld>
     <p:spTree>
@@ -2905,7 +3083,7 @@
                 <a:tabLst/>
                 <a:defRPr/>
               </a:pPr>
-              <a:t>19</a:t>
+              <a:t>20</a:t>
             </a:fld>
             <a:endParaRPr kumimoji="0" lang="en-US" sz="1200" b="0" i="0" u="none" strike="noStrike" kern="1200" cap="none" spc="0" normalizeH="0" baseline="0" noProof="0">
               <a:ln>
@@ -2937,7 +3115,7 @@
 </p:notes>
 </file>
 
-<file path=ppt/notesSlides/notesSlide16.xml><?xml version="1.0" encoding="utf-8"?>
+<file path=ppt/notesSlides/notesSlide17.xml><?xml version="1.0" encoding="utf-8"?>
 <p:notes xmlns:a="http://schemas.openxmlformats.org/drawingml/2006/main" xmlns:r="http://schemas.openxmlformats.org/officeDocument/2006/relationships" xmlns:p="http://schemas.openxmlformats.org/presentationml/2006/main">
   <p:cSld>
     <p:spTree>
@@ -3106,7 +3284,7 @@
                 <a:tabLst/>
                 <a:defRPr/>
               </a:pPr>
-              <a:t>21</a:t>
+              <a:t>22</a:t>
             </a:fld>
             <a:endParaRPr kumimoji="0" lang="en-US" sz="1200" b="0" i="0" u="none" strike="noStrike" kern="1200" cap="none" spc="0" normalizeH="0" baseline="0" noProof="0">
               <a:ln>
@@ -3138,7 +3316,7 @@
 </p:notes>
 </file>
 
-<file path=ppt/notesSlides/notesSlide17.xml><?xml version="1.0" encoding="utf-8"?>
+<file path=ppt/notesSlides/notesSlide18.xml><?xml version="1.0" encoding="utf-8"?>
 <p:notes xmlns:a="http://schemas.openxmlformats.org/drawingml/2006/main" xmlns:r="http://schemas.openxmlformats.org/officeDocument/2006/relationships" xmlns:p="http://schemas.openxmlformats.org/presentationml/2006/main">
   <p:cSld>
     <p:spTree>
@@ -3283,7 +3461,7 @@
                 <a:tabLst/>
                 <a:defRPr/>
               </a:pPr>
-              <a:t>22</a:t>
+              <a:t>23</a:t>
             </a:fld>
             <a:endParaRPr kumimoji="0" lang="en-US" sz="1200" b="0" i="0" u="none" strike="noStrike" kern="1200" cap="none" spc="0" normalizeH="0" baseline="0" noProof="0">
               <a:ln>
@@ -3315,7 +3493,7 @@
 </p:notes>
 </file>
 
-<file path=ppt/notesSlides/notesSlide18.xml><?xml version="1.0" encoding="utf-8"?>
+<file path=ppt/notesSlides/notesSlide19.xml><?xml version="1.0" encoding="utf-8"?>
 <p:notes xmlns:a="http://schemas.openxmlformats.org/drawingml/2006/main" xmlns:r="http://schemas.openxmlformats.org/officeDocument/2006/relationships" xmlns:p="http://schemas.openxmlformats.org/presentationml/2006/main">
   <p:cSld>
     <p:spTree>
@@ -3484,183 +3662,6 @@
                 <a:tabLst/>
                 <a:defRPr/>
               </a:pPr>
-              <a:t>24</a:t>
-            </a:fld>
-            <a:endParaRPr kumimoji="0" lang="en-US" sz="1200" b="0" i="0" u="none" strike="noStrike" kern="1200" cap="none" spc="0" normalizeH="0" baseline="0" noProof="0">
-              <a:ln>
-                <a:noFill/>
-              </a:ln>
-              <a:solidFill>
-                <a:prstClr val="black"/>
-              </a:solidFill>
-              <a:effectLst/>
-              <a:uLnTx/>
-              <a:uFillTx/>
-              <a:latin typeface="Calibri" panose="020F0502020204030204"/>
-              <a:ea typeface="+mn-ea"/>
-              <a:cs typeface="+mn-cs"/>
-            </a:endParaRPr>
-          </a:p>
-        </p:txBody>
-      </p:sp>
-    </p:spTree>
-    <p:extLst>
-      <p:ext uri="{BB962C8B-B14F-4D97-AF65-F5344CB8AC3E}">
-        <p14:creationId xmlns:p14="http://schemas.microsoft.com/office/powerpoint/2010/main" val="3237775987"/>
-      </p:ext>
-    </p:extLst>
-  </p:cSld>
-  <p:clrMapOvr>
-    <a:masterClrMapping/>
-  </p:clrMapOvr>
-</p:notes>
-</file>
-
-<file path=ppt/notesSlides/notesSlide19.xml><?xml version="1.0" encoding="utf-8"?>
-<p:notes xmlns:a="http://schemas.openxmlformats.org/drawingml/2006/main" xmlns:r="http://schemas.openxmlformats.org/officeDocument/2006/relationships" xmlns:p="http://schemas.openxmlformats.org/presentationml/2006/main">
-  <p:cSld>
-    <p:spTree>
-      <p:nvGrpSpPr>
-        <p:cNvPr id="1" name="">
-          <a:extLst>
-            <a:ext uri="{FF2B5EF4-FFF2-40B4-BE49-F238E27FC236}">
-              <a16:creationId xmlns:a16="http://schemas.microsoft.com/office/drawing/2014/main" id="{FC39A78C-13E1-B588-E1C9-4B8F37E26786}"/>
-            </a:ext>
-          </a:extLst>
-        </p:cNvPr>
-        <p:cNvGrpSpPr/>
-        <p:nvPr/>
-      </p:nvGrpSpPr>
-      <p:grpSpPr>
-        <a:xfrm>
-          <a:off x="0" y="0"/>
-          <a:ext cx="0" cy="0"/>
-          <a:chOff x="0" y="0"/>
-          <a:chExt cx="0" cy="0"/>
-        </a:xfrm>
-      </p:grpSpPr>
-      <p:sp>
-        <p:nvSpPr>
-          <p:cNvPr id="2" name="Slide Image Placeholder 1">
-            <a:extLst>
-              <a:ext uri="{FF2B5EF4-FFF2-40B4-BE49-F238E27FC236}">
-                <a16:creationId xmlns:a16="http://schemas.microsoft.com/office/drawing/2014/main" id="{A2BA381D-3BF6-8177-C059-FA6D46E4EF13}"/>
-              </a:ext>
-            </a:extLst>
-          </p:cNvPr>
-          <p:cNvSpPr>
-            <a:spLocks noGrp="1" noRot="1" noChangeAspect="1"/>
-          </p:cNvSpPr>
-          <p:nvPr>
-            <p:ph type="sldImg"/>
-          </p:nvPr>
-        </p:nvSpPr>
-        <p:spPr/>
-      </p:sp>
-      <p:sp>
-        <p:nvSpPr>
-          <p:cNvPr id="3" name="Notes Placeholder 2">
-            <a:extLst>
-              <a:ext uri="{FF2B5EF4-FFF2-40B4-BE49-F238E27FC236}">
-                <a16:creationId xmlns:a16="http://schemas.microsoft.com/office/drawing/2014/main" id="{A76EB639-0397-7AEF-7944-B77BDFD692F0}"/>
-              </a:ext>
-            </a:extLst>
-          </p:cNvPr>
-          <p:cNvSpPr>
-            <a:spLocks noGrp="1"/>
-          </p:cNvSpPr>
-          <p:nvPr>
-            <p:ph type="body" idx="1"/>
-          </p:nvPr>
-        </p:nvSpPr>
-        <p:spPr/>
-        <p:txBody>
-          <a:bodyPr/>
-          <a:lstStyle/>
-          <a:p>
-            <a:r>
-              <a:rPr lang="en-US" dirty="0"/>
-              <a:t>For each challenge, list out the key high-level goals.</a:t>
-            </a:r>
-          </a:p>
-          <a:p>
-            <a:r>
-              <a:rPr lang="en-US" dirty="0"/>
-              <a:t>If there are important specifications, list them here, or remind students to “read the student guide!” </a:t>
-            </a:r>
-          </a:p>
-        </p:txBody>
-      </p:sp>
-      <p:sp>
-        <p:nvSpPr>
-          <p:cNvPr id="4" name="Slide Number Placeholder 3">
-            <a:extLst>
-              <a:ext uri="{FF2B5EF4-FFF2-40B4-BE49-F238E27FC236}">
-                <a16:creationId xmlns:a16="http://schemas.microsoft.com/office/drawing/2014/main" id="{DAB4D705-2664-6E21-2372-7F4FB35C93F4}"/>
-              </a:ext>
-            </a:extLst>
-          </p:cNvPr>
-          <p:cNvSpPr>
-            <a:spLocks noGrp="1"/>
-          </p:cNvSpPr>
-          <p:nvPr>
-            <p:ph type="sldNum" sz="quarter" idx="10"/>
-          </p:nvPr>
-        </p:nvSpPr>
-        <p:spPr/>
-        <p:txBody>
-          <a:bodyPr/>
-          <a:lstStyle/>
-          <a:p>
-            <a:pPr marL="0" marR="0" lvl="0" indent="0" algn="r" defTabSz="914400" rtl="0" eaLnBrk="1" fontAlgn="auto" latinLnBrk="0" hangingPunct="1">
-              <a:lnSpc>
-                <a:spcPct val="100000"/>
-              </a:lnSpc>
-              <a:spcBef>
-                <a:spcPts val="0"/>
-              </a:spcBef>
-              <a:spcAft>
-                <a:spcPts val="0"/>
-              </a:spcAft>
-              <a:buClrTx/>
-              <a:buSzTx/>
-              <a:buFontTx/>
-              <a:buNone/>
-              <a:tabLst/>
-              <a:defRPr/>
-            </a:pPr>
-            <a:fld id="{871D71AE-08D6-4951-B1CF-CF97299DB5EB}" type="slidenum">
-              <a:rPr kumimoji="0" lang="en-US" sz="1200" b="0" i="0" u="none" strike="noStrike" kern="1200" cap="none" spc="0" normalizeH="0" baseline="0" noProof="0" smtClean="0">
-                <a:ln>
-                  <a:noFill/>
-                </a:ln>
-                <a:solidFill>
-                  <a:prstClr val="black"/>
-                </a:solidFill>
-                <a:effectLst/>
-                <a:uLnTx/>
-                <a:uFillTx/>
-                <a:latin typeface="Calibri" panose="020F0502020204030204"/>
-                <a:ea typeface="+mn-ea"/>
-                <a:cs typeface="+mn-cs"/>
-              </a:rPr>
-              <a:pPr marL="0" marR="0" lvl="0" indent="0" algn="r" defTabSz="914400" rtl="0" eaLnBrk="1" fontAlgn="auto" latinLnBrk="0" hangingPunct="1">
-                <a:lnSpc>
-                  <a:spcPct val="100000"/>
-                </a:lnSpc>
-                <a:spcBef>
-                  <a:spcPts val="0"/>
-                </a:spcBef>
-                <a:spcAft>
-                  <a:spcPts val="0"/>
-                </a:spcAft>
-                <a:buClrTx/>
-                <a:buSzTx/>
-                <a:buFontTx/>
-                <a:buNone/>
-                <a:tabLst/>
-                <a:defRPr/>
-              </a:pPr>
               <a:t>25</a:t>
             </a:fld>
             <a:endParaRPr kumimoji="0" lang="en-US" sz="1200" b="0" i="0" u="none" strike="noStrike" kern="1200" cap="none" spc="0" normalizeH="0" baseline="0" noProof="0">
@@ -3683,7 +3684,7 @@
     </p:spTree>
     <p:extLst>
       <p:ext uri="{BB962C8B-B14F-4D97-AF65-F5344CB8AC3E}">
-        <p14:creationId xmlns:p14="http://schemas.microsoft.com/office/powerpoint/2010/main" val="2889930697"/>
+        <p14:creationId xmlns:p14="http://schemas.microsoft.com/office/powerpoint/2010/main" val="3237775987"/>
       </p:ext>
     </p:extLst>
   </p:cSld>
@@ -3892,6 +3893,183 @@
         <p:cNvPr id="1" name="">
           <a:extLst>
             <a:ext uri="{FF2B5EF4-FFF2-40B4-BE49-F238E27FC236}">
+              <a16:creationId xmlns:a16="http://schemas.microsoft.com/office/drawing/2014/main" id="{FC39A78C-13E1-B588-E1C9-4B8F37E26786}"/>
+            </a:ext>
+          </a:extLst>
+        </p:cNvPr>
+        <p:cNvGrpSpPr/>
+        <p:nvPr/>
+      </p:nvGrpSpPr>
+      <p:grpSpPr>
+        <a:xfrm>
+          <a:off x="0" y="0"/>
+          <a:ext cx="0" cy="0"/>
+          <a:chOff x="0" y="0"/>
+          <a:chExt cx="0" cy="0"/>
+        </a:xfrm>
+      </p:grpSpPr>
+      <p:sp>
+        <p:nvSpPr>
+          <p:cNvPr id="2" name="Slide Image Placeholder 1">
+            <a:extLst>
+              <a:ext uri="{FF2B5EF4-FFF2-40B4-BE49-F238E27FC236}">
+                <a16:creationId xmlns:a16="http://schemas.microsoft.com/office/drawing/2014/main" id="{A2BA381D-3BF6-8177-C059-FA6D46E4EF13}"/>
+              </a:ext>
+            </a:extLst>
+          </p:cNvPr>
+          <p:cNvSpPr>
+            <a:spLocks noGrp="1" noRot="1" noChangeAspect="1"/>
+          </p:cNvSpPr>
+          <p:nvPr>
+            <p:ph type="sldImg"/>
+          </p:nvPr>
+        </p:nvSpPr>
+        <p:spPr/>
+      </p:sp>
+      <p:sp>
+        <p:nvSpPr>
+          <p:cNvPr id="3" name="Notes Placeholder 2">
+            <a:extLst>
+              <a:ext uri="{FF2B5EF4-FFF2-40B4-BE49-F238E27FC236}">
+                <a16:creationId xmlns:a16="http://schemas.microsoft.com/office/drawing/2014/main" id="{A76EB639-0397-7AEF-7944-B77BDFD692F0}"/>
+              </a:ext>
+            </a:extLst>
+          </p:cNvPr>
+          <p:cNvSpPr>
+            <a:spLocks noGrp="1"/>
+          </p:cNvSpPr>
+          <p:nvPr>
+            <p:ph type="body" idx="1"/>
+          </p:nvPr>
+        </p:nvSpPr>
+        <p:spPr/>
+        <p:txBody>
+          <a:bodyPr/>
+          <a:lstStyle/>
+          <a:p>
+            <a:r>
+              <a:rPr lang="en-US" dirty="0"/>
+              <a:t>For each challenge, list out the key high-level goals.</a:t>
+            </a:r>
+          </a:p>
+          <a:p>
+            <a:r>
+              <a:rPr lang="en-US" dirty="0"/>
+              <a:t>If there are important specifications, list them here, or remind students to “read the student guide!” </a:t>
+            </a:r>
+          </a:p>
+        </p:txBody>
+      </p:sp>
+      <p:sp>
+        <p:nvSpPr>
+          <p:cNvPr id="4" name="Slide Number Placeholder 3">
+            <a:extLst>
+              <a:ext uri="{FF2B5EF4-FFF2-40B4-BE49-F238E27FC236}">
+                <a16:creationId xmlns:a16="http://schemas.microsoft.com/office/drawing/2014/main" id="{DAB4D705-2664-6E21-2372-7F4FB35C93F4}"/>
+              </a:ext>
+            </a:extLst>
+          </p:cNvPr>
+          <p:cNvSpPr>
+            <a:spLocks noGrp="1"/>
+          </p:cNvSpPr>
+          <p:nvPr>
+            <p:ph type="sldNum" sz="quarter" idx="10"/>
+          </p:nvPr>
+        </p:nvSpPr>
+        <p:spPr/>
+        <p:txBody>
+          <a:bodyPr/>
+          <a:lstStyle/>
+          <a:p>
+            <a:pPr marL="0" marR="0" lvl="0" indent="0" algn="r" defTabSz="914400" rtl="0" eaLnBrk="1" fontAlgn="auto" latinLnBrk="0" hangingPunct="1">
+              <a:lnSpc>
+                <a:spcPct val="100000"/>
+              </a:lnSpc>
+              <a:spcBef>
+                <a:spcPts val="0"/>
+              </a:spcBef>
+              <a:spcAft>
+                <a:spcPts val="0"/>
+              </a:spcAft>
+              <a:buClrTx/>
+              <a:buSzTx/>
+              <a:buFontTx/>
+              <a:buNone/>
+              <a:tabLst/>
+              <a:defRPr/>
+            </a:pPr>
+            <a:fld id="{871D71AE-08D6-4951-B1CF-CF97299DB5EB}" type="slidenum">
+              <a:rPr kumimoji="0" lang="en-US" sz="1200" b="0" i="0" u="none" strike="noStrike" kern="1200" cap="none" spc="0" normalizeH="0" baseline="0" noProof="0" smtClean="0">
+                <a:ln>
+                  <a:noFill/>
+                </a:ln>
+                <a:solidFill>
+                  <a:prstClr val="black"/>
+                </a:solidFill>
+                <a:effectLst/>
+                <a:uLnTx/>
+                <a:uFillTx/>
+                <a:latin typeface="Calibri" panose="020F0502020204030204"/>
+                <a:ea typeface="+mn-ea"/>
+                <a:cs typeface="+mn-cs"/>
+              </a:rPr>
+              <a:pPr marL="0" marR="0" lvl="0" indent="0" algn="r" defTabSz="914400" rtl="0" eaLnBrk="1" fontAlgn="auto" latinLnBrk="0" hangingPunct="1">
+                <a:lnSpc>
+                  <a:spcPct val="100000"/>
+                </a:lnSpc>
+                <a:spcBef>
+                  <a:spcPts val="0"/>
+                </a:spcBef>
+                <a:spcAft>
+                  <a:spcPts val="0"/>
+                </a:spcAft>
+                <a:buClrTx/>
+                <a:buSzTx/>
+                <a:buFontTx/>
+                <a:buNone/>
+                <a:tabLst/>
+                <a:defRPr/>
+              </a:pPr>
+              <a:t>26</a:t>
+            </a:fld>
+            <a:endParaRPr kumimoji="0" lang="en-US" sz="1200" b="0" i="0" u="none" strike="noStrike" kern="1200" cap="none" spc="0" normalizeH="0" baseline="0" noProof="0">
+              <a:ln>
+                <a:noFill/>
+              </a:ln>
+              <a:solidFill>
+                <a:prstClr val="black"/>
+              </a:solidFill>
+              <a:effectLst/>
+              <a:uLnTx/>
+              <a:uFillTx/>
+              <a:latin typeface="Calibri" panose="020F0502020204030204"/>
+              <a:ea typeface="+mn-ea"/>
+              <a:cs typeface="+mn-cs"/>
+            </a:endParaRPr>
+          </a:p>
+        </p:txBody>
+      </p:sp>
+    </p:spTree>
+    <p:extLst>
+      <p:ext uri="{BB962C8B-B14F-4D97-AF65-F5344CB8AC3E}">
+        <p14:creationId xmlns:p14="http://schemas.microsoft.com/office/powerpoint/2010/main" val="2889930697"/>
+      </p:ext>
+    </p:extLst>
+  </p:cSld>
+  <p:clrMapOvr>
+    <a:masterClrMapping/>
+  </p:clrMapOvr>
+</p:notes>
+</file>
+
+<file path=ppt/notesSlides/notesSlide21.xml><?xml version="1.0" encoding="utf-8"?>
+<p:notes xmlns:a="http://schemas.openxmlformats.org/drawingml/2006/main" xmlns:r="http://schemas.openxmlformats.org/officeDocument/2006/relationships" xmlns:p="http://schemas.openxmlformats.org/presentationml/2006/main">
+  <p:cSld>
+    <p:spTree>
+      <p:nvGrpSpPr>
+        <p:cNvPr id="1" name="">
+          <a:extLst>
+            <a:ext uri="{FF2B5EF4-FFF2-40B4-BE49-F238E27FC236}">
               <a16:creationId xmlns:a16="http://schemas.microsoft.com/office/drawing/2014/main" id="{BEEB29D5-8DD7-EE76-AFB3-EC86B8B929CD}"/>
             </a:ext>
           </a:extLst>
@@ -4053,7 +4231,7 @@
                 <a:tabLst/>
                 <a:defRPr/>
               </a:pPr>
-              <a:t>27</a:t>
+              <a:t>28</a:t>
             </a:fld>
             <a:endParaRPr kumimoji="0" lang="en-US" sz="1200" b="0" i="0" u="none" strike="noStrike" kern="1200" cap="none" spc="0" normalizeH="0" baseline="0" noProof="0">
               <a:ln>
@@ -4085,7 +4263,7 @@
 </p:notes>
 </file>
 
-<file path=ppt/notesSlides/notesSlide21.xml><?xml version="1.0" encoding="utf-8"?>
+<file path=ppt/notesSlides/notesSlide22.xml><?xml version="1.0" encoding="utf-8"?>
 <p:notes xmlns:a="http://schemas.openxmlformats.org/drawingml/2006/main" xmlns:r="http://schemas.openxmlformats.org/officeDocument/2006/relationships" xmlns:p="http://schemas.openxmlformats.org/presentationml/2006/main">
   <p:cSld>
     <p:spTree>
@@ -4230,7 +4408,7 @@
                 <a:tabLst/>
                 <a:defRPr/>
               </a:pPr>
-              <a:t>28</a:t>
+              <a:t>29</a:t>
             </a:fld>
             <a:endParaRPr kumimoji="0" lang="en-US" sz="1200" b="0" i="0" u="none" strike="noStrike" kern="1200" cap="none" spc="0" normalizeH="0" baseline="0" noProof="0">
               <a:ln>
@@ -4262,7 +4440,7 @@
 </p:notes>
 </file>
 
-<file path=ppt/notesSlides/notesSlide22.xml><?xml version="1.0" encoding="utf-8"?>
+<file path=ppt/notesSlides/notesSlide23.xml><?xml version="1.0" encoding="utf-8"?>
 <p:notes xmlns:a="http://schemas.openxmlformats.org/drawingml/2006/main" xmlns:r="http://schemas.openxmlformats.org/officeDocument/2006/relationships" xmlns:p="http://schemas.openxmlformats.org/presentationml/2006/main">
   <p:cSld>
     <p:spTree>
@@ -4431,7 +4609,7 @@
                 <a:tabLst/>
                 <a:defRPr/>
               </a:pPr>
-              <a:t>30</a:t>
+              <a:t>31</a:t>
             </a:fld>
             <a:endParaRPr kumimoji="0" lang="en-US" sz="1200" b="0" i="0" u="none" strike="noStrike" kern="1200" cap="none" spc="0" normalizeH="0" baseline="0" noProof="0">
               <a:ln>
@@ -4463,7 +4641,7 @@
 </p:notes>
 </file>
 
-<file path=ppt/notesSlides/notesSlide23.xml><?xml version="1.0" encoding="utf-8"?>
+<file path=ppt/notesSlides/notesSlide24.xml><?xml version="1.0" encoding="utf-8"?>
 <p:notes xmlns:a="http://schemas.openxmlformats.org/drawingml/2006/main" xmlns:r="http://schemas.openxmlformats.org/officeDocument/2006/relationships" xmlns:p="http://schemas.openxmlformats.org/presentationml/2006/main">
   <p:cSld>
     <p:spTree>
@@ -4608,7 +4786,7 @@
                 <a:tabLst/>
                 <a:defRPr/>
               </a:pPr>
-              <a:t>31</a:t>
+              <a:t>32</a:t>
             </a:fld>
             <a:endParaRPr kumimoji="0" lang="en-US" sz="1200" b="0" i="0" u="none" strike="noStrike" kern="1200" cap="none" spc="0" normalizeH="0" baseline="0" noProof="0">
               <a:ln>
@@ -4640,7 +4818,7 @@
 </p:notes>
 </file>
 
-<file path=ppt/notesSlides/notesSlide24.xml><?xml version="1.0" encoding="utf-8"?>
+<file path=ppt/notesSlides/notesSlide25.xml><?xml version="1.0" encoding="utf-8"?>
 <p:notes xmlns:a="http://schemas.openxmlformats.org/drawingml/2006/main" xmlns:r="http://schemas.openxmlformats.org/officeDocument/2006/relationships" xmlns:p="http://schemas.openxmlformats.org/presentationml/2006/main">
   <p:cSld>
     <p:spTree>
@@ -4761,7 +4939,7 @@
                 <a:tabLst/>
                 <a:defRPr/>
               </a:pPr>
-              <a:t>32</a:t>
+              <a:t>33</a:t>
             </a:fld>
             <a:endParaRPr kumimoji="0" lang="en-US" sz="1200" b="0" i="0" u="none" strike="noStrike" kern="1200" cap="none" spc="0" normalizeH="0" baseline="0" noProof="0" dirty="0">
               <a:ln>
@@ -5180,7 +5358,13 @@
   <p:cSld>
     <p:spTree>
       <p:nvGrpSpPr>
-        <p:cNvPr id="1" name=""/>
+        <p:cNvPr id="1" name="">
+          <a:extLst>
+            <a:ext uri="{FF2B5EF4-FFF2-40B4-BE49-F238E27FC236}">
+              <a16:creationId xmlns:a16="http://schemas.microsoft.com/office/drawing/2014/main" id="{ADC5E0DF-2865-9725-0657-F81D7DB82A0C}"/>
+            </a:ext>
+          </a:extLst>
+        </p:cNvPr>
         <p:cNvGrpSpPr/>
         <p:nvPr/>
       </p:nvGrpSpPr>
@@ -5194,7 +5378,13 @@
       </p:grpSpPr>
       <p:sp>
         <p:nvSpPr>
-          <p:cNvPr id="2" name="Slide Image Placeholder 1"/>
+          <p:cNvPr id="2" name="Slide Image Placeholder 1">
+            <a:extLst>
+              <a:ext uri="{FF2B5EF4-FFF2-40B4-BE49-F238E27FC236}">
+                <a16:creationId xmlns:a16="http://schemas.microsoft.com/office/drawing/2014/main" id="{260F102D-5177-9FC1-3878-F2C653038902}"/>
+              </a:ext>
+            </a:extLst>
+          </p:cNvPr>
           <p:cNvSpPr>
             <a:spLocks noGrp="1" noRot="1" noChangeAspect="1"/>
           </p:cNvSpPr>
@@ -5206,7 +5396,13 @@
       </p:sp>
       <p:sp>
         <p:nvSpPr>
-          <p:cNvPr id="3" name="Notes Placeholder 2"/>
+          <p:cNvPr id="3" name="Notes Placeholder 2">
+            <a:extLst>
+              <a:ext uri="{FF2B5EF4-FFF2-40B4-BE49-F238E27FC236}">
+                <a16:creationId xmlns:a16="http://schemas.microsoft.com/office/drawing/2014/main" id="{39352D1E-B6DF-96EC-5000-36ED283AFF40}"/>
+              </a:ext>
+            </a:extLst>
+          </p:cNvPr>
           <p:cNvSpPr>
             <a:spLocks noGrp="1"/>
           </p:cNvSpPr>
@@ -5273,7 +5469,13 @@
       </p:sp>
       <p:sp>
         <p:nvSpPr>
-          <p:cNvPr id="4" name="Slide Number Placeholder 3"/>
+          <p:cNvPr id="4" name="Slide Number Placeholder 3">
+            <a:extLst>
+              <a:ext uri="{FF2B5EF4-FFF2-40B4-BE49-F238E27FC236}">
+                <a16:creationId xmlns:a16="http://schemas.microsoft.com/office/drawing/2014/main" id="{56622121-9377-02BA-4C6C-4EBC62991C02}"/>
+              </a:ext>
+            </a:extLst>
+          </p:cNvPr>
           <p:cNvSpPr>
             <a:spLocks noGrp="1"/>
           </p:cNvSpPr>
@@ -5357,6 +5559,198 @@
     </p:spTree>
     <p:extLst>
       <p:ext uri="{BB962C8B-B14F-4D97-AF65-F5344CB8AC3E}">
+        <p14:creationId xmlns:p14="http://schemas.microsoft.com/office/powerpoint/2010/main" val="3459714742"/>
+      </p:ext>
+    </p:extLst>
+  </p:cSld>
+  <p:clrMapOvr>
+    <a:masterClrMapping/>
+  </p:clrMapOvr>
+</p:notes>
+</file>
+
+<file path=ppt/notesSlides/notesSlide6.xml><?xml version="1.0" encoding="utf-8"?>
+<p:notes xmlns:a="http://schemas.openxmlformats.org/drawingml/2006/main" xmlns:r="http://schemas.openxmlformats.org/officeDocument/2006/relationships" xmlns:p="http://schemas.openxmlformats.org/presentationml/2006/main">
+  <p:cSld>
+    <p:spTree>
+      <p:nvGrpSpPr>
+        <p:cNvPr id="1" name=""/>
+        <p:cNvGrpSpPr/>
+        <p:nvPr/>
+      </p:nvGrpSpPr>
+      <p:grpSpPr>
+        <a:xfrm>
+          <a:off x="0" y="0"/>
+          <a:ext cx="0" cy="0"/>
+          <a:chOff x="0" y="0"/>
+          <a:chExt cx="0" cy="0"/>
+        </a:xfrm>
+      </p:grpSpPr>
+      <p:sp>
+        <p:nvSpPr>
+          <p:cNvPr id="2" name="Slide Image Placeholder 1"/>
+          <p:cNvSpPr>
+            <a:spLocks noGrp="1" noRot="1" noChangeAspect="1"/>
+          </p:cNvSpPr>
+          <p:nvPr>
+            <p:ph type="sldImg"/>
+          </p:nvPr>
+        </p:nvSpPr>
+        <p:spPr/>
+      </p:sp>
+      <p:sp>
+        <p:nvSpPr>
+          <p:cNvPr id="3" name="Notes Placeholder 2"/>
+          <p:cNvSpPr>
+            <a:spLocks noGrp="1"/>
+          </p:cNvSpPr>
+          <p:nvPr>
+            <p:ph type="body" idx="1"/>
+          </p:nvPr>
+        </p:nvSpPr>
+        <p:spPr/>
+        <p:txBody>
+          <a:bodyPr/>
+          <a:lstStyle/>
+          <a:p>
+            <a:r>
+              <a:rPr lang="en-US" b="1" dirty="0"/>
+              <a:t>Coaches/Presenters for THIS hack/lecture event should be listed on this slide.</a:t>
+            </a:r>
+          </a:p>
+          <a:p>
+            <a:endParaRPr lang="en-US" dirty="0"/>
+          </a:p>
+          <a:p>
+            <a:r>
+              <a:rPr lang="en-US" dirty="0"/>
+              <a:t>Original contributors to the hack content &amp; these slides include:</a:t>
+            </a:r>
+          </a:p>
+          <a:p>
+            <a:endParaRPr lang="en-US" dirty="0"/>
+          </a:p>
+          <a:p>
+            <a:r>
+              <a:rPr lang="en-US" dirty="0"/>
+              <a:t>Please list original contributors to this hack here in the speaker notes and give them credit when delivering this content.</a:t>
+            </a:r>
+          </a:p>
+          <a:p>
+            <a:endParaRPr lang="en-US" dirty="0"/>
+          </a:p>
+          <a:p>
+            <a:r>
+              <a:rPr lang="en-US" dirty="0"/>
+              <a:t>&lt;Original Author 1&gt;</a:t>
+            </a:r>
+          </a:p>
+          <a:p>
+            <a:r>
+              <a:rPr lang="en-US" dirty="0"/>
+              <a:t>&lt;Original Author 2&gt;</a:t>
+            </a:r>
+          </a:p>
+          <a:p>
+            <a:r>
+              <a:rPr lang="en-US" dirty="0"/>
+              <a:t>…</a:t>
+            </a:r>
+          </a:p>
+          <a:p>
+            <a:r>
+              <a:rPr lang="en-US" dirty="0"/>
+              <a:t>&lt;Original Author N&gt;</a:t>
+            </a:r>
+          </a:p>
+        </p:txBody>
+      </p:sp>
+      <p:sp>
+        <p:nvSpPr>
+          <p:cNvPr id="4" name="Slide Number Placeholder 3"/>
+          <p:cNvSpPr>
+            <a:spLocks noGrp="1"/>
+          </p:cNvSpPr>
+          <p:nvPr>
+            <p:ph type="sldNum" sz="quarter" idx="10"/>
+          </p:nvPr>
+        </p:nvSpPr>
+        <p:spPr/>
+        <p:txBody>
+          <a:bodyPr/>
+          <a:lstStyle/>
+          <a:p>
+            <a:pPr marL="0" marR="0" lvl="0" indent="0" algn="r" defTabSz="914400" rtl="0" eaLnBrk="1" fontAlgn="auto" latinLnBrk="0" hangingPunct="1">
+              <a:lnSpc>
+                <a:spcPct val="100000"/>
+              </a:lnSpc>
+              <a:spcBef>
+                <a:spcPts val="0"/>
+              </a:spcBef>
+              <a:spcAft>
+                <a:spcPts val="0"/>
+              </a:spcAft>
+              <a:buClrTx/>
+              <a:buSzTx/>
+              <a:buFontTx/>
+              <a:buNone/>
+              <a:tabLst/>
+              <a:defRPr/>
+            </a:pPr>
+            <a:fld id="{4C3A18DF-2E2C-4B51-B31A-8EAAD44872AA}" type="slidenum">
+              <a:rPr kumimoji="0" lang="en-US" sz="1200" b="0" i="0" u="none" strike="noStrike" kern="1200" cap="none" spc="0" normalizeH="0" baseline="0" noProof="0" smtClean="0">
+                <a:ln>
+                  <a:noFill/>
+                </a:ln>
+                <a:solidFill>
+                  <a:prstClr val="black"/>
+                </a:solidFill>
+                <a:effectLst/>
+                <a:uLnTx/>
+                <a:uFillTx/>
+                <a:latin typeface="Calibri" panose="020F0502020204030204"/>
+                <a:ea typeface="+mn-ea"/>
+                <a:cs typeface="+mn-cs"/>
+              </a:rPr>
+              <a:pPr marL="0" marR="0" lvl="0" indent="0" algn="r" defTabSz="914400" rtl="0" eaLnBrk="1" fontAlgn="auto" latinLnBrk="0" hangingPunct="1">
+                <a:lnSpc>
+                  <a:spcPct val="100000"/>
+                </a:lnSpc>
+                <a:spcBef>
+                  <a:spcPts val="0"/>
+                </a:spcBef>
+                <a:spcAft>
+                  <a:spcPts val="0"/>
+                </a:spcAft>
+                <a:buClrTx/>
+                <a:buSzTx/>
+                <a:buFontTx/>
+                <a:buNone/>
+                <a:tabLst/>
+                <a:defRPr/>
+              </a:pPr>
+              <a:t>6</a:t>
+            </a:fld>
+            <a:endParaRPr kumimoji="0" lang="en-US" sz="1200" b="0" i="0" u="none" strike="noStrike" kern="1200" cap="none" spc="0" normalizeH="0" baseline="0" noProof="0">
+              <a:ln>
+                <a:noFill/>
+              </a:ln>
+              <a:solidFill>
+                <a:prstClr val="black"/>
+              </a:solidFill>
+              <a:effectLst/>
+              <a:uLnTx/>
+              <a:uFillTx/>
+              <a:latin typeface="Calibri" panose="020F0502020204030204"/>
+              <a:ea typeface="+mn-ea"/>
+              <a:cs typeface="+mn-cs"/>
+            </a:endParaRPr>
+          </a:p>
+        </p:txBody>
+      </p:sp>
+    </p:spTree>
+    <p:extLst>
+      <p:ext uri="{BB962C8B-B14F-4D97-AF65-F5344CB8AC3E}">
         <p14:creationId xmlns:p14="http://schemas.microsoft.com/office/powerpoint/2010/main" val="2439682645"/>
       </p:ext>
     </p:extLst>
@@ -5367,7 +5761,7 @@
 </p:notes>
 </file>
 
-<file path=ppt/notesSlides/notesSlide6.xml><?xml version="1.0" encoding="utf-8"?>
+<file path=ppt/notesSlides/notesSlide7.xml><?xml version="1.0" encoding="utf-8"?>
 <p:notes xmlns:a="http://schemas.openxmlformats.org/drawingml/2006/main" xmlns:r="http://schemas.openxmlformats.org/officeDocument/2006/relationships" xmlns:p="http://schemas.openxmlformats.org/presentationml/2006/main">
   <p:cSld>
     <p:spTree>
@@ -5502,7 +5896,7 @@
                 <a:tabLst/>
                 <a:defRPr/>
               </a:pPr>
-              <a:t>6</a:t>
+              <a:t>7</a:t>
             </a:fld>
             <a:endParaRPr kumimoji="0" lang="en-US" sz="1200" b="0" i="0" u="none" strike="noStrike" kern="1200" cap="none" spc="0" normalizeH="0" baseline="0" noProof="0">
               <a:ln>
@@ -5534,7 +5928,7 @@
 </p:notes>
 </file>
 
-<file path=ppt/notesSlides/notesSlide7.xml><?xml version="1.0" encoding="utf-8"?>
+<file path=ppt/notesSlides/notesSlide8.xml><?xml version="1.0" encoding="utf-8"?>
 <p:notes xmlns:a="http://schemas.openxmlformats.org/drawingml/2006/main" xmlns:r="http://schemas.openxmlformats.org/officeDocument/2006/relationships" xmlns:p="http://schemas.openxmlformats.org/presentationml/2006/main">
   <p:cSld>
     <p:spTree>
@@ -5679,7 +6073,7 @@
                 <a:tabLst/>
                 <a:defRPr/>
               </a:pPr>
-              <a:t>8</a:t>
+              <a:t>9</a:t>
             </a:fld>
             <a:endParaRPr kumimoji="0" lang="en-US" sz="1200" b="0" i="0" u="none" strike="noStrike" kern="1200" cap="none" spc="0" normalizeH="0" baseline="0" noProof="0">
               <a:ln>
@@ -5711,7 +6105,7 @@
 </p:notes>
 </file>
 
-<file path=ppt/notesSlides/notesSlide8.xml><?xml version="1.0" encoding="utf-8"?>
+<file path=ppt/notesSlides/notesSlide9.xml><?xml version="1.0" encoding="utf-8"?>
 <p:notes xmlns:a="http://schemas.openxmlformats.org/drawingml/2006/main" xmlns:r="http://schemas.openxmlformats.org/officeDocument/2006/relationships" xmlns:p="http://schemas.openxmlformats.org/presentationml/2006/main">
   <p:cSld>
     <p:spTree>
@@ -5771,183 +6165,6 @@
       <p:sp>
         <p:nvSpPr>
           <p:cNvPr id="4" name="Slide Number Placeholder 3"/>
-          <p:cNvSpPr>
-            <a:spLocks noGrp="1"/>
-          </p:cNvSpPr>
-          <p:nvPr>
-            <p:ph type="sldNum" sz="quarter" idx="10"/>
-          </p:nvPr>
-        </p:nvSpPr>
-        <p:spPr/>
-        <p:txBody>
-          <a:bodyPr/>
-          <a:lstStyle/>
-          <a:p>
-            <a:pPr marL="0" marR="0" lvl="0" indent="0" algn="r" defTabSz="914400" rtl="0" eaLnBrk="1" fontAlgn="auto" latinLnBrk="0" hangingPunct="1">
-              <a:lnSpc>
-                <a:spcPct val="100000"/>
-              </a:lnSpc>
-              <a:spcBef>
-                <a:spcPts val="0"/>
-              </a:spcBef>
-              <a:spcAft>
-                <a:spcPts val="0"/>
-              </a:spcAft>
-              <a:buClrTx/>
-              <a:buSzTx/>
-              <a:buFontTx/>
-              <a:buNone/>
-              <a:tabLst/>
-              <a:defRPr/>
-            </a:pPr>
-            <a:fld id="{871D71AE-08D6-4951-B1CF-CF97299DB5EB}" type="slidenum">
-              <a:rPr kumimoji="0" lang="en-US" sz="1200" b="0" i="0" u="none" strike="noStrike" kern="1200" cap="none" spc="0" normalizeH="0" baseline="0" noProof="0" smtClean="0">
-                <a:ln>
-                  <a:noFill/>
-                </a:ln>
-                <a:solidFill>
-                  <a:prstClr val="black"/>
-                </a:solidFill>
-                <a:effectLst/>
-                <a:uLnTx/>
-                <a:uFillTx/>
-                <a:latin typeface="Calibri" panose="020F0502020204030204"/>
-                <a:ea typeface="+mn-ea"/>
-                <a:cs typeface="+mn-cs"/>
-              </a:rPr>
-              <a:pPr marL="0" marR="0" lvl="0" indent="0" algn="r" defTabSz="914400" rtl="0" eaLnBrk="1" fontAlgn="auto" latinLnBrk="0" hangingPunct="1">
-                <a:lnSpc>
-                  <a:spcPct val="100000"/>
-                </a:lnSpc>
-                <a:spcBef>
-                  <a:spcPts val="0"/>
-                </a:spcBef>
-                <a:spcAft>
-                  <a:spcPts val="0"/>
-                </a:spcAft>
-                <a:buClrTx/>
-                <a:buSzTx/>
-                <a:buFontTx/>
-                <a:buNone/>
-                <a:tabLst/>
-                <a:defRPr/>
-              </a:pPr>
-              <a:t>9</a:t>
-            </a:fld>
-            <a:endParaRPr kumimoji="0" lang="en-US" sz="1200" b="0" i="0" u="none" strike="noStrike" kern="1200" cap="none" spc="0" normalizeH="0" baseline="0" noProof="0">
-              <a:ln>
-                <a:noFill/>
-              </a:ln>
-              <a:solidFill>
-                <a:prstClr val="black"/>
-              </a:solidFill>
-              <a:effectLst/>
-              <a:uLnTx/>
-              <a:uFillTx/>
-              <a:latin typeface="Calibri" panose="020F0502020204030204"/>
-              <a:ea typeface="+mn-ea"/>
-              <a:cs typeface="+mn-cs"/>
-            </a:endParaRPr>
-          </a:p>
-        </p:txBody>
-      </p:sp>
-    </p:spTree>
-    <p:extLst>
-      <p:ext uri="{BB962C8B-B14F-4D97-AF65-F5344CB8AC3E}">
-        <p14:creationId xmlns:p14="http://schemas.microsoft.com/office/powerpoint/2010/main" val="76796664"/>
-      </p:ext>
-    </p:extLst>
-  </p:cSld>
-  <p:clrMapOvr>
-    <a:masterClrMapping/>
-  </p:clrMapOvr>
-</p:notes>
-</file>
-
-<file path=ppt/notesSlides/notesSlide9.xml><?xml version="1.0" encoding="utf-8"?>
-<p:notes xmlns:a="http://schemas.openxmlformats.org/drawingml/2006/main" xmlns:r="http://schemas.openxmlformats.org/officeDocument/2006/relationships" xmlns:p="http://schemas.openxmlformats.org/presentationml/2006/main">
-  <p:cSld>
-    <p:spTree>
-      <p:nvGrpSpPr>
-        <p:cNvPr id="1" name="">
-          <a:extLst>
-            <a:ext uri="{FF2B5EF4-FFF2-40B4-BE49-F238E27FC236}">
-              <a16:creationId xmlns:a16="http://schemas.microsoft.com/office/drawing/2014/main" id="{A9203B94-A0D1-8BA2-52CA-BA275829F031}"/>
-            </a:ext>
-          </a:extLst>
-        </p:cNvPr>
-        <p:cNvGrpSpPr/>
-        <p:nvPr/>
-      </p:nvGrpSpPr>
-      <p:grpSpPr>
-        <a:xfrm>
-          <a:off x="0" y="0"/>
-          <a:ext cx="0" cy="0"/>
-          <a:chOff x="0" y="0"/>
-          <a:chExt cx="0" cy="0"/>
-        </a:xfrm>
-      </p:grpSpPr>
-      <p:sp>
-        <p:nvSpPr>
-          <p:cNvPr id="2" name="Slide Image Placeholder 1">
-            <a:extLst>
-              <a:ext uri="{FF2B5EF4-FFF2-40B4-BE49-F238E27FC236}">
-                <a16:creationId xmlns:a16="http://schemas.microsoft.com/office/drawing/2014/main" id="{5874A54C-C3B9-1419-2C5D-F1862ED9DE2C}"/>
-              </a:ext>
-            </a:extLst>
-          </p:cNvPr>
-          <p:cNvSpPr>
-            <a:spLocks noGrp="1" noRot="1" noChangeAspect="1"/>
-          </p:cNvSpPr>
-          <p:nvPr>
-            <p:ph type="sldImg"/>
-          </p:nvPr>
-        </p:nvSpPr>
-        <p:spPr/>
-      </p:sp>
-      <p:sp>
-        <p:nvSpPr>
-          <p:cNvPr id="3" name="Notes Placeholder 2">
-            <a:extLst>
-              <a:ext uri="{FF2B5EF4-FFF2-40B4-BE49-F238E27FC236}">
-                <a16:creationId xmlns:a16="http://schemas.microsoft.com/office/drawing/2014/main" id="{2AACAF55-006E-189E-33FF-B208890EB903}"/>
-              </a:ext>
-            </a:extLst>
-          </p:cNvPr>
-          <p:cNvSpPr>
-            <a:spLocks noGrp="1"/>
-          </p:cNvSpPr>
-          <p:nvPr>
-            <p:ph type="body" idx="1"/>
-          </p:nvPr>
-        </p:nvSpPr>
-        <p:spPr/>
-        <p:txBody>
-          <a:bodyPr/>
-          <a:lstStyle/>
-          <a:p>
-            <a:r>
-              <a:rPr lang="en-US" dirty="0"/>
-              <a:t>For each challenge, list out the key high-level goals.</a:t>
-            </a:r>
-          </a:p>
-          <a:p>
-            <a:r>
-              <a:rPr lang="en-US" dirty="0"/>
-              <a:t>If there are important specifications, list them here, or remind students to “read the student guide!” </a:t>
-            </a:r>
-          </a:p>
-        </p:txBody>
-      </p:sp>
-      <p:sp>
-        <p:nvSpPr>
-          <p:cNvPr id="4" name="Slide Number Placeholder 3">
-            <a:extLst>
-              <a:ext uri="{FF2B5EF4-FFF2-40B4-BE49-F238E27FC236}">
-                <a16:creationId xmlns:a16="http://schemas.microsoft.com/office/drawing/2014/main" id="{29AB6E74-35AF-E136-F99A-BB2162FFF253}"/>
-              </a:ext>
-            </a:extLst>
-          </p:cNvPr>
           <p:cNvSpPr>
             <a:spLocks noGrp="1"/>
           </p:cNvSpPr>
@@ -6031,7 +6248,7 @@
     </p:spTree>
     <p:extLst>
       <p:ext uri="{BB962C8B-B14F-4D97-AF65-F5344CB8AC3E}">
-        <p14:creationId xmlns:p14="http://schemas.microsoft.com/office/powerpoint/2010/main" val="769841124"/>
+        <p14:creationId xmlns:p14="http://schemas.microsoft.com/office/powerpoint/2010/main" val="76796664"/>
       </p:ext>
     </p:extLst>
   </p:cSld>
@@ -6211,7 +6428,7 @@
           <a:p>
             <a:fld id="{DFED49D2-CC62-47A6-8FD4-1840AC422660}" type="datetimeFigureOut">
               <a:rPr lang="en-US" smtClean="0"/>
-              <a:t>3/24/26</a:t>
+              <a:t>3/27/26</a:t>
             </a:fld>
             <a:endParaRPr lang="en-US"/>
           </a:p>
@@ -6566,7 +6783,7 @@
           <a:p>
             <a:fld id="{DFED49D2-CC62-47A6-8FD4-1840AC422660}" type="datetimeFigureOut">
               <a:rPr lang="en-US" smtClean="0"/>
-              <a:t>3/24/26</a:t>
+              <a:t>3/27/26</a:t>
             </a:fld>
             <a:endParaRPr lang="en-US"/>
           </a:p>
@@ -6764,7 +6981,7 @@
           <a:p>
             <a:fld id="{DFED49D2-CC62-47A6-8FD4-1840AC422660}" type="datetimeFigureOut">
               <a:rPr lang="en-US" smtClean="0"/>
-              <a:t>3/24/26</a:t>
+              <a:t>3/27/26</a:t>
             </a:fld>
             <a:endParaRPr lang="en-US"/>
           </a:p>
@@ -6972,7 +7189,7 @@
           <a:p>
             <a:fld id="{DFED49D2-CC62-47A6-8FD4-1840AC422660}" type="datetimeFigureOut">
               <a:rPr lang="en-US" smtClean="0"/>
-              <a:t>3/24/26</a:t>
+              <a:t>3/27/26</a:t>
             </a:fld>
             <a:endParaRPr lang="en-US"/>
           </a:p>
@@ -7539,7 +7756,7 @@
           <a:p>
             <a:fld id="{DFED49D2-CC62-47A6-8FD4-1840AC422660}" type="datetimeFigureOut">
               <a:rPr lang="en-US" smtClean="0"/>
-              <a:t>3/24/26</a:t>
+              <a:t>3/27/26</a:t>
             </a:fld>
             <a:endParaRPr lang="en-US" dirty="0"/>
           </a:p>
@@ -7795,7 +8012,7 @@
           <a:p>
             <a:fld id="{DFED49D2-CC62-47A6-8FD4-1840AC422660}" type="datetimeFigureOut">
               <a:rPr lang="en-US" smtClean="0"/>
-              <a:t>3/24/26</a:t>
+              <a:t>3/27/26</a:t>
             </a:fld>
             <a:endParaRPr lang="en-US"/>
           </a:p>
@@ -8168,7 +8385,7 @@
           <a:p>
             <a:fld id="{DFED49D2-CC62-47A6-8FD4-1840AC422660}" type="datetimeFigureOut">
               <a:rPr lang="en-US" smtClean="0"/>
-              <a:t>3/24/26</a:t>
+              <a:t>3/27/26</a:t>
             </a:fld>
             <a:endParaRPr lang="en-US"/>
           </a:p>
@@ -8505,7 +8722,7 @@
           <a:p>
             <a:fld id="{DFED49D2-CC62-47A6-8FD4-1840AC422660}" type="datetimeFigureOut">
               <a:rPr lang="en-US" smtClean="0"/>
-              <a:t>3/24/26</a:t>
+              <a:t>3/27/26</a:t>
             </a:fld>
             <a:endParaRPr lang="en-US"/>
           </a:p>
@@ -8917,7 +9134,7 @@
           <a:p>
             <a:fld id="{DFED49D2-CC62-47A6-8FD4-1840AC422660}" type="datetimeFigureOut">
               <a:rPr lang="en-US" smtClean="0"/>
-              <a:t>3/24/26</a:t>
+              <a:t>3/27/26</a:t>
             </a:fld>
             <a:endParaRPr lang="en-US"/>
           </a:p>
@@ -9063,7 +9280,7 @@
           <a:p>
             <a:fld id="{DFED49D2-CC62-47A6-8FD4-1840AC422660}" type="datetimeFigureOut">
               <a:rPr lang="en-US" smtClean="0"/>
-              <a:t>3/24/26</a:t>
+              <a:t>3/27/26</a:t>
             </a:fld>
             <a:endParaRPr lang="en-US"/>
           </a:p>
@@ -9176,7 +9393,7 @@
           <a:p>
             <a:fld id="{DFED49D2-CC62-47A6-8FD4-1840AC422660}" type="datetimeFigureOut">
               <a:rPr lang="en-US" smtClean="0"/>
-              <a:t>3/24/26</a:t>
+              <a:t>3/27/26</a:t>
             </a:fld>
             <a:endParaRPr lang="en-US"/>
           </a:p>
@@ -9487,7 +9704,7 @@
           <a:p>
             <a:fld id="{DFED49D2-CC62-47A6-8FD4-1840AC422660}" type="datetimeFigureOut">
               <a:rPr lang="en-US" smtClean="0"/>
-              <a:t>3/24/26</a:t>
+              <a:t>3/27/26</a:t>
             </a:fld>
             <a:endParaRPr lang="en-US"/>
           </a:p>
@@ -9728,7 +9945,7 @@
           <a:p>
             <a:fld id="{DFED49D2-CC62-47A6-8FD4-1840AC422660}" type="datetimeFigureOut">
               <a:rPr lang="en-US" smtClean="0"/>
-              <a:t>3/24/26</a:t>
+              <a:t>3/27/26</a:t>
             </a:fld>
             <a:endParaRPr lang="en-US"/>
           </a:p>
@@ -10327,6 +10544,353 @@
   <p:cSld>
     <p:spTree>
       <p:nvGrpSpPr>
+        <p:cNvPr id="1" name=""/>
+        <p:cNvGrpSpPr/>
+        <p:nvPr/>
+      </p:nvGrpSpPr>
+      <p:grpSpPr>
+        <a:xfrm>
+          <a:off x="0" y="0"/>
+          <a:ext cx="0" cy="0"/>
+          <a:chOff x="0" y="0"/>
+          <a:chExt cx="0" cy="0"/>
+        </a:xfrm>
+      </p:grpSpPr>
+      <p:sp>
+        <p:nvSpPr>
+          <p:cNvPr id="3" name="Title 2"/>
+          <p:cNvSpPr>
+            <a:spLocks noGrp="1"/>
+          </p:cNvSpPr>
+          <p:nvPr>
+            <p:ph type="title"/>
+          </p:nvPr>
+        </p:nvSpPr>
+        <p:spPr/>
+        <p:txBody>
+          <a:bodyPr>
+            <a:normAutofit/>
+          </a:bodyPr>
+          <a:lstStyle/>
+          <a:p>
+            <a:r>
+              <a:rPr lang="en-US" sz="5400" b="1" dirty="0">
+                <a:solidFill>
+                  <a:srgbClr val="002060"/>
+                </a:solidFill>
+                <a:latin typeface="Segoe UI" panose="020B0502040204020203" pitchFamily="34" charset="0"/>
+                <a:cs typeface="Segoe UI" panose="020B0502040204020203" pitchFamily="34" charset="0"/>
+              </a:rPr>
+              <a:t>Challenge #1</a:t>
+            </a:r>
+            <a:endParaRPr lang="en-US" sz="3200" b="1" dirty="0">
+              <a:solidFill>
+                <a:srgbClr val="7030A0"/>
+              </a:solidFill>
+              <a:latin typeface="Segoe UI" panose="020B0502040204020203" pitchFamily="34" charset="0"/>
+              <a:cs typeface="Segoe UI" panose="020B0502040204020203" pitchFamily="34" charset="0"/>
+            </a:endParaRPr>
+          </a:p>
+        </p:txBody>
+      </p:sp>
+      <p:sp>
+        <p:nvSpPr>
+          <p:cNvPr id="2" name="Text Placeholder 1"/>
+          <p:cNvSpPr>
+            <a:spLocks noGrp="1"/>
+          </p:cNvSpPr>
+          <p:nvPr>
+            <p:ph idx="1"/>
+          </p:nvPr>
+        </p:nvSpPr>
+        <p:spPr/>
+        <p:txBody>
+          <a:bodyPr>
+            <a:normAutofit fontScale="92500" lnSpcReduction="20000"/>
+          </a:bodyPr>
+          <a:lstStyle/>
+          <a:p>
+            <a:pPr marL="0" indent="0">
+              <a:buNone/>
+            </a:pPr>
+            <a:r>
+              <a:rPr lang="en-US" sz="2400" dirty="0">
+                <a:latin typeface="Segoe UI" panose="020B0502040204020203" pitchFamily="34" charset="0"/>
+                <a:cs typeface="Segoe UI" panose="020B0502040204020203" pitchFamily="34" charset="0"/>
+              </a:rPr>
+              <a:t>Your goal is to gain a solid understanding of the following concepts:</a:t>
+            </a:r>
+          </a:p>
+          <a:p>
+            <a:endParaRPr lang="en-US" sz="2400" dirty="0">
+              <a:latin typeface="Segoe UI" panose="020B0502040204020203" pitchFamily="34" charset="0"/>
+              <a:cs typeface="Segoe UI" panose="020B0502040204020203" pitchFamily="34" charset="0"/>
+            </a:endParaRPr>
+          </a:p>
+          <a:p>
+            <a:r>
+              <a:rPr lang="en-US" sz="2400" b="1" dirty="0">
+                <a:solidFill>
+                  <a:srgbClr val="F6C243"/>
+                </a:solidFill>
+                <a:latin typeface="Segoe UI" panose="020B0502040204020203" pitchFamily="34" charset="0"/>
+                <a:cs typeface="Segoe UI" panose="020B0502040204020203" pitchFamily="34" charset="0"/>
+              </a:rPr>
+              <a:t>AI Agents vs. Simple LLM Calls</a:t>
+            </a:r>
+          </a:p>
+          <a:p>
+            <a:pPr lvl="1"/>
+            <a:r>
+              <a:rPr lang="en-US" dirty="0">
+                <a:latin typeface="Segoe UI" panose="020B0502040204020203" pitchFamily="34" charset="0"/>
+                <a:cs typeface="Segoe UI" panose="020B0502040204020203" pitchFamily="34" charset="0"/>
+              </a:rPr>
+              <a:t>Understand what differentiates an agent from a basic chat completion API call</a:t>
+            </a:r>
+          </a:p>
+          <a:p>
+            <a:r>
+              <a:rPr lang="en-US" sz="2400" b="1" dirty="0">
+                <a:solidFill>
+                  <a:srgbClr val="F6C243"/>
+                </a:solidFill>
+                <a:latin typeface="Segoe UI" panose="020B0502040204020203" pitchFamily="34" charset="0"/>
+                <a:cs typeface="Segoe UI" panose="020B0502040204020203" pitchFamily="34" charset="0"/>
+              </a:rPr>
+              <a:t>Tool Calling</a:t>
+            </a:r>
+          </a:p>
+          <a:p>
+            <a:pPr lvl="1"/>
+            <a:r>
+              <a:rPr lang="en-US" dirty="0">
+                <a:latin typeface="Segoe UI" panose="020B0502040204020203" pitchFamily="34" charset="0"/>
+                <a:cs typeface="Segoe UI" panose="020B0502040204020203" pitchFamily="34" charset="0"/>
+              </a:rPr>
+              <a:t>Learn why agents need tools and how they decide when to call them</a:t>
+            </a:r>
+          </a:p>
+          <a:p>
+            <a:r>
+              <a:rPr lang="en-US" sz="2400" b="1" dirty="0">
+                <a:solidFill>
+                  <a:srgbClr val="F6C243"/>
+                </a:solidFill>
+                <a:latin typeface="Segoe UI" panose="020B0502040204020203" pitchFamily="34" charset="0"/>
+                <a:cs typeface="Segoe UI" panose="020B0502040204020203" pitchFamily="34" charset="0"/>
+              </a:rPr>
+              <a:t>Agent-Tool Lifecycle</a:t>
+            </a:r>
+          </a:p>
+          <a:p>
+            <a:pPr lvl="1"/>
+            <a:r>
+              <a:rPr lang="en-US" dirty="0">
+                <a:latin typeface="Segoe UI" panose="020B0502040204020203" pitchFamily="34" charset="0"/>
+                <a:cs typeface="Segoe UI" panose="020B0502040204020203" pitchFamily="34" charset="0"/>
+              </a:rPr>
+              <a:t>Understand the flow from user request through agent reasoning to tool execution and response</a:t>
+            </a:r>
+          </a:p>
+          <a:p>
+            <a:r>
+              <a:rPr lang="en-US" sz="2400" b="1" dirty="0" err="1">
+                <a:solidFill>
+                  <a:srgbClr val="F6C243"/>
+                </a:solidFill>
+                <a:latin typeface="Segoe UI" panose="020B0502040204020203" pitchFamily="34" charset="0"/>
+                <a:cs typeface="Segoe UI" panose="020B0502040204020203" pitchFamily="34" charset="0"/>
+              </a:rPr>
+              <a:t>OpenTelemetry</a:t>
+            </a:r>
+            <a:r>
+              <a:rPr lang="en-US" sz="2400" b="1" dirty="0">
+                <a:solidFill>
+                  <a:srgbClr val="F6C243"/>
+                </a:solidFill>
+                <a:latin typeface="Segoe UI" panose="020B0502040204020203" pitchFamily="34" charset="0"/>
+                <a:cs typeface="Segoe UI" panose="020B0502040204020203" pitchFamily="34" charset="0"/>
+              </a:rPr>
+              <a:t> Basics</a:t>
+            </a:r>
+          </a:p>
+          <a:p>
+            <a:pPr lvl="1"/>
+            <a:r>
+              <a:rPr lang="en-US" dirty="0">
+                <a:latin typeface="Segoe UI" panose="020B0502040204020203" pitchFamily="34" charset="0"/>
+                <a:cs typeface="Segoe UI" panose="020B0502040204020203" pitchFamily="34" charset="0"/>
+              </a:rPr>
+              <a:t>Learn about traces, metrics, and logs and why they matter for AI systems</a:t>
+            </a:r>
+          </a:p>
+          <a:p>
+            <a:r>
+              <a:rPr lang="en-US" sz="2400" b="1" dirty="0">
+                <a:solidFill>
+                  <a:srgbClr val="F6C243"/>
+                </a:solidFill>
+                <a:latin typeface="Segoe UI" panose="020B0502040204020203" pitchFamily="34" charset="0"/>
+                <a:cs typeface="Segoe UI" panose="020B0502040204020203" pitchFamily="34" charset="0"/>
+              </a:rPr>
+              <a:t>Application Architecture</a:t>
+            </a:r>
+          </a:p>
+          <a:p>
+            <a:pPr lvl="1"/>
+            <a:r>
+              <a:rPr lang="en-US" dirty="0">
+                <a:latin typeface="Segoe UI" panose="020B0502040204020203" pitchFamily="34" charset="0"/>
+                <a:cs typeface="Segoe UI" panose="020B0502040204020203" pitchFamily="34" charset="0"/>
+              </a:rPr>
+              <a:t>Understand how a Flask web app integrates with the Microsoft Agent Framework</a:t>
+            </a:r>
+          </a:p>
+        </p:txBody>
+      </p:sp>
+      <p:sp>
+        <p:nvSpPr>
+          <p:cNvPr id="8" name="Text Placeholder 7">
+            <a:extLst>
+              <a:ext uri="{FF2B5EF4-FFF2-40B4-BE49-F238E27FC236}">
+                <a16:creationId xmlns:a16="http://schemas.microsoft.com/office/drawing/2014/main" id="{E3048B16-5BF1-7CB9-7FB4-FEF3812F70B0}"/>
+              </a:ext>
+            </a:extLst>
+          </p:cNvPr>
+          <p:cNvSpPr>
+            <a:spLocks noGrp="1"/>
+          </p:cNvSpPr>
+          <p:nvPr>
+            <p:ph type="body" sz="quarter" idx="13"/>
+          </p:nvPr>
+        </p:nvSpPr>
+        <p:spPr/>
+        <p:txBody>
+          <a:bodyPr/>
+          <a:lstStyle/>
+          <a:p>
+            <a:r>
+              <a:rPr lang="en-US" dirty="0"/>
+              <a:t>Master the Foundations – What makes an AI agent tick?</a:t>
+            </a:r>
+          </a:p>
+        </p:txBody>
+      </p:sp>
+      <p:sp>
+        <p:nvSpPr>
+          <p:cNvPr id="4" name="TextBox 3">
+            <a:extLst>
+              <a:ext uri="{FF2B5EF4-FFF2-40B4-BE49-F238E27FC236}">
+                <a16:creationId xmlns:a16="http://schemas.microsoft.com/office/drawing/2014/main" id="{63CFF63D-04FB-705F-FDE7-615DA747FAC4}"/>
+              </a:ext>
+            </a:extLst>
+          </p:cNvPr>
+          <p:cNvSpPr txBox="1"/>
+          <p:nvPr/>
+        </p:nvSpPr>
+        <p:spPr>
+          <a:xfrm>
+            <a:off x="5034987" y="1307939"/>
+            <a:ext cx="184731" cy="369332"/>
+          </a:xfrm>
+          <a:prstGeom prst="rect">
+            <a:avLst/>
+          </a:prstGeom>
+          <a:noFill/>
+        </p:spPr>
+        <p:txBody>
+          <a:bodyPr wrap="none" rtlCol="0">
+            <a:spAutoFit/>
+          </a:bodyPr>
+          <a:lstStyle/>
+          <a:p>
+            <a:endParaRPr lang="en-US" dirty="0"/>
+          </a:p>
+        </p:txBody>
+      </p:sp>
+      <p:sp>
+        <p:nvSpPr>
+          <p:cNvPr id="6" name="TextBox 5">
+            <a:extLst>
+              <a:ext uri="{FF2B5EF4-FFF2-40B4-BE49-F238E27FC236}">
+                <a16:creationId xmlns:a16="http://schemas.microsoft.com/office/drawing/2014/main" id="{AB9110E3-5DA2-43FD-3338-F621924160AB}"/>
+              </a:ext>
+            </a:extLst>
+          </p:cNvPr>
+          <p:cNvSpPr txBox="1"/>
+          <p:nvPr/>
+        </p:nvSpPr>
+        <p:spPr>
+          <a:xfrm>
+            <a:off x="5775767" y="1088020"/>
+            <a:ext cx="184731" cy="369332"/>
+          </a:xfrm>
+          <a:prstGeom prst="rect">
+            <a:avLst/>
+          </a:prstGeom>
+          <a:noFill/>
+        </p:spPr>
+        <p:txBody>
+          <a:bodyPr wrap="none" rtlCol="0">
+            <a:spAutoFit/>
+          </a:bodyPr>
+          <a:lstStyle/>
+          <a:p>
+            <a:endParaRPr lang="en-US" dirty="0"/>
+          </a:p>
+        </p:txBody>
+      </p:sp>
+      <p:sp>
+        <p:nvSpPr>
+          <p:cNvPr id="7" name="TextBox 6">
+            <a:extLst>
+              <a:ext uri="{FF2B5EF4-FFF2-40B4-BE49-F238E27FC236}">
+                <a16:creationId xmlns:a16="http://schemas.microsoft.com/office/drawing/2014/main" id="{42E1B2F0-C4E0-E0F5-983F-767CA58230D0}"/>
+              </a:ext>
+            </a:extLst>
+          </p:cNvPr>
+          <p:cNvSpPr txBox="1"/>
+          <p:nvPr/>
+        </p:nvSpPr>
+        <p:spPr>
+          <a:xfrm>
+            <a:off x="6111433" y="1157468"/>
+            <a:ext cx="184731" cy="369332"/>
+          </a:xfrm>
+          <a:prstGeom prst="rect">
+            <a:avLst/>
+          </a:prstGeom>
+          <a:noFill/>
+        </p:spPr>
+        <p:txBody>
+          <a:bodyPr wrap="none" rtlCol="0">
+            <a:spAutoFit/>
+          </a:bodyPr>
+          <a:lstStyle/>
+          <a:p>
+            <a:endParaRPr lang="en-US" dirty="0"/>
+          </a:p>
+        </p:txBody>
+      </p:sp>
+    </p:spTree>
+    <p:extLst>
+      <p:ext uri="{BB962C8B-B14F-4D97-AF65-F5344CB8AC3E}">
+        <p14:creationId xmlns:p14="http://schemas.microsoft.com/office/powerpoint/2010/main" val="2471118552"/>
+      </p:ext>
+    </p:extLst>
+  </p:cSld>
+  <p:clrMapOvr>
+    <a:masterClrMapping/>
+  </p:clrMapOvr>
+</p:sld>
+</file>
+
+<file path=ppt/slides/slide11.xml><?xml version="1.0" encoding="utf-8"?>
+<p:sld xmlns:a="http://schemas.openxmlformats.org/drawingml/2006/main" xmlns:r="http://schemas.openxmlformats.org/officeDocument/2006/relationships" xmlns:p="http://schemas.openxmlformats.org/presentationml/2006/main">
+  <p:cSld>
+    <p:spTree>
+      <p:nvGrpSpPr>
         <p:cNvPr id="1" name="">
           <a:extLst>
             <a:ext uri="{FF2B5EF4-FFF2-40B4-BE49-F238E27FC236}">
@@ -10560,7 +11124,7 @@
 </p:sld>
 </file>
 
-<file path=ppt/slides/slide11.xml><?xml version="1.0" encoding="utf-8"?>
+<file path=ppt/slides/slide12.xml><?xml version="1.0" encoding="utf-8"?>
 <p:sld xmlns:a="http://schemas.openxmlformats.org/drawingml/2006/main" xmlns:r="http://schemas.openxmlformats.org/officeDocument/2006/relationships" xmlns:p="http://schemas.openxmlformats.org/presentationml/2006/main">
   <p:cSld>
     <p:spTree>
@@ -10670,7 +11234,7 @@
 </p:sld>
 </file>
 
-<file path=ppt/slides/slide12.xml><?xml version="1.0" encoding="utf-8"?>
+<file path=ppt/slides/slide13.xml><?xml version="1.0" encoding="utf-8"?>
 <p:sld xmlns:a="http://schemas.openxmlformats.org/drawingml/2006/main" xmlns:r="http://schemas.openxmlformats.org/officeDocument/2006/relationships" xmlns:p="http://schemas.openxmlformats.org/presentationml/2006/main">
   <p:cSld>
     <p:spTree>
@@ -10863,7 +11427,7 @@
 </p:sld>
 </file>
 
-<file path=ppt/slides/slide13.xml><?xml version="1.0" encoding="utf-8"?>
+<file path=ppt/slides/slide14.xml><?xml version="1.0" encoding="utf-8"?>
 <p:sld xmlns:a="http://schemas.openxmlformats.org/drawingml/2006/main" xmlns:r="http://schemas.openxmlformats.org/officeDocument/2006/relationships" xmlns:p="http://schemas.openxmlformats.org/presentationml/2006/main">
   <p:cSld>
     <p:spTree>
@@ -11191,7 +11755,7 @@
 </p:sld>
 </file>
 
-<file path=ppt/slides/slide14.xml><?xml version="1.0" encoding="utf-8"?>
+<file path=ppt/slides/slide15.xml><?xml version="1.0" encoding="utf-8"?>
 <p:sld xmlns:a="http://schemas.openxmlformats.org/drawingml/2006/main" xmlns:r="http://schemas.openxmlformats.org/officeDocument/2006/relationships" xmlns:p="http://schemas.openxmlformats.org/presentationml/2006/main">
   <p:cSld>
     <p:spTree>
@@ -11295,7 +11859,7 @@
 </p:sld>
 </file>
 
-<file path=ppt/slides/slide15.xml><?xml version="1.0" encoding="utf-8"?>
+<file path=ppt/slides/slide16.xml><?xml version="1.0" encoding="utf-8"?>
 <p:sld xmlns:a="http://schemas.openxmlformats.org/drawingml/2006/main" xmlns:r="http://schemas.openxmlformats.org/officeDocument/2006/relationships" xmlns:p="http://schemas.openxmlformats.org/presentationml/2006/main">
   <p:cSld>
     <p:spTree>
@@ -11583,7 +12147,7 @@
 </p:sld>
 </file>
 
-<file path=ppt/slides/slide16.xml><?xml version="1.0" encoding="utf-8"?>
+<file path=ppt/slides/slide17.xml><?xml version="1.0" encoding="utf-8"?>
 <p:sld xmlns:a="http://schemas.openxmlformats.org/drawingml/2006/main" xmlns:r="http://schemas.openxmlformats.org/officeDocument/2006/relationships" xmlns:p="http://schemas.openxmlformats.org/presentationml/2006/main">
   <p:cSld>
     <p:spTree>
@@ -11909,7 +12473,7 @@
 </p:sld>
 </file>
 
-<file path=ppt/slides/slide17.xml><?xml version="1.0" encoding="utf-8"?>
+<file path=ppt/slides/slide18.xml><?xml version="1.0" encoding="utf-8"?>
 <p:sld xmlns:a="http://schemas.openxmlformats.org/drawingml/2006/main" xmlns:r="http://schemas.openxmlformats.org/officeDocument/2006/relationships" xmlns:p="http://schemas.openxmlformats.org/presentationml/2006/main">
   <p:cSld>
     <p:spTree>
@@ -12013,7 +12577,7 @@
 </p:sld>
 </file>
 
-<file path=ppt/slides/slide18.xml><?xml version="1.0" encoding="utf-8"?>
+<file path=ppt/slides/slide19.xml><?xml version="1.0" encoding="utf-8"?>
 <p:sld xmlns:a="http://schemas.openxmlformats.org/drawingml/2006/main" xmlns:r="http://schemas.openxmlformats.org/officeDocument/2006/relationships" xmlns:p="http://schemas.openxmlformats.org/presentationml/2006/main">
   <p:cSld>
     <p:spTree>
@@ -12270,358 +12834,6 @@
     <p:extLst>
       <p:ext uri="{BB962C8B-B14F-4D97-AF65-F5344CB8AC3E}">
         <p14:creationId xmlns:p14="http://schemas.microsoft.com/office/powerpoint/2010/main" val="1811058792"/>
-      </p:ext>
-    </p:extLst>
-  </p:cSld>
-  <p:clrMapOvr>
-    <a:masterClrMapping/>
-  </p:clrMapOvr>
-</p:sld>
-</file>
-
-<file path=ppt/slides/slide19.xml><?xml version="1.0" encoding="utf-8"?>
-<p:sld xmlns:a="http://schemas.openxmlformats.org/drawingml/2006/main" xmlns:r="http://schemas.openxmlformats.org/officeDocument/2006/relationships" xmlns:p="http://schemas.openxmlformats.org/presentationml/2006/main">
-  <p:cSld>
-    <p:spTree>
-      <p:nvGrpSpPr>
-        <p:cNvPr id="1" name="">
-          <a:extLst>
-            <a:ext uri="{FF2B5EF4-FFF2-40B4-BE49-F238E27FC236}">
-              <a16:creationId xmlns:a16="http://schemas.microsoft.com/office/drawing/2014/main" id="{C443317F-74EF-57F8-08B9-6C83CE449BDD}"/>
-            </a:ext>
-          </a:extLst>
-        </p:cNvPr>
-        <p:cNvGrpSpPr/>
-        <p:nvPr/>
-      </p:nvGrpSpPr>
-      <p:grpSpPr>
-        <a:xfrm>
-          <a:off x="0" y="0"/>
-          <a:ext cx="0" cy="0"/>
-          <a:chOff x="0" y="0"/>
-          <a:chExt cx="0" cy="0"/>
-        </a:xfrm>
-      </p:grpSpPr>
-      <p:sp>
-        <p:nvSpPr>
-          <p:cNvPr id="3" name="Title 2">
-            <a:extLst>
-              <a:ext uri="{FF2B5EF4-FFF2-40B4-BE49-F238E27FC236}">
-                <a16:creationId xmlns:a16="http://schemas.microsoft.com/office/drawing/2014/main" id="{2D825D59-34F9-F4C9-5B64-03965D800016}"/>
-              </a:ext>
-            </a:extLst>
-          </p:cNvPr>
-          <p:cNvSpPr>
-            <a:spLocks noGrp="1"/>
-          </p:cNvSpPr>
-          <p:nvPr>
-            <p:ph type="title"/>
-          </p:nvPr>
-        </p:nvSpPr>
-        <p:spPr/>
-        <p:txBody>
-          <a:bodyPr>
-            <a:normAutofit/>
-          </a:bodyPr>
-          <a:lstStyle/>
-          <a:p>
-            <a:r>
-              <a:rPr lang="en-US" sz="5400" b="1" dirty="0">
-                <a:solidFill>
-                  <a:srgbClr val="002060"/>
-                </a:solidFill>
-                <a:latin typeface="Segoe UI" panose="020B0502040204020203" pitchFamily="34" charset="0"/>
-                <a:cs typeface="Segoe UI" panose="020B0502040204020203" pitchFamily="34" charset="0"/>
-              </a:rPr>
-              <a:t>Challenge #4</a:t>
-            </a:r>
-            <a:endParaRPr lang="en-US" sz="3200" b="1" dirty="0">
-              <a:solidFill>
-                <a:srgbClr val="7030A0"/>
-              </a:solidFill>
-              <a:latin typeface="Segoe UI" panose="020B0502040204020203" pitchFamily="34" charset="0"/>
-              <a:cs typeface="Segoe UI" panose="020B0502040204020203" pitchFamily="34" charset="0"/>
-            </a:endParaRPr>
-          </a:p>
-        </p:txBody>
-      </p:sp>
-      <p:sp>
-        <p:nvSpPr>
-          <p:cNvPr id="2" name="Text Placeholder 1">
-            <a:extLst>
-              <a:ext uri="{FF2B5EF4-FFF2-40B4-BE49-F238E27FC236}">
-                <a16:creationId xmlns:a16="http://schemas.microsoft.com/office/drawing/2014/main" id="{8FD97A90-78BF-65F9-804C-11C53DA8ADEF}"/>
-              </a:ext>
-            </a:extLst>
-          </p:cNvPr>
-          <p:cNvSpPr>
-            <a:spLocks noGrp="1"/>
-          </p:cNvSpPr>
-          <p:nvPr>
-            <p:ph idx="1"/>
-          </p:nvPr>
-        </p:nvSpPr>
-        <p:spPr/>
-        <p:txBody>
-          <a:bodyPr>
-            <a:noAutofit/>
-          </a:bodyPr>
-          <a:lstStyle/>
-          <a:p>
-            <a:pPr marL="0" indent="0">
-              <a:buNone/>
-            </a:pPr>
-            <a:r>
-              <a:rPr lang="en-US" sz="2200" dirty="0">
-                <a:latin typeface="Segoe UI" panose="020B0502040204020203" pitchFamily="34" charset="0"/>
-                <a:cs typeface="Segoe UI" panose="020B0502040204020203" pitchFamily="34" charset="0"/>
-              </a:rPr>
-              <a:t>Your goal is to add custom spans, metrics, and structured logging to your travel planning application:</a:t>
-            </a:r>
-          </a:p>
-          <a:p>
-            <a:pPr marL="0" indent="0">
-              <a:buNone/>
-            </a:pPr>
-            <a:endParaRPr lang="en-US" sz="2200" dirty="0">
-              <a:latin typeface="Segoe UI" panose="020B0502040204020203" pitchFamily="34" charset="0"/>
-              <a:cs typeface="Segoe UI" panose="020B0502040204020203" pitchFamily="34" charset="0"/>
-            </a:endParaRPr>
-          </a:p>
-          <a:p>
-            <a:pPr>
-              <a:lnSpc>
-                <a:spcPct val="70000"/>
-              </a:lnSpc>
-            </a:pPr>
-            <a:r>
-              <a:rPr lang="en-US" sz="2500" b="1" dirty="0">
-                <a:solidFill>
-                  <a:srgbClr val="F6C243"/>
-                </a:solidFill>
-              </a:rPr>
-              <a:t>Add Custom Spans</a:t>
-            </a:r>
-          </a:p>
-          <a:p>
-            <a:pPr lvl="1">
-              <a:lnSpc>
-                <a:spcPct val="70000"/>
-              </a:lnSpc>
-            </a:pPr>
-            <a:r>
-              <a:rPr lang="en-US" sz="2500" dirty="0"/>
-              <a:t>Instrument tool calls and business logic with manual spans</a:t>
-            </a:r>
-          </a:p>
-          <a:p>
-            <a:pPr>
-              <a:lnSpc>
-                <a:spcPct val="70000"/>
-              </a:lnSpc>
-            </a:pPr>
-            <a:r>
-              <a:rPr lang="en-US" sz="2500" b="1" dirty="0">
-                <a:solidFill>
-                  <a:srgbClr val="F6C243"/>
-                </a:solidFill>
-              </a:rPr>
-              <a:t>Add Custom Metrics</a:t>
-            </a:r>
-          </a:p>
-          <a:p>
-            <a:pPr lvl="1">
-              <a:lnSpc>
-                <a:spcPct val="70000"/>
-              </a:lnSpc>
-            </a:pPr>
-            <a:r>
-              <a:rPr lang="en-US" sz="2500" dirty="0"/>
-              <a:t>Record meaningful measurements (trip planning duration, destination counts, etc.)</a:t>
-            </a:r>
-          </a:p>
-          <a:p>
-            <a:pPr>
-              <a:lnSpc>
-                <a:spcPct val="70000"/>
-              </a:lnSpc>
-            </a:pPr>
-            <a:r>
-              <a:rPr lang="en-US" sz="2500" b="1" dirty="0">
-                <a:solidFill>
-                  <a:srgbClr val="F6C243"/>
-                </a:solidFill>
-              </a:rPr>
-              <a:t>Add Structured Logging</a:t>
-            </a:r>
-          </a:p>
-          <a:p>
-            <a:pPr lvl="1">
-              <a:lnSpc>
-                <a:spcPct val="70000"/>
-              </a:lnSpc>
-            </a:pPr>
-            <a:r>
-              <a:rPr lang="en-US" sz="2500" dirty="0"/>
-              <a:t>Correlate logs with spans using trace context</a:t>
-            </a:r>
-          </a:p>
-          <a:p>
-            <a:pPr>
-              <a:lnSpc>
-                <a:spcPct val="70000"/>
-              </a:lnSpc>
-            </a:pPr>
-            <a:r>
-              <a:rPr lang="en-US" sz="2500" b="1" dirty="0">
-                <a:solidFill>
-                  <a:srgbClr val="F6C243"/>
-                </a:solidFill>
-              </a:rPr>
-              <a:t>Verify in New Relic</a:t>
-            </a:r>
-          </a:p>
-          <a:p>
-            <a:pPr lvl="1">
-              <a:lnSpc>
-                <a:spcPct val="70000"/>
-              </a:lnSpc>
-            </a:pPr>
-            <a:r>
-              <a:rPr lang="en-US" sz="2500" dirty="0"/>
-              <a:t>Confirm custom telemetry appears alongside auto-generated signals</a:t>
-            </a:r>
-          </a:p>
-        </p:txBody>
-      </p:sp>
-      <p:sp>
-        <p:nvSpPr>
-          <p:cNvPr id="8" name="Text Placeholder 7">
-            <a:extLst>
-              <a:ext uri="{FF2B5EF4-FFF2-40B4-BE49-F238E27FC236}">
-                <a16:creationId xmlns:a16="http://schemas.microsoft.com/office/drawing/2014/main" id="{EDF1FFF1-1F61-D01D-6DE7-3D56A5C8FDF5}"/>
-              </a:ext>
-            </a:extLst>
-          </p:cNvPr>
-          <p:cNvSpPr>
-            <a:spLocks noGrp="1"/>
-          </p:cNvSpPr>
-          <p:nvPr>
-            <p:ph type="body" sz="quarter" idx="13"/>
-          </p:nvPr>
-        </p:nvSpPr>
-        <p:spPr/>
-        <p:txBody>
-          <a:bodyPr/>
-          <a:lstStyle/>
-          <a:p>
-            <a:r>
-              <a:rPr lang="en-US" dirty="0"/>
-              <a:t>Custom Telemetry - Add your own signals</a:t>
-            </a:r>
-          </a:p>
-        </p:txBody>
-      </p:sp>
-      <p:sp>
-        <p:nvSpPr>
-          <p:cNvPr id="4" name="TextBox 3">
-            <a:extLst>
-              <a:ext uri="{FF2B5EF4-FFF2-40B4-BE49-F238E27FC236}">
-                <a16:creationId xmlns:a16="http://schemas.microsoft.com/office/drawing/2014/main" id="{228EE9D7-3009-9B3A-9DF5-EEA7AAFCDC30}"/>
-              </a:ext>
-            </a:extLst>
-          </p:cNvPr>
-          <p:cNvSpPr txBox="1"/>
-          <p:nvPr/>
-        </p:nvSpPr>
-        <p:spPr>
-          <a:xfrm>
-            <a:off x="5034987" y="1307939"/>
-            <a:ext cx="184731" cy="369332"/>
-          </a:xfrm>
-          <a:prstGeom prst="rect">
-            <a:avLst/>
-          </a:prstGeom>
-          <a:noFill/>
-        </p:spPr>
-        <p:txBody>
-          <a:bodyPr wrap="none" rtlCol="0">
-            <a:spAutoFit/>
-          </a:bodyPr>
-          <a:lstStyle/>
-          <a:p>
-            <a:endParaRPr lang="en-US" dirty="0"/>
-          </a:p>
-        </p:txBody>
-      </p:sp>
-      <p:sp>
-        <p:nvSpPr>
-          <p:cNvPr id="6" name="TextBox 5">
-            <a:extLst>
-              <a:ext uri="{FF2B5EF4-FFF2-40B4-BE49-F238E27FC236}">
-                <a16:creationId xmlns:a16="http://schemas.microsoft.com/office/drawing/2014/main" id="{82054D33-7493-7ADC-B23C-05E077C0FCDA}"/>
-              </a:ext>
-            </a:extLst>
-          </p:cNvPr>
-          <p:cNvSpPr txBox="1"/>
-          <p:nvPr/>
-        </p:nvSpPr>
-        <p:spPr>
-          <a:xfrm>
-            <a:off x="5775767" y="1088020"/>
-            <a:ext cx="184731" cy="369332"/>
-          </a:xfrm>
-          <a:prstGeom prst="rect">
-            <a:avLst/>
-          </a:prstGeom>
-          <a:noFill/>
-        </p:spPr>
-        <p:txBody>
-          <a:bodyPr wrap="none" rtlCol="0">
-            <a:spAutoFit/>
-          </a:bodyPr>
-          <a:lstStyle/>
-          <a:p>
-            <a:endParaRPr lang="en-US" dirty="0"/>
-          </a:p>
-        </p:txBody>
-      </p:sp>
-      <p:sp>
-        <p:nvSpPr>
-          <p:cNvPr id="7" name="TextBox 6">
-            <a:extLst>
-              <a:ext uri="{FF2B5EF4-FFF2-40B4-BE49-F238E27FC236}">
-                <a16:creationId xmlns:a16="http://schemas.microsoft.com/office/drawing/2014/main" id="{9AB85D21-7FB6-14C3-92DA-D9DC17F7A6FE}"/>
-              </a:ext>
-            </a:extLst>
-          </p:cNvPr>
-          <p:cNvSpPr txBox="1"/>
-          <p:nvPr/>
-        </p:nvSpPr>
-        <p:spPr>
-          <a:xfrm>
-            <a:off x="6111433" y="1157468"/>
-            <a:ext cx="184731" cy="369332"/>
-          </a:xfrm>
-          <a:prstGeom prst="rect">
-            <a:avLst/>
-          </a:prstGeom>
-          <a:noFill/>
-        </p:spPr>
-        <p:txBody>
-          <a:bodyPr wrap="none" rtlCol="0">
-            <a:spAutoFit/>
-          </a:bodyPr>
-          <a:lstStyle/>
-          <a:p>
-            <a:endParaRPr lang="en-US" dirty="0"/>
-          </a:p>
-        </p:txBody>
-      </p:sp>
-    </p:spTree>
-    <p:extLst>
-      <p:ext uri="{BB962C8B-B14F-4D97-AF65-F5344CB8AC3E}">
-        <p14:creationId xmlns:p14="http://schemas.microsoft.com/office/powerpoint/2010/main" val="334788417"/>
       </p:ext>
     </p:extLst>
   </p:cSld>
@@ -12867,6 +13079,358 @@
         <p:cNvPr id="1" name="">
           <a:extLst>
             <a:ext uri="{FF2B5EF4-FFF2-40B4-BE49-F238E27FC236}">
+              <a16:creationId xmlns:a16="http://schemas.microsoft.com/office/drawing/2014/main" id="{C443317F-74EF-57F8-08B9-6C83CE449BDD}"/>
+            </a:ext>
+          </a:extLst>
+        </p:cNvPr>
+        <p:cNvGrpSpPr/>
+        <p:nvPr/>
+      </p:nvGrpSpPr>
+      <p:grpSpPr>
+        <a:xfrm>
+          <a:off x="0" y="0"/>
+          <a:ext cx="0" cy="0"/>
+          <a:chOff x="0" y="0"/>
+          <a:chExt cx="0" cy="0"/>
+        </a:xfrm>
+      </p:grpSpPr>
+      <p:sp>
+        <p:nvSpPr>
+          <p:cNvPr id="3" name="Title 2">
+            <a:extLst>
+              <a:ext uri="{FF2B5EF4-FFF2-40B4-BE49-F238E27FC236}">
+                <a16:creationId xmlns:a16="http://schemas.microsoft.com/office/drawing/2014/main" id="{2D825D59-34F9-F4C9-5B64-03965D800016}"/>
+              </a:ext>
+            </a:extLst>
+          </p:cNvPr>
+          <p:cNvSpPr>
+            <a:spLocks noGrp="1"/>
+          </p:cNvSpPr>
+          <p:nvPr>
+            <p:ph type="title"/>
+          </p:nvPr>
+        </p:nvSpPr>
+        <p:spPr/>
+        <p:txBody>
+          <a:bodyPr>
+            <a:normAutofit/>
+          </a:bodyPr>
+          <a:lstStyle/>
+          <a:p>
+            <a:r>
+              <a:rPr lang="en-US" sz="5400" b="1" dirty="0">
+                <a:solidFill>
+                  <a:srgbClr val="002060"/>
+                </a:solidFill>
+                <a:latin typeface="Segoe UI" panose="020B0502040204020203" pitchFamily="34" charset="0"/>
+                <a:cs typeface="Segoe UI" panose="020B0502040204020203" pitchFamily="34" charset="0"/>
+              </a:rPr>
+              <a:t>Challenge #4</a:t>
+            </a:r>
+            <a:endParaRPr lang="en-US" sz="3200" b="1" dirty="0">
+              <a:solidFill>
+                <a:srgbClr val="7030A0"/>
+              </a:solidFill>
+              <a:latin typeface="Segoe UI" panose="020B0502040204020203" pitchFamily="34" charset="0"/>
+              <a:cs typeface="Segoe UI" panose="020B0502040204020203" pitchFamily="34" charset="0"/>
+            </a:endParaRPr>
+          </a:p>
+        </p:txBody>
+      </p:sp>
+      <p:sp>
+        <p:nvSpPr>
+          <p:cNvPr id="2" name="Text Placeholder 1">
+            <a:extLst>
+              <a:ext uri="{FF2B5EF4-FFF2-40B4-BE49-F238E27FC236}">
+                <a16:creationId xmlns:a16="http://schemas.microsoft.com/office/drawing/2014/main" id="{8FD97A90-78BF-65F9-804C-11C53DA8ADEF}"/>
+              </a:ext>
+            </a:extLst>
+          </p:cNvPr>
+          <p:cNvSpPr>
+            <a:spLocks noGrp="1"/>
+          </p:cNvSpPr>
+          <p:nvPr>
+            <p:ph idx="1"/>
+          </p:nvPr>
+        </p:nvSpPr>
+        <p:spPr/>
+        <p:txBody>
+          <a:bodyPr>
+            <a:noAutofit/>
+          </a:bodyPr>
+          <a:lstStyle/>
+          <a:p>
+            <a:pPr marL="0" indent="0">
+              <a:buNone/>
+            </a:pPr>
+            <a:r>
+              <a:rPr lang="en-US" sz="2200" dirty="0">
+                <a:latin typeface="Segoe UI" panose="020B0502040204020203" pitchFamily="34" charset="0"/>
+                <a:cs typeface="Segoe UI" panose="020B0502040204020203" pitchFamily="34" charset="0"/>
+              </a:rPr>
+              <a:t>Your goal is to add custom spans, metrics, and structured logging to your travel planning application:</a:t>
+            </a:r>
+          </a:p>
+          <a:p>
+            <a:pPr marL="0" indent="0">
+              <a:buNone/>
+            </a:pPr>
+            <a:endParaRPr lang="en-US" sz="2200" dirty="0">
+              <a:latin typeface="Segoe UI" panose="020B0502040204020203" pitchFamily="34" charset="0"/>
+              <a:cs typeface="Segoe UI" panose="020B0502040204020203" pitchFamily="34" charset="0"/>
+            </a:endParaRPr>
+          </a:p>
+          <a:p>
+            <a:pPr>
+              <a:lnSpc>
+                <a:spcPct val="70000"/>
+              </a:lnSpc>
+            </a:pPr>
+            <a:r>
+              <a:rPr lang="en-US" sz="2500" b="1" dirty="0">
+                <a:solidFill>
+                  <a:srgbClr val="F6C243"/>
+                </a:solidFill>
+              </a:rPr>
+              <a:t>Add Custom Spans</a:t>
+            </a:r>
+          </a:p>
+          <a:p>
+            <a:pPr lvl="1">
+              <a:lnSpc>
+                <a:spcPct val="70000"/>
+              </a:lnSpc>
+            </a:pPr>
+            <a:r>
+              <a:rPr lang="en-US" sz="2500" dirty="0"/>
+              <a:t>Instrument tool calls and business logic with manual spans</a:t>
+            </a:r>
+          </a:p>
+          <a:p>
+            <a:pPr>
+              <a:lnSpc>
+                <a:spcPct val="70000"/>
+              </a:lnSpc>
+            </a:pPr>
+            <a:r>
+              <a:rPr lang="en-US" sz="2500" b="1" dirty="0">
+                <a:solidFill>
+                  <a:srgbClr val="F6C243"/>
+                </a:solidFill>
+              </a:rPr>
+              <a:t>Add Custom Metrics</a:t>
+            </a:r>
+          </a:p>
+          <a:p>
+            <a:pPr lvl="1">
+              <a:lnSpc>
+                <a:spcPct val="70000"/>
+              </a:lnSpc>
+            </a:pPr>
+            <a:r>
+              <a:rPr lang="en-US" sz="2500" dirty="0"/>
+              <a:t>Record meaningful measurements (trip planning duration, destination counts, etc.)</a:t>
+            </a:r>
+          </a:p>
+          <a:p>
+            <a:pPr>
+              <a:lnSpc>
+                <a:spcPct val="70000"/>
+              </a:lnSpc>
+            </a:pPr>
+            <a:r>
+              <a:rPr lang="en-US" sz="2500" b="1" dirty="0">
+                <a:solidFill>
+                  <a:srgbClr val="F6C243"/>
+                </a:solidFill>
+              </a:rPr>
+              <a:t>Add Structured Logging</a:t>
+            </a:r>
+          </a:p>
+          <a:p>
+            <a:pPr lvl="1">
+              <a:lnSpc>
+                <a:spcPct val="70000"/>
+              </a:lnSpc>
+            </a:pPr>
+            <a:r>
+              <a:rPr lang="en-US" sz="2500" dirty="0"/>
+              <a:t>Correlate logs with spans using trace context</a:t>
+            </a:r>
+          </a:p>
+          <a:p>
+            <a:pPr>
+              <a:lnSpc>
+                <a:spcPct val="70000"/>
+              </a:lnSpc>
+            </a:pPr>
+            <a:r>
+              <a:rPr lang="en-US" sz="2500" b="1" dirty="0">
+                <a:solidFill>
+                  <a:srgbClr val="F6C243"/>
+                </a:solidFill>
+              </a:rPr>
+              <a:t>Verify in New Relic</a:t>
+            </a:r>
+          </a:p>
+          <a:p>
+            <a:pPr lvl="1">
+              <a:lnSpc>
+                <a:spcPct val="70000"/>
+              </a:lnSpc>
+            </a:pPr>
+            <a:r>
+              <a:rPr lang="en-US" sz="2500" dirty="0"/>
+              <a:t>Confirm custom telemetry appears alongside auto-generated signals</a:t>
+            </a:r>
+          </a:p>
+        </p:txBody>
+      </p:sp>
+      <p:sp>
+        <p:nvSpPr>
+          <p:cNvPr id="8" name="Text Placeholder 7">
+            <a:extLst>
+              <a:ext uri="{FF2B5EF4-FFF2-40B4-BE49-F238E27FC236}">
+                <a16:creationId xmlns:a16="http://schemas.microsoft.com/office/drawing/2014/main" id="{EDF1FFF1-1F61-D01D-6DE7-3D56A5C8FDF5}"/>
+              </a:ext>
+            </a:extLst>
+          </p:cNvPr>
+          <p:cNvSpPr>
+            <a:spLocks noGrp="1"/>
+          </p:cNvSpPr>
+          <p:nvPr>
+            <p:ph type="body" sz="quarter" idx="13"/>
+          </p:nvPr>
+        </p:nvSpPr>
+        <p:spPr/>
+        <p:txBody>
+          <a:bodyPr/>
+          <a:lstStyle/>
+          <a:p>
+            <a:r>
+              <a:rPr lang="en-US" dirty="0"/>
+              <a:t>Custom Telemetry - Add your own signals</a:t>
+            </a:r>
+          </a:p>
+        </p:txBody>
+      </p:sp>
+      <p:sp>
+        <p:nvSpPr>
+          <p:cNvPr id="4" name="TextBox 3">
+            <a:extLst>
+              <a:ext uri="{FF2B5EF4-FFF2-40B4-BE49-F238E27FC236}">
+                <a16:creationId xmlns:a16="http://schemas.microsoft.com/office/drawing/2014/main" id="{228EE9D7-3009-9B3A-9DF5-EEA7AAFCDC30}"/>
+              </a:ext>
+            </a:extLst>
+          </p:cNvPr>
+          <p:cNvSpPr txBox="1"/>
+          <p:nvPr/>
+        </p:nvSpPr>
+        <p:spPr>
+          <a:xfrm>
+            <a:off x="5034987" y="1307939"/>
+            <a:ext cx="184731" cy="369332"/>
+          </a:xfrm>
+          <a:prstGeom prst="rect">
+            <a:avLst/>
+          </a:prstGeom>
+          <a:noFill/>
+        </p:spPr>
+        <p:txBody>
+          <a:bodyPr wrap="none" rtlCol="0">
+            <a:spAutoFit/>
+          </a:bodyPr>
+          <a:lstStyle/>
+          <a:p>
+            <a:endParaRPr lang="en-US" dirty="0"/>
+          </a:p>
+        </p:txBody>
+      </p:sp>
+      <p:sp>
+        <p:nvSpPr>
+          <p:cNvPr id="6" name="TextBox 5">
+            <a:extLst>
+              <a:ext uri="{FF2B5EF4-FFF2-40B4-BE49-F238E27FC236}">
+                <a16:creationId xmlns:a16="http://schemas.microsoft.com/office/drawing/2014/main" id="{82054D33-7493-7ADC-B23C-05E077C0FCDA}"/>
+              </a:ext>
+            </a:extLst>
+          </p:cNvPr>
+          <p:cNvSpPr txBox="1"/>
+          <p:nvPr/>
+        </p:nvSpPr>
+        <p:spPr>
+          <a:xfrm>
+            <a:off x="5775767" y="1088020"/>
+            <a:ext cx="184731" cy="369332"/>
+          </a:xfrm>
+          <a:prstGeom prst="rect">
+            <a:avLst/>
+          </a:prstGeom>
+          <a:noFill/>
+        </p:spPr>
+        <p:txBody>
+          <a:bodyPr wrap="none" rtlCol="0">
+            <a:spAutoFit/>
+          </a:bodyPr>
+          <a:lstStyle/>
+          <a:p>
+            <a:endParaRPr lang="en-US" dirty="0"/>
+          </a:p>
+        </p:txBody>
+      </p:sp>
+      <p:sp>
+        <p:nvSpPr>
+          <p:cNvPr id="7" name="TextBox 6">
+            <a:extLst>
+              <a:ext uri="{FF2B5EF4-FFF2-40B4-BE49-F238E27FC236}">
+                <a16:creationId xmlns:a16="http://schemas.microsoft.com/office/drawing/2014/main" id="{9AB85D21-7FB6-14C3-92DA-D9DC17F7A6FE}"/>
+              </a:ext>
+            </a:extLst>
+          </p:cNvPr>
+          <p:cNvSpPr txBox="1"/>
+          <p:nvPr/>
+        </p:nvSpPr>
+        <p:spPr>
+          <a:xfrm>
+            <a:off x="6111433" y="1157468"/>
+            <a:ext cx="184731" cy="369332"/>
+          </a:xfrm>
+          <a:prstGeom prst="rect">
+            <a:avLst/>
+          </a:prstGeom>
+          <a:noFill/>
+        </p:spPr>
+        <p:txBody>
+          <a:bodyPr wrap="none" rtlCol="0">
+            <a:spAutoFit/>
+          </a:bodyPr>
+          <a:lstStyle/>
+          <a:p>
+            <a:endParaRPr lang="en-US" dirty="0"/>
+          </a:p>
+        </p:txBody>
+      </p:sp>
+    </p:spTree>
+    <p:extLst>
+      <p:ext uri="{BB962C8B-B14F-4D97-AF65-F5344CB8AC3E}">
+        <p14:creationId xmlns:p14="http://schemas.microsoft.com/office/powerpoint/2010/main" val="334788417"/>
+      </p:ext>
+    </p:extLst>
+  </p:cSld>
+  <p:clrMapOvr>
+    <a:masterClrMapping/>
+  </p:clrMapOvr>
+</p:sld>
+</file>
+
+<file path=ppt/slides/slide21.xml><?xml version="1.0" encoding="utf-8"?>
+<p:sld xmlns:a="http://schemas.openxmlformats.org/drawingml/2006/main" xmlns:r="http://schemas.openxmlformats.org/officeDocument/2006/relationships" xmlns:p="http://schemas.openxmlformats.org/presentationml/2006/main">
+  <p:cSld>
+    <p:spTree>
+      <p:nvGrpSpPr>
+        <p:cNvPr id="1" name="">
+          <a:extLst>
+            <a:ext uri="{FF2B5EF4-FFF2-40B4-BE49-F238E27FC236}">
               <a16:creationId xmlns:a16="http://schemas.microsoft.com/office/drawing/2014/main" id="{9473CF8A-21E8-7F4F-55A0-0B1CB7E9224A}"/>
             </a:ext>
           </a:extLst>
@@ -12967,7 +13531,7 @@
 </p:sld>
 </file>
 
-<file path=ppt/slides/slide21.xml><?xml version="1.0" encoding="utf-8"?>
+<file path=ppt/slides/slide22.xml><?xml version="1.0" encoding="utf-8"?>
 <p:sld xmlns:a="http://schemas.openxmlformats.org/drawingml/2006/main" xmlns:r="http://schemas.openxmlformats.org/officeDocument/2006/relationships" xmlns:p="http://schemas.openxmlformats.org/presentationml/2006/main">
   <p:cSld>
     <p:spTree>
@@ -13125,7 +13689,7 @@
 </p:sld>
 </file>
 
-<file path=ppt/slides/slide22.xml><?xml version="1.0" encoding="utf-8"?>
+<file path=ppt/slides/slide23.xml><?xml version="1.0" encoding="utf-8"?>
 <p:sld xmlns:a="http://schemas.openxmlformats.org/drawingml/2006/main" xmlns:r="http://schemas.openxmlformats.org/officeDocument/2006/relationships" xmlns:p="http://schemas.openxmlformats.org/presentationml/2006/main">
   <p:cSld>
     <p:spTree>
@@ -13502,7 +14066,7 @@
 </p:sld>
 </file>
 
-<file path=ppt/slides/slide23.xml><?xml version="1.0" encoding="utf-8"?>
+<file path=ppt/slides/slide24.xml><?xml version="1.0" encoding="utf-8"?>
 <p:sld xmlns:a="http://schemas.openxmlformats.org/drawingml/2006/main" xmlns:r="http://schemas.openxmlformats.org/officeDocument/2006/relationships" xmlns:p="http://schemas.openxmlformats.org/presentationml/2006/main">
   <p:cSld>
     <p:spTree>
@@ -13610,7 +14174,7 @@
 </p:sld>
 </file>
 
-<file path=ppt/slides/slide24.xml><?xml version="1.0" encoding="utf-8"?>
+<file path=ppt/slides/slide25.xml><?xml version="1.0" encoding="utf-8"?>
 <p:sld xmlns:a="http://schemas.openxmlformats.org/drawingml/2006/main" xmlns:r="http://schemas.openxmlformats.org/officeDocument/2006/relationships" xmlns:p="http://schemas.openxmlformats.org/presentationml/2006/main">
   <p:cSld>
     <p:spTree>
@@ -13762,7 +14326,7 @@
 </p:sld>
 </file>
 
-<file path=ppt/slides/slide25.xml><?xml version="1.0" encoding="utf-8"?>
+<file path=ppt/slides/slide26.xml><?xml version="1.0" encoding="utf-8"?>
 <p:sld xmlns:a="http://schemas.openxmlformats.org/drawingml/2006/main" xmlns:r="http://schemas.openxmlformats.org/officeDocument/2006/relationships" xmlns:p="http://schemas.openxmlformats.org/presentationml/2006/main">
   <p:cSld>
     <p:spTree>
@@ -14149,7 +14713,7 @@
 </p:sld>
 </file>
 
-<file path=ppt/slides/slide26.xml><?xml version="1.0" encoding="utf-8"?>
+<file path=ppt/slides/slide27.xml><?xml version="1.0" encoding="utf-8"?>
 <p:sld xmlns:a="http://schemas.openxmlformats.org/drawingml/2006/main" xmlns:r="http://schemas.openxmlformats.org/officeDocument/2006/relationships" xmlns:p="http://schemas.openxmlformats.org/presentationml/2006/main">
   <p:cSld>
     <p:spTree>
@@ -14270,7 +14834,7 @@
 </p:sld>
 </file>
 
-<file path=ppt/slides/slide27.xml><?xml version="1.0" encoding="utf-8"?>
+<file path=ppt/slides/slide28.xml><?xml version="1.0" encoding="utf-8"?>
 <p:sld xmlns:a="http://schemas.openxmlformats.org/drawingml/2006/main" xmlns:r="http://schemas.openxmlformats.org/officeDocument/2006/relationships" xmlns:p="http://schemas.openxmlformats.org/presentationml/2006/main">
   <p:cSld>
     <p:spTree>
@@ -14463,7 +15027,7 @@
 </p:sld>
 </file>
 
-<file path=ppt/slides/slide28.xml><?xml version="1.0" encoding="utf-8"?>
+<file path=ppt/slides/slide29.xml><?xml version="1.0" encoding="utf-8"?>
 <p:sld xmlns:a="http://schemas.openxmlformats.org/drawingml/2006/main" xmlns:r="http://schemas.openxmlformats.org/officeDocument/2006/relationships" xmlns:p="http://schemas.openxmlformats.org/presentationml/2006/main">
   <p:cSld>
     <p:spTree>
@@ -14760,115 +15324,6 @@
     <p:extLst>
       <p:ext uri="{BB962C8B-B14F-4D97-AF65-F5344CB8AC3E}">
         <p14:creationId xmlns:p14="http://schemas.microsoft.com/office/powerpoint/2010/main" val="3708894519"/>
-      </p:ext>
-    </p:extLst>
-  </p:cSld>
-  <p:clrMapOvr>
-    <a:masterClrMapping/>
-  </p:clrMapOvr>
-</p:sld>
-</file>
-
-<file path=ppt/slides/slide29.xml><?xml version="1.0" encoding="utf-8"?>
-<p:sld xmlns:a="http://schemas.openxmlformats.org/drawingml/2006/main" xmlns:r="http://schemas.openxmlformats.org/officeDocument/2006/relationships" xmlns:p="http://schemas.openxmlformats.org/presentationml/2006/main">
-  <p:cSld>
-    <p:spTree>
-      <p:nvGrpSpPr>
-        <p:cNvPr id="1" name="">
-          <a:extLst>
-            <a:ext uri="{FF2B5EF4-FFF2-40B4-BE49-F238E27FC236}">
-              <a16:creationId xmlns:a16="http://schemas.microsoft.com/office/drawing/2014/main" id="{D1857BAB-EDCF-5C0C-A3EE-CAF52662944B}"/>
-            </a:ext>
-          </a:extLst>
-        </p:cNvPr>
-        <p:cNvGrpSpPr/>
-        <p:nvPr/>
-      </p:nvGrpSpPr>
-      <p:grpSpPr>
-        <a:xfrm>
-          <a:off x="0" y="0"/>
-          <a:ext cx="0" cy="0"/>
-          <a:chOff x="0" y="0"/>
-          <a:chExt cx="0" cy="0"/>
-        </a:xfrm>
-      </p:grpSpPr>
-      <p:sp>
-        <p:nvSpPr>
-          <p:cNvPr id="2" name="Title 1">
-            <a:extLst>
-              <a:ext uri="{FF2B5EF4-FFF2-40B4-BE49-F238E27FC236}">
-                <a16:creationId xmlns:a16="http://schemas.microsoft.com/office/drawing/2014/main" id="{5498AA1B-7744-AF86-80B1-2ECB50761CF4}"/>
-              </a:ext>
-            </a:extLst>
-          </p:cNvPr>
-          <p:cNvSpPr>
-            <a:spLocks noGrp="1"/>
-          </p:cNvSpPr>
-          <p:nvPr>
-            <p:ph type="title"/>
-          </p:nvPr>
-        </p:nvSpPr>
-        <p:spPr>
-          <a:xfrm>
-            <a:off x="831850" y="1317852"/>
-            <a:ext cx="11360150" cy="2132919"/>
-          </a:xfrm>
-        </p:spPr>
-        <p:txBody>
-          <a:bodyPr lIns="90000" anchor="t" anchorCtr="0">
-            <a:noAutofit/>
-          </a:bodyPr>
-          <a:lstStyle/>
-          <a:p>
-            <a:r>
-              <a:rPr lang="en-US" sz="5400" dirty="0"/>
-              <a:t>Challenge 8</a:t>
-            </a:r>
-            <a:br>
-              <a:rPr lang="en-US" sz="5400" dirty="0"/>
-            </a:br>
-            <a:r>
-              <a:rPr lang="en-US" sz="5400" dirty="0"/>
-              <a:t>- AI Security: Application-Level</a:t>
-            </a:r>
-          </a:p>
-        </p:txBody>
-      </p:sp>
-      <p:sp>
-        <p:nvSpPr>
-          <p:cNvPr id="3" name="Text Placeholder 2">
-            <a:extLst>
-              <a:ext uri="{FF2B5EF4-FFF2-40B4-BE49-F238E27FC236}">
-                <a16:creationId xmlns:a16="http://schemas.microsoft.com/office/drawing/2014/main" id="{AA0EDB8C-7140-8F94-1D00-C58358021FDD}"/>
-              </a:ext>
-            </a:extLst>
-          </p:cNvPr>
-          <p:cNvSpPr>
-            <a:spLocks noGrp="1"/>
-          </p:cNvSpPr>
-          <p:nvPr>
-            <p:ph type="body" idx="1"/>
-          </p:nvPr>
-        </p:nvSpPr>
-        <p:spPr/>
-        <p:txBody>
-          <a:bodyPr>
-            <a:normAutofit/>
-          </a:bodyPr>
-          <a:lstStyle/>
-          <a:p>
-            <a:pPr algn="ctr"/>
-            <a:r>
-              <a:rPr lang="en-US" dirty="0"/>
-              <a:t>Build custom detection and blocking</a:t>
-            </a:r>
-          </a:p>
-        </p:txBody>
-      </p:sp>
-    </p:spTree>
-    <p:extLst>
-      <p:ext uri="{BB962C8B-B14F-4D97-AF65-F5344CB8AC3E}">
-        <p14:creationId xmlns:p14="http://schemas.microsoft.com/office/powerpoint/2010/main" val="2401108977"/>
       </p:ext>
     </p:extLst>
   </p:cSld>
@@ -15419,6 +15874,115 @@
         <p:cNvPr id="1" name="">
           <a:extLst>
             <a:ext uri="{FF2B5EF4-FFF2-40B4-BE49-F238E27FC236}">
+              <a16:creationId xmlns:a16="http://schemas.microsoft.com/office/drawing/2014/main" id="{D1857BAB-EDCF-5C0C-A3EE-CAF52662944B}"/>
+            </a:ext>
+          </a:extLst>
+        </p:cNvPr>
+        <p:cNvGrpSpPr/>
+        <p:nvPr/>
+      </p:nvGrpSpPr>
+      <p:grpSpPr>
+        <a:xfrm>
+          <a:off x="0" y="0"/>
+          <a:ext cx="0" cy="0"/>
+          <a:chOff x="0" y="0"/>
+          <a:chExt cx="0" cy="0"/>
+        </a:xfrm>
+      </p:grpSpPr>
+      <p:sp>
+        <p:nvSpPr>
+          <p:cNvPr id="2" name="Title 1">
+            <a:extLst>
+              <a:ext uri="{FF2B5EF4-FFF2-40B4-BE49-F238E27FC236}">
+                <a16:creationId xmlns:a16="http://schemas.microsoft.com/office/drawing/2014/main" id="{5498AA1B-7744-AF86-80B1-2ECB50761CF4}"/>
+              </a:ext>
+            </a:extLst>
+          </p:cNvPr>
+          <p:cNvSpPr>
+            <a:spLocks noGrp="1"/>
+          </p:cNvSpPr>
+          <p:nvPr>
+            <p:ph type="title"/>
+          </p:nvPr>
+        </p:nvSpPr>
+        <p:spPr>
+          <a:xfrm>
+            <a:off x="831850" y="1317852"/>
+            <a:ext cx="11360150" cy="2132919"/>
+          </a:xfrm>
+        </p:spPr>
+        <p:txBody>
+          <a:bodyPr lIns="90000" anchor="t" anchorCtr="0">
+            <a:noAutofit/>
+          </a:bodyPr>
+          <a:lstStyle/>
+          <a:p>
+            <a:r>
+              <a:rPr lang="en-US" sz="5400" dirty="0"/>
+              <a:t>Challenge 8</a:t>
+            </a:r>
+            <a:br>
+              <a:rPr lang="en-US" sz="5400" dirty="0"/>
+            </a:br>
+            <a:r>
+              <a:rPr lang="en-US" sz="5400" dirty="0"/>
+              <a:t>- AI Security: Application-Level</a:t>
+            </a:r>
+          </a:p>
+        </p:txBody>
+      </p:sp>
+      <p:sp>
+        <p:nvSpPr>
+          <p:cNvPr id="3" name="Text Placeholder 2">
+            <a:extLst>
+              <a:ext uri="{FF2B5EF4-FFF2-40B4-BE49-F238E27FC236}">
+                <a16:creationId xmlns:a16="http://schemas.microsoft.com/office/drawing/2014/main" id="{AA0EDB8C-7140-8F94-1D00-C58358021FDD}"/>
+              </a:ext>
+            </a:extLst>
+          </p:cNvPr>
+          <p:cNvSpPr>
+            <a:spLocks noGrp="1"/>
+          </p:cNvSpPr>
+          <p:nvPr>
+            <p:ph type="body" idx="1"/>
+          </p:nvPr>
+        </p:nvSpPr>
+        <p:spPr/>
+        <p:txBody>
+          <a:bodyPr>
+            <a:normAutofit/>
+          </a:bodyPr>
+          <a:lstStyle/>
+          <a:p>
+            <a:pPr algn="ctr"/>
+            <a:r>
+              <a:rPr lang="en-US" dirty="0"/>
+              <a:t>Build custom detection and blocking</a:t>
+            </a:r>
+          </a:p>
+        </p:txBody>
+      </p:sp>
+    </p:spTree>
+    <p:extLst>
+      <p:ext uri="{BB962C8B-B14F-4D97-AF65-F5344CB8AC3E}">
+        <p14:creationId xmlns:p14="http://schemas.microsoft.com/office/powerpoint/2010/main" val="2401108977"/>
+      </p:ext>
+    </p:extLst>
+  </p:cSld>
+  <p:clrMapOvr>
+    <a:masterClrMapping/>
+  </p:clrMapOvr>
+</p:sld>
+</file>
+
+<file path=ppt/slides/slide31.xml><?xml version="1.0" encoding="utf-8"?>
+<p:sld xmlns:a="http://schemas.openxmlformats.org/drawingml/2006/main" xmlns:r="http://schemas.openxmlformats.org/officeDocument/2006/relationships" xmlns:p="http://schemas.openxmlformats.org/presentationml/2006/main">
+  <p:cSld>
+    <p:spTree>
+      <p:nvGrpSpPr>
+        <p:cNvPr id="1" name="">
+          <a:extLst>
+            <a:ext uri="{FF2B5EF4-FFF2-40B4-BE49-F238E27FC236}">
               <a16:creationId xmlns:a16="http://schemas.microsoft.com/office/drawing/2014/main" id="{E1DCD483-5C21-7B7B-0C8D-285E7B45941C}"/>
             </a:ext>
           </a:extLst>
@@ -15611,7 +16175,7 @@
 </p:sld>
 </file>
 
-<file path=ppt/slides/slide31.xml><?xml version="1.0" encoding="utf-8"?>
+<file path=ppt/slides/slide32.xml><?xml version="1.0" encoding="utf-8"?>
 <p:sld xmlns:a="http://schemas.openxmlformats.org/drawingml/2006/main" xmlns:r="http://schemas.openxmlformats.org/officeDocument/2006/relationships" xmlns:p="http://schemas.openxmlformats.org/presentationml/2006/main">
   <p:cSld>
     <p:spTree>
@@ -15950,7 +16514,7 @@
 </p:sld>
 </file>
 
-<file path=ppt/slides/slide32.xml><?xml version="1.0" encoding="utf-8"?>
+<file path=ppt/slides/slide33.xml><?xml version="1.0" encoding="utf-8"?>
 <p:sld xmlns:a="http://schemas.openxmlformats.org/drawingml/2006/main" xmlns:r="http://schemas.openxmlformats.org/officeDocument/2006/relationships" xmlns:p="http://schemas.openxmlformats.org/presentationml/2006/main">
   <p:cSld>
     <p:bg>
@@ -16375,7 +16939,13 @@
   <p:cSld>
     <p:spTree>
       <p:nvGrpSpPr>
-        <p:cNvPr id="1" name=""/>
+        <p:cNvPr id="1" name="">
+          <a:extLst>
+            <a:ext uri="{FF2B5EF4-FFF2-40B4-BE49-F238E27FC236}">
+              <a16:creationId xmlns:a16="http://schemas.microsoft.com/office/drawing/2014/main" id="{7D1881B7-FB2B-2298-84FA-ADFB97DAD20E}"/>
+            </a:ext>
+          </a:extLst>
+        </p:cNvPr>
         <p:cNvGrpSpPr/>
         <p:nvPr/>
       </p:nvGrpSpPr>
@@ -16392,7 +16962,7 @@
           <p:cNvPr id="13" name="Picture 12" descr="A sign in the dark&#10;&#10;Description automatically generated">
             <a:extLst>
               <a:ext uri="{FF2B5EF4-FFF2-40B4-BE49-F238E27FC236}">
-                <a16:creationId xmlns:a16="http://schemas.microsoft.com/office/drawing/2014/main" id="{BE6589E2-4BBA-2F44-91F9-E56FD50BED98}"/>
+                <a16:creationId xmlns:a16="http://schemas.microsoft.com/office/drawing/2014/main" id="{B46CE5BD-AC3E-AEC4-2020-30272C9FB474}"/>
               </a:ext>
             </a:extLst>
           </p:cNvPr>
@@ -16427,7 +16997,7 @@
           <p:cNvPr id="3" name="Content Placeholder 2">
             <a:extLst>
               <a:ext uri="{FF2B5EF4-FFF2-40B4-BE49-F238E27FC236}">
-                <a16:creationId xmlns:a16="http://schemas.microsoft.com/office/drawing/2014/main" id="{65EF49C9-ADEF-4199-87BD-25B691F4E4AF}"/>
+                <a16:creationId xmlns:a16="http://schemas.microsoft.com/office/drawing/2014/main" id="{88037DDF-5FB6-93D5-4709-FC75ACEB8DE2}"/>
               </a:ext>
             </a:extLst>
           </p:cNvPr>
@@ -16440,7 +17010,7 @@
         </p:nvSpPr>
         <p:spPr>
           <a:xfrm>
-            <a:off x="845671" y="2107614"/>
+            <a:off x="838200" y="2816522"/>
             <a:ext cx="10515600" cy="612478"/>
           </a:xfrm>
         </p:spPr>
@@ -16522,7 +17092,7 @@
           <p:cNvPr id="7" name="TextBox 6">
             <a:extLst>
               <a:ext uri="{FF2B5EF4-FFF2-40B4-BE49-F238E27FC236}">
-                <a16:creationId xmlns:a16="http://schemas.microsoft.com/office/drawing/2014/main" id="{A2E725C8-3DB9-ED40-B2EB-EC82B1330DC9}"/>
+                <a16:creationId xmlns:a16="http://schemas.microsoft.com/office/drawing/2014/main" id="{99134BF9-E176-5635-8AA8-8A14EF789F2E}"/>
               </a:ext>
             </a:extLst>
           </p:cNvPr>
@@ -16579,6 +17149,228 @@
           </a:p>
         </p:txBody>
       </p:sp>
+    </p:spTree>
+    <p:extLst>
+      <p:ext uri="{BB962C8B-B14F-4D97-AF65-F5344CB8AC3E}">
+        <p14:creationId xmlns:p14="http://schemas.microsoft.com/office/powerpoint/2010/main" val="241735255"/>
+      </p:ext>
+    </p:extLst>
+  </p:cSld>
+  <p:clrMapOvr>
+    <a:masterClrMapping/>
+  </p:clrMapOvr>
+</p:sld>
+</file>
+
+<file path=ppt/slides/slide6.xml><?xml version="1.0" encoding="utf-8"?>
+<p:sld xmlns:a="http://schemas.openxmlformats.org/drawingml/2006/main" xmlns:r="http://schemas.openxmlformats.org/officeDocument/2006/relationships" xmlns:p="http://schemas.openxmlformats.org/presentationml/2006/main" show="0">
+  <p:cSld>
+    <p:spTree>
+      <p:nvGrpSpPr>
+        <p:cNvPr id="1" name=""/>
+        <p:cNvGrpSpPr/>
+        <p:nvPr/>
+      </p:nvGrpSpPr>
+      <p:grpSpPr>
+        <a:xfrm>
+          <a:off x="0" y="0"/>
+          <a:ext cx="0" cy="0"/>
+          <a:chOff x="0" y="0"/>
+          <a:chExt cx="0" cy="0"/>
+        </a:xfrm>
+      </p:grpSpPr>
+      <p:pic>
+        <p:nvPicPr>
+          <p:cNvPr id="13" name="Picture 12" descr="A sign in the dark&#10;&#10;Description automatically generated">
+            <a:extLst>
+              <a:ext uri="{FF2B5EF4-FFF2-40B4-BE49-F238E27FC236}">
+                <a16:creationId xmlns:a16="http://schemas.microsoft.com/office/drawing/2014/main" id="{BE6589E2-4BBA-2F44-91F9-E56FD50BED98}"/>
+              </a:ext>
+            </a:extLst>
+          </p:cNvPr>
+          <p:cNvPicPr>
+            <a:picLocks noChangeAspect="1"/>
+          </p:cNvPicPr>
+          <p:nvPr/>
+        </p:nvPicPr>
+        <p:blipFill rotWithShape="1">
+          <a:blip r:embed="rId3" cstate="print">
+            <a:extLst>
+              <a:ext uri="{28A0092B-C50C-407E-A947-70E740481C1C}">
+                <a14:useLocalDpi xmlns:a14="http://schemas.microsoft.com/office/drawing/2010/main"/>
+              </a:ext>
+            </a:extLst>
+          </a:blip>
+          <a:srcRect/>
+          <a:stretch/>
+        </p:blipFill>
+        <p:spPr>
+          <a:xfrm>
+            <a:off x="2492037" y="259976"/>
+            <a:ext cx="7123481" cy="1748118"/>
+          </a:xfrm>
+          <a:prstGeom prst="rect">
+            <a:avLst/>
+          </a:prstGeom>
+        </p:spPr>
+      </p:pic>
+      <p:sp>
+        <p:nvSpPr>
+          <p:cNvPr id="3" name="Content Placeholder 2">
+            <a:extLst>
+              <a:ext uri="{FF2B5EF4-FFF2-40B4-BE49-F238E27FC236}">
+                <a16:creationId xmlns:a16="http://schemas.microsoft.com/office/drawing/2014/main" id="{65EF49C9-ADEF-4199-87BD-25B691F4E4AF}"/>
+              </a:ext>
+            </a:extLst>
+          </p:cNvPr>
+          <p:cNvSpPr>
+            <a:spLocks noGrp="1"/>
+          </p:cNvSpPr>
+          <p:nvPr>
+            <p:ph idx="1"/>
+          </p:nvPr>
+        </p:nvSpPr>
+        <p:spPr>
+          <a:xfrm>
+            <a:off x="845671" y="2107614"/>
+            <a:ext cx="10515600" cy="612478"/>
+          </a:xfrm>
+        </p:spPr>
+        <p:txBody>
+          <a:bodyPr>
+            <a:normAutofit fontScale="25000" lnSpcReduction="20000"/>
+          </a:bodyPr>
+          <a:lstStyle/>
+          <a:p>
+            <a:pPr marL="0" indent="0" algn="ctr">
+              <a:buNone/>
+            </a:pPr>
+            <a:r>
+              <a:rPr lang="en-US" sz="12800" dirty="0">
+                <a:solidFill>
+                  <a:srgbClr val="7030A0"/>
+                </a:solidFill>
+                <a:latin typeface="Segoe UI Light" panose="020B0502040204020203" pitchFamily="34" charset="0"/>
+                <a:cs typeface="Segoe UI Light" panose="020B0502040204020203" pitchFamily="34" charset="0"/>
+              </a:rPr>
+              <a:t>🚀 </a:t>
+            </a:r>
+            <a:r>
+              <a:rPr lang="en-US" sz="12800" dirty="0" err="1">
+                <a:solidFill>
+                  <a:srgbClr val="7030A0"/>
+                </a:solidFill>
+                <a:latin typeface="Segoe UI Light" panose="020B0502040204020203" pitchFamily="34" charset="0"/>
+                <a:cs typeface="Segoe UI Light" panose="020B0502040204020203" pitchFamily="34" charset="0"/>
+              </a:rPr>
+              <a:t>WanderAI</a:t>
+            </a:r>
+            <a:r>
+              <a:rPr lang="en-US" sz="12800" dirty="0">
+                <a:solidFill>
+                  <a:srgbClr val="7030A0"/>
+                </a:solidFill>
+                <a:latin typeface="Segoe UI Light" panose="020B0502040204020203" pitchFamily="34" charset="0"/>
+                <a:cs typeface="Segoe UI Light" panose="020B0502040204020203" pitchFamily="34" charset="0"/>
+              </a:rPr>
+              <a:t> - Your Travel Planning Startup</a:t>
+            </a:r>
+          </a:p>
+          <a:p>
+            <a:pPr marL="0" indent="0" algn="ctr">
+              <a:buNone/>
+            </a:pPr>
+            <a:r>
+              <a:rPr lang="en-US" sz="14400" dirty="0">
+                <a:solidFill>
+                  <a:srgbClr val="7030A0"/>
+                </a:solidFill>
+                <a:latin typeface="Segoe UI" panose="020B0502040204020203" pitchFamily="34" charset="0"/>
+                <a:cs typeface="Segoe UI" panose="020B0502040204020203" pitchFamily="34" charset="0"/>
+              </a:rPr>
+              <a:t>Welcome &amp; Intros</a:t>
+            </a:r>
+            <a:endParaRPr lang="en-US" sz="14400" i="1" dirty="0">
+              <a:solidFill>
+                <a:srgbClr val="7030A0"/>
+              </a:solidFill>
+              <a:latin typeface="Segoe UI" panose="020B0502040204020203" pitchFamily="34" charset="0"/>
+              <a:cs typeface="Segoe UI" panose="020B0502040204020203" pitchFamily="34" charset="0"/>
+            </a:endParaRPr>
+          </a:p>
+          <a:p>
+            <a:pPr marL="0" indent="0" algn="ctr">
+              <a:buNone/>
+            </a:pPr>
+            <a:endParaRPr lang="en-US" dirty="0">
+              <a:latin typeface="Segoe UI Light" panose="020B0502040204020203" pitchFamily="34" charset="0"/>
+              <a:cs typeface="Segoe UI Light" panose="020B0502040204020203" pitchFamily="34" charset="0"/>
+            </a:endParaRPr>
+          </a:p>
+        </p:txBody>
+      </p:sp>
+      <p:sp>
+        <p:nvSpPr>
+          <p:cNvPr id="7" name="TextBox 6">
+            <a:extLst>
+              <a:ext uri="{FF2B5EF4-FFF2-40B4-BE49-F238E27FC236}">
+                <a16:creationId xmlns:a16="http://schemas.microsoft.com/office/drawing/2014/main" id="{A2E725C8-3DB9-ED40-B2EB-EC82B1330DC9}"/>
+              </a:ext>
+            </a:extLst>
+          </p:cNvPr>
+          <p:cNvSpPr txBox="1"/>
+          <p:nvPr/>
+        </p:nvSpPr>
+        <p:spPr>
+          <a:xfrm>
+            <a:off x="-1005840" y="901337"/>
+            <a:ext cx="184731" cy="369332"/>
+          </a:xfrm>
+          <a:prstGeom prst="rect">
+            <a:avLst/>
+          </a:prstGeom>
+          <a:noFill/>
+        </p:spPr>
+        <p:txBody>
+          <a:bodyPr wrap="none" rtlCol="0">
+            <a:spAutoFit/>
+          </a:bodyPr>
+          <a:lstStyle/>
+          <a:p>
+            <a:pPr marL="0" marR="0" lvl="0" indent="0" algn="l" defTabSz="914400" rtl="0" eaLnBrk="1" fontAlgn="auto" latinLnBrk="0" hangingPunct="1">
+              <a:lnSpc>
+                <a:spcPct val="100000"/>
+              </a:lnSpc>
+              <a:spcBef>
+                <a:spcPts val="0"/>
+              </a:spcBef>
+              <a:spcAft>
+                <a:spcPts val="0"/>
+              </a:spcAft>
+              <a:buClrTx/>
+              <a:buSzTx/>
+              <a:buFontTx/>
+              <a:buNone/>
+              <a:tabLst/>
+              <a:defRPr/>
+            </a:pPr>
+            <a:endParaRPr kumimoji="0" lang="en-US" sz="1800" b="0" i="0" u="none" strike="noStrike" kern="1200" cap="none" spc="0" normalizeH="0" baseline="0" noProof="0" dirty="0">
+              <a:ln>
+                <a:noFill/>
+              </a:ln>
+              <a:solidFill>
+                <a:prstClr val="black"/>
+              </a:solidFill>
+              <a:effectLst/>
+              <a:uLnTx/>
+              <a:uFillTx/>
+              <a:latin typeface="Calibri" panose="020F0502020204030204"/>
+              <a:ea typeface="+mn-ea"/>
+              <a:cs typeface="+mn-cs"/>
+            </a:endParaRPr>
+          </a:p>
+        </p:txBody>
+      </p:sp>
       <p:sp>
         <p:nvSpPr>
           <p:cNvPr id="12" name="TextBox 11">
@@ -17218,8 +18010,8 @@
 </p:sld>
 </file>
 
-<file path=ppt/slides/slide6.xml><?xml version="1.0" encoding="utf-8"?>
-<p:sld xmlns:a="http://schemas.openxmlformats.org/drawingml/2006/main" xmlns:r="http://schemas.openxmlformats.org/officeDocument/2006/relationships" xmlns:p="http://schemas.openxmlformats.org/presentationml/2006/main">
+<file path=ppt/slides/slide7.xml><?xml version="1.0" encoding="utf-8"?>
+<p:sld xmlns:a="http://schemas.openxmlformats.org/drawingml/2006/main" xmlns:r="http://schemas.openxmlformats.org/officeDocument/2006/relationships" xmlns:p="http://schemas.openxmlformats.org/presentationml/2006/main" show="0">
   <p:cSld>
     <p:spTree>
       <p:nvGrpSpPr>
@@ -17274,59 +18066,6 @@
       </p:sp>
       <p:sp>
         <p:nvSpPr>
-          <p:cNvPr id="4" name="Content Placeholder 3">
-            <a:extLst>
-              <a:ext uri="{FF2B5EF4-FFF2-40B4-BE49-F238E27FC236}">
-                <a16:creationId xmlns:a16="http://schemas.microsoft.com/office/drawing/2014/main" id="{31D3DF15-4403-D489-FA65-6DA8B097E53F}"/>
-              </a:ext>
-            </a:extLst>
-          </p:cNvPr>
-          <p:cNvSpPr>
-            <a:spLocks noGrp="1"/>
-          </p:cNvSpPr>
-          <p:nvPr>
-            <p:ph idx="1"/>
-          </p:nvPr>
-        </p:nvSpPr>
-        <p:spPr/>
-        <p:txBody>
-          <a:bodyPr/>
-          <a:lstStyle/>
-          <a:p>
-            <a:r>
-              <a:rPr lang="en-US" sz="2800" dirty="0">
-                <a:latin typeface="Segoe UI" panose="020B0502040204020203" pitchFamily="34" charset="0"/>
-                <a:cs typeface="Segoe UI" panose="020B0502040204020203" pitchFamily="34" charset="0"/>
-                <a:hlinkClick r:id="rId3"/>
-              </a:rPr>
-              <a:t>Deploy Microsoft Foundry</a:t>
-            </a:r>
-            <a:r>
-              <a:rPr lang="en-US" sz="2800" dirty="0">
-                <a:latin typeface="Segoe UI" panose="020B0502040204020203" pitchFamily="34" charset="0"/>
-                <a:cs typeface="Segoe UI" panose="020B0502040204020203" pitchFamily="34" charset="0"/>
-              </a:rPr>
-              <a:t> (incl. base LLM model)</a:t>
-            </a:r>
-          </a:p>
-          <a:p>
-            <a:r>
-              <a:rPr lang="en-US" sz="2800" dirty="0">
-                <a:latin typeface="Segoe UI" panose="020B0502040204020203" pitchFamily="34" charset="0"/>
-                <a:cs typeface="Segoe UI" panose="020B0502040204020203" pitchFamily="34" charset="0"/>
-                <a:hlinkClick r:id="rId4"/>
-              </a:rPr>
-              <a:t>Deploy Azure Native New Relic Service</a:t>
-            </a:r>
-            <a:endParaRPr lang="en-US" sz="2800" dirty="0">
-              <a:latin typeface="Segoe UI" panose="020B0502040204020203" pitchFamily="34" charset="0"/>
-              <a:cs typeface="Segoe UI" panose="020B0502040204020203" pitchFamily="34" charset="0"/>
-            </a:endParaRPr>
-          </a:p>
-        </p:txBody>
-      </p:sp>
-      <p:sp>
-        <p:nvSpPr>
           <p:cNvPr id="2" name="Text Placeholder 1"/>
           <p:cNvSpPr>
             <a:spLocks noGrp="1"/>
@@ -17335,7 +18074,12 @@
             <p:ph type="body" sz="quarter" idx="13"/>
           </p:nvPr>
         </p:nvSpPr>
-        <p:spPr/>
+        <p:spPr>
+          <a:xfrm>
+            <a:off x="491705" y="1416849"/>
+            <a:ext cx="11189766" cy="614362"/>
+          </a:xfrm>
+        </p:spPr>
         <p:txBody>
           <a:bodyPr>
             <a:normAutofit/>
@@ -17350,7 +18094,7 @@
                 <a:latin typeface="Segoe UI" panose="020B0502040204020203" pitchFamily="34" charset="0"/>
                 <a:cs typeface="Segoe UI" panose="020B0502040204020203" pitchFamily="34" charset="0"/>
               </a:rPr>
-              <a:t>Get your machines ready!</a:t>
+              <a:t>Come up with a name for your team</a:t>
             </a:r>
             <a:endParaRPr lang="en-US" sz="3200" dirty="0">
               <a:latin typeface="Segoe UI" panose="020B0502040204020203" pitchFamily="34" charset="0"/>
@@ -17359,106 +18103,424 @@
           </a:p>
         </p:txBody>
       </p:sp>
+      <p:sp>
+        <p:nvSpPr>
+          <p:cNvPr id="8" name="Content Placeholder 3">
+            <a:extLst>
+              <a:ext uri="{FF2B5EF4-FFF2-40B4-BE49-F238E27FC236}">
+                <a16:creationId xmlns:a16="http://schemas.microsoft.com/office/drawing/2014/main" id="{D20E6E32-0425-DE55-5F7E-D3ED4136C200}"/>
+              </a:ext>
+            </a:extLst>
+          </p:cNvPr>
+          <p:cNvSpPr txBox="1">
+            <a:spLocks/>
+          </p:cNvSpPr>
+          <p:nvPr/>
+        </p:nvSpPr>
+        <p:spPr>
+          <a:xfrm>
+            <a:off x="848436" y="3700212"/>
+            <a:ext cx="10515600" cy="1381028"/>
+          </a:xfrm>
+          <a:prstGeom prst="rect">
+            <a:avLst/>
+          </a:prstGeom>
+        </p:spPr>
+        <p:txBody>
+          <a:bodyPr vert="horz" lIns="91440" tIns="45720" rIns="91440" bIns="45720" rtlCol="0">
+            <a:normAutofit/>
+          </a:bodyPr>
+          <a:lstStyle>
+            <a:lvl1pPr marL="228600" indent="-228600" algn="l" defTabSz="914400" rtl="0" eaLnBrk="1" latinLnBrk="0" hangingPunct="1">
+              <a:lnSpc>
+                <a:spcPct val="90000"/>
+              </a:lnSpc>
+              <a:spcBef>
+                <a:spcPts val="1000"/>
+              </a:spcBef>
+              <a:buFont typeface="Arial" panose="020B0604020202020204" pitchFamily="34" charset="0"/>
+              <a:buChar char="•"/>
+              <a:defRPr sz="2800" kern="1200">
+                <a:solidFill>
+                  <a:schemeClr val="tx1"/>
+                </a:solidFill>
+                <a:latin typeface="Segoe UI" panose="020B0502040204020203" pitchFamily="34" charset="0"/>
+                <a:ea typeface="+mn-ea"/>
+                <a:cs typeface="Segoe UI" panose="020B0502040204020203" pitchFamily="34" charset="0"/>
+              </a:defRPr>
+            </a:lvl1pPr>
+            <a:lvl2pPr marL="685800" indent="-228600" algn="l" defTabSz="914400" rtl="0" eaLnBrk="1" latinLnBrk="0" hangingPunct="1">
+              <a:lnSpc>
+                <a:spcPct val="90000"/>
+              </a:lnSpc>
+              <a:spcBef>
+                <a:spcPts val="500"/>
+              </a:spcBef>
+              <a:buFont typeface="Arial" panose="020B0604020202020204" pitchFamily="34" charset="0"/>
+              <a:buChar char="•"/>
+              <a:defRPr sz="2400" kern="1200">
+                <a:solidFill>
+                  <a:schemeClr val="tx1"/>
+                </a:solidFill>
+                <a:latin typeface="Segoe UI" panose="020B0502040204020203" pitchFamily="34" charset="0"/>
+                <a:ea typeface="+mn-ea"/>
+                <a:cs typeface="Segoe UI" panose="020B0502040204020203" pitchFamily="34" charset="0"/>
+              </a:defRPr>
+            </a:lvl2pPr>
+            <a:lvl3pPr marL="1143000" indent="-228600" algn="l" defTabSz="914400" rtl="0" eaLnBrk="1" latinLnBrk="0" hangingPunct="1">
+              <a:lnSpc>
+                <a:spcPct val="90000"/>
+              </a:lnSpc>
+              <a:spcBef>
+                <a:spcPts val="500"/>
+              </a:spcBef>
+              <a:buFont typeface="Arial" panose="020B0604020202020204" pitchFamily="34" charset="0"/>
+              <a:buChar char="•"/>
+              <a:defRPr sz="2000" kern="1200">
+                <a:solidFill>
+                  <a:schemeClr val="tx1"/>
+                </a:solidFill>
+                <a:latin typeface="Segoe UI" panose="020B0502040204020203" pitchFamily="34" charset="0"/>
+                <a:ea typeface="+mn-ea"/>
+                <a:cs typeface="Segoe UI" panose="020B0502040204020203" pitchFamily="34" charset="0"/>
+              </a:defRPr>
+            </a:lvl3pPr>
+            <a:lvl4pPr marL="1600200" indent="-228600" algn="l" defTabSz="914400" rtl="0" eaLnBrk="1" latinLnBrk="0" hangingPunct="1">
+              <a:lnSpc>
+                <a:spcPct val="90000"/>
+              </a:lnSpc>
+              <a:spcBef>
+                <a:spcPts val="500"/>
+              </a:spcBef>
+              <a:buFont typeface="Arial" panose="020B0604020202020204" pitchFamily="34" charset="0"/>
+              <a:buChar char="•"/>
+              <a:defRPr sz="1800" kern="1200">
+                <a:solidFill>
+                  <a:schemeClr val="tx1"/>
+                </a:solidFill>
+                <a:latin typeface="Segoe UI" panose="020B0502040204020203" pitchFamily="34" charset="0"/>
+                <a:ea typeface="+mn-ea"/>
+                <a:cs typeface="Segoe UI" panose="020B0502040204020203" pitchFamily="34" charset="0"/>
+              </a:defRPr>
+            </a:lvl4pPr>
+            <a:lvl5pPr marL="2057400" indent="-228600" algn="l" defTabSz="914400" rtl="0" eaLnBrk="1" latinLnBrk="0" hangingPunct="1">
+              <a:lnSpc>
+                <a:spcPct val="90000"/>
+              </a:lnSpc>
+              <a:spcBef>
+                <a:spcPts val="500"/>
+              </a:spcBef>
+              <a:buFont typeface="Arial" panose="020B0604020202020204" pitchFamily="34" charset="0"/>
+              <a:buChar char="•"/>
+              <a:defRPr sz="1800" kern="1200">
+                <a:solidFill>
+                  <a:schemeClr val="tx1"/>
+                </a:solidFill>
+                <a:latin typeface="Segoe UI" panose="020B0502040204020203" pitchFamily="34" charset="0"/>
+                <a:ea typeface="+mn-ea"/>
+                <a:cs typeface="Segoe UI" panose="020B0502040204020203" pitchFamily="34" charset="0"/>
+              </a:defRPr>
+            </a:lvl5pPr>
+            <a:lvl6pPr marL="2514600" indent="-228600" algn="l" defTabSz="914400" rtl="0" eaLnBrk="1" latinLnBrk="0" hangingPunct="1">
+              <a:lnSpc>
+                <a:spcPct val="90000"/>
+              </a:lnSpc>
+              <a:spcBef>
+                <a:spcPts val="500"/>
+              </a:spcBef>
+              <a:buFont typeface="Arial" panose="020B0604020202020204" pitchFamily="34" charset="0"/>
+              <a:buChar char="•"/>
+              <a:defRPr sz="1800" kern="1200">
+                <a:solidFill>
+                  <a:schemeClr val="tx1"/>
+                </a:solidFill>
+                <a:latin typeface="+mn-lt"/>
+                <a:ea typeface="+mn-ea"/>
+                <a:cs typeface="+mn-cs"/>
+              </a:defRPr>
+            </a:lvl6pPr>
+            <a:lvl7pPr marL="2971800" indent="-228600" algn="l" defTabSz="914400" rtl="0" eaLnBrk="1" latinLnBrk="0" hangingPunct="1">
+              <a:lnSpc>
+                <a:spcPct val="90000"/>
+              </a:lnSpc>
+              <a:spcBef>
+                <a:spcPts val="500"/>
+              </a:spcBef>
+              <a:buFont typeface="Arial" panose="020B0604020202020204" pitchFamily="34" charset="0"/>
+              <a:buChar char="•"/>
+              <a:defRPr sz="1800" kern="1200">
+                <a:solidFill>
+                  <a:schemeClr val="tx1"/>
+                </a:solidFill>
+                <a:latin typeface="+mn-lt"/>
+                <a:ea typeface="+mn-ea"/>
+                <a:cs typeface="+mn-cs"/>
+              </a:defRPr>
+            </a:lvl7pPr>
+            <a:lvl8pPr marL="3429000" indent="-228600" algn="l" defTabSz="914400" rtl="0" eaLnBrk="1" latinLnBrk="0" hangingPunct="1">
+              <a:lnSpc>
+                <a:spcPct val="90000"/>
+              </a:lnSpc>
+              <a:spcBef>
+                <a:spcPts val="500"/>
+              </a:spcBef>
+              <a:buFont typeface="Arial" panose="020B0604020202020204" pitchFamily="34" charset="0"/>
+              <a:buChar char="•"/>
+              <a:defRPr sz="1800" kern="1200">
+                <a:solidFill>
+                  <a:schemeClr val="tx1"/>
+                </a:solidFill>
+                <a:latin typeface="+mn-lt"/>
+                <a:ea typeface="+mn-ea"/>
+                <a:cs typeface="+mn-cs"/>
+              </a:defRPr>
+            </a:lvl8pPr>
+            <a:lvl9pPr marL="3886200" indent="-228600" algn="l" defTabSz="914400" rtl="0" eaLnBrk="1" latinLnBrk="0" hangingPunct="1">
+              <a:lnSpc>
+                <a:spcPct val="90000"/>
+              </a:lnSpc>
+              <a:spcBef>
+                <a:spcPts val="500"/>
+              </a:spcBef>
+              <a:buFont typeface="Arial" panose="020B0604020202020204" pitchFamily="34" charset="0"/>
+              <a:buChar char="•"/>
+              <a:defRPr sz="1800" kern="1200">
+                <a:solidFill>
+                  <a:schemeClr val="tx1"/>
+                </a:solidFill>
+                <a:latin typeface="+mn-lt"/>
+                <a:ea typeface="+mn-ea"/>
+                <a:cs typeface="+mn-cs"/>
+              </a:defRPr>
+            </a:lvl9pPr>
+          </a:lstStyle>
+          <a:p>
+            <a:r>
+              <a:rPr lang="en-US">
+                <a:hlinkClick r:id="rId3"/>
+              </a:rPr>
+              <a:t>Deploy Microsoft Foundry</a:t>
+            </a:r>
+            <a:r>
+              <a:rPr lang="en-US"/>
+              <a:t> (incl. base LLM model)</a:t>
+            </a:r>
+          </a:p>
+          <a:p>
+            <a:r>
+              <a:rPr lang="en-US">
+                <a:hlinkClick r:id="rId4"/>
+              </a:rPr>
+              <a:t>Deploy Azure Native New Relic Service</a:t>
+            </a:r>
+            <a:endParaRPr lang="en-US" dirty="0"/>
+          </a:p>
+        </p:txBody>
+      </p:sp>
+      <p:sp>
+        <p:nvSpPr>
+          <p:cNvPr id="9" name="Text Placeholder 1">
+            <a:extLst>
+              <a:ext uri="{FF2B5EF4-FFF2-40B4-BE49-F238E27FC236}">
+                <a16:creationId xmlns:a16="http://schemas.microsoft.com/office/drawing/2014/main" id="{2F613304-419A-D9E4-2AC0-26D6349EA341}"/>
+              </a:ext>
+            </a:extLst>
+          </p:cNvPr>
+          <p:cNvSpPr txBox="1">
+            <a:spLocks/>
+          </p:cNvSpPr>
+          <p:nvPr/>
+        </p:nvSpPr>
+        <p:spPr>
+          <a:xfrm>
+            <a:off x="491705" y="2918548"/>
+            <a:ext cx="11189766" cy="614362"/>
+          </a:xfrm>
+          <a:prstGeom prst="rect">
+            <a:avLst/>
+          </a:prstGeom>
+        </p:spPr>
+        <p:txBody>
+          <a:bodyPr vert="horz" lIns="91440" tIns="45720" rIns="91440" bIns="45720" rtlCol="0">
+            <a:normAutofit/>
+          </a:bodyPr>
+          <a:lstStyle>
+            <a:lvl1pPr marL="0" indent="0" algn="l" defTabSz="914400" rtl="0" eaLnBrk="1" latinLnBrk="0" hangingPunct="1">
+              <a:lnSpc>
+                <a:spcPct val="90000"/>
+              </a:lnSpc>
+              <a:spcBef>
+                <a:spcPts val="1000"/>
+              </a:spcBef>
+              <a:buFont typeface="Arial" panose="020B0604020202020204" pitchFamily="34" charset="0"/>
+              <a:buNone/>
+              <a:defRPr sz="3200" b="1" kern="1200">
+                <a:solidFill>
+                  <a:srgbClr val="7030A0"/>
+                </a:solidFill>
+                <a:latin typeface="Segoe UI" panose="020B0502040204020203" pitchFamily="34" charset="0"/>
+                <a:ea typeface="+mn-ea"/>
+                <a:cs typeface="Segoe UI" panose="020B0502040204020203" pitchFamily="34" charset="0"/>
+              </a:defRPr>
+            </a:lvl1pPr>
+            <a:lvl2pPr marL="685800" indent="-228600" algn="l" defTabSz="914400" rtl="0" eaLnBrk="1" latinLnBrk="0" hangingPunct="1">
+              <a:lnSpc>
+                <a:spcPct val="90000"/>
+              </a:lnSpc>
+              <a:spcBef>
+                <a:spcPts val="500"/>
+              </a:spcBef>
+              <a:buFont typeface="Arial" panose="020B0604020202020204" pitchFamily="34" charset="0"/>
+              <a:buChar char="•"/>
+              <a:defRPr sz="2400" kern="1200">
+                <a:solidFill>
+                  <a:schemeClr val="tx1"/>
+                </a:solidFill>
+                <a:latin typeface="Segoe UI" panose="020B0502040204020203" pitchFamily="34" charset="0"/>
+                <a:ea typeface="+mn-ea"/>
+                <a:cs typeface="Segoe UI" panose="020B0502040204020203" pitchFamily="34" charset="0"/>
+              </a:defRPr>
+            </a:lvl2pPr>
+            <a:lvl3pPr marL="1143000" indent="-228600" algn="l" defTabSz="914400" rtl="0" eaLnBrk="1" latinLnBrk="0" hangingPunct="1">
+              <a:lnSpc>
+                <a:spcPct val="90000"/>
+              </a:lnSpc>
+              <a:spcBef>
+                <a:spcPts val="500"/>
+              </a:spcBef>
+              <a:buFont typeface="Arial" panose="020B0604020202020204" pitchFamily="34" charset="0"/>
+              <a:buChar char="•"/>
+              <a:defRPr sz="2000" kern="1200">
+                <a:solidFill>
+                  <a:schemeClr val="tx1"/>
+                </a:solidFill>
+                <a:latin typeface="Segoe UI" panose="020B0502040204020203" pitchFamily="34" charset="0"/>
+                <a:ea typeface="+mn-ea"/>
+                <a:cs typeface="Segoe UI" panose="020B0502040204020203" pitchFamily="34" charset="0"/>
+              </a:defRPr>
+            </a:lvl3pPr>
+            <a:lvl4pPr marL="1600200" indent="-228600" algn="l" defTabSz="914400" rtl="0" eaLnBrk="1" latinLnBrk="0" hangingPunct="1">
+              <a:lnSpc>
+                <a:spcPct val="90000"/>
+              </a:lnSpc>
+              <a:spcBef>
+                <a:spcPts val="500"/>
+              </a:spcBef>
+              <a:buFont typeface="Arial" panose="020B0604020202020204" pitchFamily="34" charset="0"/>
+              <a:buChar char="•"/>
+              <a:defRPr sz="1800" kern="1200">
+                <a:solidFill>
+                  <a:schemeClr val="tx1"/>
+                </a:solidFill>
+                <a:latin typeface="Segoe UI" panose="020B0502040204020203" pitchFamily="34" charset="0"/>
+                <a:ea typeface="+mn-ea"/>
+                <a:cs typeface="Segoe UI" panose="020B0502040204020203" pitchFamily="34" charset="0"/>
+              </a:defRPr>
+            </a:lvl4pPr>
+            <a:lvl5pPr marL="2057400" indent="-228600" algn="l" defTabSz="914400" rtl="0" eaLnBrk="1" latinLnBrk="0" hangingPunct="1">
+              <a:lnSpc>
+                <a:spcPct val="90000"/>
+              </a:lnSpc>
+              <a:spcBef>
+                <a:spcPts val="500"/>
+              </a:spcBef>
+              <a:buFont typeface="Arial" panose="020B0604020202020204" pitchFamily="34" charset="0"/>
+              <a:buChar char="•"/>
+              <a:defRPr sz="1800" kern="1200">
+                <a:solidFill>
+                  <a:schemeClr val="tx1"/>
+                </a:solidFill>
+                <a:latin typeface="Segoe UI" panose="020B0502040204020203" pitchFamily="34" charset="0"/>
+                <a:ea typeface="+mn-ea"/>
+                <a:cs typeface="Segoe UI" panose="020B0502040204020203" pitchFamily="34" charset="0"/>
+              </a:defRPr>
+            </a:lvl5pPr>
+            <a:lvl6pPr marL="2514600" indent="-228600" algn="l" defTabSz="914400" rtl="0" eaLnBrk="1" latinLnBrk="0" hangingPunct="1">
+              <a:lnSpc>
+                <a:spcPct val="90000"/>
+              </a:lnSpc>
+              <a:spcBef>
+                <a:spcPts val="500"/>
+              </a:spcBef>
+              <a:buFont typeface="Arial" panose="020B0604020202020204" pitchFamily="34" charset="0"/>
+              <a:buChar char="•"/>
+              <a:defRPr sz="1800" kern="1200">
+                <a:solidFill>
+                  <a:schemeClr val="tx1"/>
+                </a:solidFill>
+                <a:latin typeface="+mn-lt"/>
+                <a:ea typeface="+mn-ea"/>
+                <a:cs typeface="+mn-cs"/>
+              </a:defRPr>
+            </a:lvl6pPr>
+            <a:lvl7pPr marL="2971800" indent="-228600" algn="l" defTabSz="914400" rtl="0" eaLnBrk="1" latinLnBrk="0" hangingPunct="1">
+              <a:lnSpc>
+                <a:spcPct val="90000"/>
+              </a:lnSpc>
+              <a:spcBef>
+                <a:spcPts val="500"/>
+              </a:spcBef>
+              <a:buFont typeface="Arial" panose="020B0604020202020204" pitchFamily="34" charset="0"/>
+              <a:buChar char="•"/>
+              <a:defRPr sz="1800" kern="1200">
+                <a:solidFill>
+                  <a:schemeClr val="tx1"/>
+                </a:solidFill>
+                <a:latin typeface="+mn-lt"/>
+                <a:ea typeface="+mn-ea"/>
+                <a:cs typeface="+mn-cs"/>
+              </a:defRPr>
+            </a:lvl7pPr>
+            <a:lvl8pPr marL="3429000" indent="-228600" algn="l" defTabSz="914400" rtl="0" eaLnBrk="1" latinLnBrk="0" hangingPunct="1">
+              <a:lnSpc>
+                <a:spcPct val="90000"/>
+              </a:lnSpc>
+              <a:spcBef>
+                <a:spcPts val="500"/>
+              </a:spcBef>
+              <a:buFont typeface="Arial" panose="020B0604020202020204" pitchFamily="34" charset="0"/>
+              <a:buChar char="•"/>
+              <a:defRPr sz="1800" kern="1200">
+                <a:solidFill>
+                  <a:schemeClr val="tx1"/>
+                </a:solidFill>
+                <a:latin typeface="+mn-lt"/>
+                <a:ea typeface="+mn-ea"/>
+                <a:cs typeface="+mn-cs"/>
+              </a:defRPr>
+            </a:lvl8pPr>
+            <a:lvl9pPr marL="3886200" indent="-228600" algn="l" defTabSz="914400" rtl="0" eaLnBrk="1" latinLnBrk="0" hangingPunct="1">
+              <a:lnSpc>
+                <a:spcPct val="90000"/>
+              </a:lnSpc>
+              <a:spcBef>
+                <a:spcPts val="500"/>
+              </a:spcBef>
+              <a:buFont typeface="Arial" panose="020B0604020202020204" pitchFamily="34" charset="0"/>
+              <a:buChar char="•"/>
+              <a:defRPr sz="1800" kern="1200">
+                <a:solidFill>
+                  <a:schemeClr val="tx1"/>
+                </a:solidFill>
+                <a:latin typeface="+mn-lt"/>
+                <a:ea typeface="+mn-ea"/>
+                <a:cs typeface="+mn-cs"/>
+              </a:defRPr>
+            </a:lvl9pPr>
+          </a:lstStyle>
+          <a:p>
+            <a:r>
+              <a:rPr lang="en-US"/>
+              <a:t>Get your environments ready!</a:t>
+            </a:r>
+            <a:endParaRPr lang="en-US" dirty="0"/>
+          </a:p>
+        </p:txBody>
+      </p:sp>
     </p:spTree>
     <p:extLst>
       <p:ext uri="{BB962C8B-B14F-4D97-AF65-F5344CB8AC3E}">
         <p14:creationId xmlns:p14="http://schemas.microsoft.com/office/powerpoint/2010/main" val="4086393502"/>
-      </p:ext>
-    </p:extLst>
-  </p:cSld>
-  <p:clrMapOvr>
-    <a:masterClrMapping/>
-  </p:clrMapOvr>
-</p:sld>
-</file>
-
-<file path=ppt/slides/slide7.xml><?xml version="1.0" encoding="utf-8"?>
-<p:sld xmlns:a="http://schemas.openxmlformats.org/drawingml/2006/main" xmlns:r="http://schemas.openxmlformats.org/officeDocument/2006/relationships" xmlns:p="http://schemas.openxmlformats.org/presentationml/2006/main">
-  <p:cSld>
-    <p:spTree>
-      <p:nvGrpSpPr>
-        <p:cNvPr id="1" name=""/>
-        <p:cNvGrpSpPr/>
-        <p:nvPr/>
-      </p:nvGrpSpPr>
-      <p:grpSpPr>
-        <a:xfrm>
-          <a:off x="0" y="0"/>
-          <a:ext cx="0" cy="0"/>
-          <a:chOff x="0" y="0"/>
-          <a:chExt cx="0" cy="0"/>
-        </a:xfrm>
-      </p:grpSpPr>
-      <p:sp>
-        <p:nvSpPr>
-          <p:cNvPr id="2" name="Title 1">
-            <a:extLst>
-              <a:ext uri="{FF2B5EF4-FFF2-40B4-BE49-F238E27FC236}">
-                <a16:creationId xmlns:a16="http://schemas.microsoft.com/office/drawing/2014/main" id="{B0B3C1D8-997A-3307-B567-5C31F43276DE}"/>
-              </a:ext>
-            </a:extLst>
-          </p:cNvPr>
-          <p:cNvSpPr>
-            <a:spLocks noGrp="1"/>
-          </p:cNvSpPr>
-          <p:nvPr>
-            <p:ph type="title"/>
-          </p:nvPr>
-        </p:nvSpPr>
-        <p:spPr/>
-        <p:txBody>
-          <a:bodyPr anchor="t" anchorCtr="0"/>
-          <a:lstStyle/>
-          <a:p>
-            <a:r>
-              <a:rPr lang="en-US" dirty="0"/>
-              <a:t>Challenge 1</a:t>
-            </a:r>
-            <a:br>
-              <a:rPr lang="en-US" dirty="0"/>
-            </a:br>
-            <a:r>
-              <a:rPr lang="en-US" dirty="0"/>
-              <a:t>- Master the Foundations</a:t>
-            </a:r>
-          </a:p>
-        </p:txBody>
-      </p:sp>
-      <p:sp>
-        <p:nvSpPr>
-          <p:cNvPr id="3" name="Text Placeholder 2">
-            <a:extLst>
-              <a:ext uri="{FF2B5EF4-FFF2-40B4-BE49-F238E27FC236}">
-                <a16:creationId xmlns:a16="http://schemas.microsoft.com/office/drawing/2014/main" id="{2F3AC27F-55BE-EAA1-2E0E-6E854A75AFEC}"/>
-              </a:ext>
-            </a:extLst>
-          </p:cNvPr>
-          <p:cNvSpPr>
-            <a:spLocks noGrp="1"/>
-          </p:cNvSpPr>
-          <p:nvPr>
-            <p:ph type="body" idx="1"/>
-          </p:nvPr>
-        </p:nvSpPr>
-        <p:spPr/>
-        <p:txBody>
-          <a:bodyPr>
-            <a:normAutofit/>
-          </a:bodyPr>
-          <a:lstStyle/>
-          <a:p>
-            <a:pPr algn="ctr"/>
-            <a:r>
-              <a:rPr lang="en-US" dirty="0"/>
-              <a:t>What makes an AI agent tick?</a:t>
-            </a:r>
-          </a:p>
-        </p:txBody>
-      </p:sp>
-    </p:spTree>
-    <p:extLst>
-      <p:ext uri="{BB962C8B-B14F-4D97-AF65-F5344CB8AC3E}">
-        <p14:creationId xmlns:p14="http://schemas.microsoft.com/office/powerpoint/2010/main" val="2990754167"/>
       </p:ext>
     </p:extLst>
   </p:cSld>
@@ -17487,163 +18549,74 @@
       </p:grpSpPr>
       <p:sp>
         <p:nvSpPr>
-          <p:cNvPr id="3" name="Content Placeholder 2">
-            <a:extLst>
-              <a:ext uri="{FF2B5EF4-FFF2-40B4-BE49-F238E27FC236}">
-                <a16:creationId xmlns:a16="http://schemas.microsoft.com/office/drawing/2014/main" id="{17DBF992-46E2-4A48-9C03-B9E15BA5EC83}"/>
-              </a:ext>
-            </a:extLst>
-          </p:cNvPr>
-          <p:cNvSpPr>
-            <a:spLocks noGrp="1"/>
-          </p:cNvSpPr>
-          <p:nvPr>
-            <p:ph idx="1"/>
+          <p:cNvPr id="2" name="Title 1">
+            <a:extLst>
+              <a:ext uri="{FF2B5EF4-FFF2-40B4-BE49-F238E27FC236}">
+                <a16:creationId xmlns:a16="http://schemas.microsoft.com/office/drawing/2014/main" id="{B0B3C1D8-997A-3307-B567-5C31F43276DE}"/>
+              </a:ext>
+            </a:extLst>
+          </p:cNvPr>
+          <p:cNvSpPr>
+            <a:spLocks noGrp="1"/>
+          </p:cNvSpPr>
+          <p:nvPr>
+            <p:ph type="title"/>
           </p:nvPr>
         </p:nvSpPr>
         <p:spPr/>
         <p:txBody>
+          <a:bodyPr anchor="t" anchorCtr="0"/>
+          <a:lstStyle/>
+          <a:p>
+            <a:r>
+              <a:rPr lang="en-US" dirty="0"/>
+              <a:t>Challenge 1</a:t>
+            </a:r>
+            <a:br>
+              <a:rPr lang="en-US" dirty="0"/>
+            </a:br>
+            <a:r>
+              <a:rPr lang="en-US" dirty="0"/>
+              <a:t>- Master the Foundations</a:t>
+            </a:r>
+          </a:p>
+        </p:txBody>
+      </p:sp>
+      <p:sp>
+        <p:nvSpPr>
+          <p:cNvPr id="3" name="Text Placeholder 2">
+            <a:extLst>
+              <a:ext uri="{FF2B5EF4-FFF2-40B4-BE49-F238E27FC236}">
+                <a16:creationId xmlns:a16="http://schemas.microsoft.com/office/drawing/2014/main" id="{2F3AC27F-55BE-EAA1-2E0E-6E854A75AFEC}"/>
+              </a:ext>
+            </a:extLst>
+          </p:cNvPr>
+          <p:cNvSpPr>
+            <a:spLocks noGrp="1"/>
+          </p:cNvSpPr>
+          <p:nvPr>
+            <p:ph type="body" idx="1"/>
+          </p:nvPr>
+        </p:nvSpPr>
+        <p:spPr/>
+        <p:txBody>
           <a:bodyPr>
-            <a:normAutofit fontScale="92500" lnSpcReduction="20000"/>
+            <a:normAutofit/>
           </a:bodyPr>
           <a:lstStyle/>
           <a:p>
-            <a:pPr marL="0" indent="0">
-              <a:buNone/>
-            </a:pPr>
-            <a:r>
-              <a:rPr lang="en-US" dirty="0">
-                <a:latin typeface="Segoe UI" panose="020B0502040204020203" pitchFamily="34" charset="0"/>
-                <a:cs typeface="Segoe UI" panose="020B0502040204020203" pitchFamily="34" charset="0"/>
-              </a:rPr>
-              <a:t>Before you start building </a:t>
-            </a:r>
-            <a:r>
-              <a:rPr lang="en-US" dirty="0" err="1">
-                <a:latin typeface="Segoe UI" panose="020B0502040204020203" pitchFamily="34" charset="0"/>
-                <a:cs typeface="Segoe UI" panose="020B0502040204020203" pitchFamily="34" charset="0"/>
-              </a:rPr>
-              <a:t>WanderAI's</a:t>
-            </a:r>
-            <a:r>
-              <a:rPr lang="en-US" dirty="0">
-                <a:latin typeface="Segoe UI" panose="020B0502040204020203" pitchFamily="34" charset="0"/>
-                <a:cs typeface="Segoe UI" panose="020B0502040204020203" pitchFamily="34" charset="0"/>
-              </a:rPr>
-              <a:t> AI agents, you need to understand the core concepts that power them. This challenge focuses on building your foundational knowledge of AI agents, the Microsoft Agent Framework, and observability concepts.</a:t>
-            </a:r>
-          </a:p>
-          <a:p>
-            <a:pPr marL="0" indent="0">
-              <a:buNone/>
-            </a:pPr>
-            <a:endParaRPr lang="en-US" dirty="0">
-              <a:latin typeface="Segoe UI" panose="020B0502040204020203" pitchFamily="34" charset="0"/>
-              <a:cs typeface="Segoe UI" panose="020B0502040204020203" pitchFamily="34" charset="0"/>
-            </a:endParaRPr>
-          </a:p>
-          <a:p>
-            <a:pPr marL="0" indent="0">
-              <a:buNone/>
-            </a:pPr>
-            <a:r>
-              <a:rPr lang="en-US" dirty="0">
-                <a:latin typeface="Segoe UI" panose="020B0502040204020203" pitchFamily="34" charset="0"/>
-                <a:cs typeface="Segoe UI" panose="020B0502040204020203" pitchFamily="34" charset="0"/>
-              </a:rPr>
-              <a:t>An AI agent is different from a simple LLM API call. While a direct API call just sends a prompt and receives a response, an agent can reason about problems, decide when to use external tools, and orchestrate multiple steps to accomplish complex tasks. Understanding this distinction is crucial for building effective AI-powered applications.</a:t>
-            </a:r>
-          </a:p>
-          <a:p>
-            <a:pPr marL="0" indent="0">
-              <a:buNone/>
-            </a:pPr>
-            <a:endParaRPr lang="en-US" dirty="0">
-              <a:latin typeface="Segoe UI" panose="020B0502040204020203" pitchFamily="34" charset="0"/>
-              <a:cs typeface="Segoe UI" panose="020B0502040204020203" pitchFamily="34" charset="0"/>
-            </a:endParaRPr>
-          </a:p>
-          <a:p>
-            <a:pPr marL="0" indent="0">
-              <a:buNone/>
-            </a:pPr>
-            <a:r>
-              <a:rPr lang="en-US" dirty="0">
-                <a:latin typeface="Segoe UI" panose="020B0502040204020203" pitchFamily="34" charset="0"/>
-                <a:cs typeface="Segoe UI" panose="020B0502040204020203" pitchFamily="34" charset="0"/>
-              </a:rPr>
-              <a:t>In this challenge, you will study the Microsoft Agent Framework documentation and learn about tool calling, agent lifecycles, and why observability matters for AI systems.</a:t>
-            </a:r>
-          </a:p>
-        </p:txBody>
-      </p:sp>
-      <p:sp>
-        <p:nvSpPr>
-          <p:cNvPr id="4" name="Text Placeholder 3">
-            <a:extLst>
-              <a:ext uri="{FF2B5EF4-FFF2-40B4-BE49-F238E27FC236}">
-                <a16:creationId xmlns:a16="http://schemas.microsoft.com/office/drawing/2014/main" id="{91051B93-082E-F159-F4B6-DDC0E3942FE4}"/>
-              </a:ext>
-            </a:extLst>
-          </p:cNvPr>
-          <p:cNvSpPr>
-            <a:spLocks noGrp="1"/>
-          </p:cNvSpPr>
-          <p:nvPr>
-            <p:ph type="body" sz="quarter" idx="13"/>
-          </p:nvPr>
-        </p:nvSpPr>
-        <p:spPr/>
-        <p:txBody>
-          <a:bodyPr/>
-          <a:lstStyle/>
-          <a:p>
-            <a:r>
-              <a:rPr lang="en-US" sz="3200" b="1" dirty="0">
-                <a:solidFill>
-                  <a:srgbClr val="7030A0"/>
-                </a:solidFill>
-                <a:latin typeface="Segoe UI" panose="020B0502040204020203" pitchFamily="34" charset="0"/>
-                <a:cs typeface="Segoe UI" panose="020B0502040204020203" pitchFamily="34" charset="0"/>
-              </a:rPr>
-              <a:t>Master the Foundations – What makes an AI agent tick?</a:t>
-            </a:r>
-          </a:p>
-        </p:txBody>
-      </p:sp>
-      <p:sp>
-        <p:nvSpPr>
-          <p:cNvPr id="6" name="Title 5">
-            <a:extLst>
-              <a:ext uri="{FF2B5EF4-FFF2-40B4-BE49-F238E27FC236}">
-                <a16:creationId xmlns:a16="http://schemas.microsoft.com/office/drawing/2014/main" id="{C9A2E726-F8FE-9287-6F4A-257C69570E5B}"/>
-              </a:ext>
-            </a:extLst>
-          </p:cNvPr>
-          <p:cNvSpPr>
-            <a:spLocks noGrp="1"/>
-          </p:cNvSpPr>
-          <p:nvPr>
-            <p:ph type="title"/>
-          </p:nvPr>
-        </p:nvSpPr>
-        <p:spPr/>
-        <p:txBody>
-          <a:bodyPr/>
-          <a:lstStyle/>
-          <a:p>
-            <a:r>
-              <a:rPr lang="en-GB" dirty="0"/>
-              <a:t>Challenge #1</a:t>
-            </a:r>
-            <a:endParaRPr lang="en-DE" dirty="0"/>
+            <a:pPr algn="ctr"/>
+            <a:r>
+              <a:rPr lang="en-US" dirty="0"/>
+              <a:t>What makes an AI agent tick?</a:t>
+            </a:r>
           </a:p>
         </p:txBody>
       </p:sp>
     </p:spTree>
     <p:extLst>
       <p:ext uri="{BB962C8B-B14F-4D97-AF65-F5344CB8AC3E}">
-        <p14:creationId xmlns:p14="http://schemas.microsoft.com/office/powerpoint/2010/main" val="2240261495"/>
+        <p14:creationId xmlns:p14="http://schemas.microsoft.com/office/powerpoint/2010/main" val="2990754167"/>
       </p:ext>
     </p:extLst>
   </p:cSld>
@@ -17672,325 +18645,163 @@
       </p:grpSpPr>
       <p:sp>
         <p:nvSpPr>
-          <p:cNvPr id="3" name="Title 2"/>
-          <p:cNvSpPr>
-            <a:spLocks noGrp="1"/>
-          </p:cNvSpPr>
-          <p:nvPr>
-            <p:ph type="title"/>
+          <p:cNvPr id="3" name="Content Placeholder 2">
+            <a:extLst>
+              <a:ext uri="{FF2B5EF4-FFF2-40B4-BE49-F238E27FC236}">
+                <a16:creationId xmlns:a16="http://schemas.microsoft.com/office/drawing/2014/main" id="{17DBF992-46E2-4A48-9C03-B9E15BA5EC83}"/>
+              </a:ext>
+            </a:extLst>
+          </p:cNvPr>
+          <p:cNvSpPr>
+            <a:spLocks noGrp="1"/>
+          </p:cNvSpPr>
+          <p:nvPr>
+            <p:ph idx="1"/>
           </p:nvPr>
         </p:nvSpPr>
         <p:spPr/>
         <p:txBody>
           <a:bodyPr>
-            <a:normAutofit/>
+            <a:normAutofit fontScale="92500" lnSpcReduction="20000"/>
           </a:bodyPr>
           <a:lstStyle/>
           <a:p>
-            <a:r>
-              <a:rPr lang="en-US" sz="5400" b="1" dirty="0">
+            <a:pPr marL="0" indent="0">
+              <a:buNone/>
+            </a:pPr>
+            <a:r>
+              <a:rPr lang="en-US" dirty="0">
+                <a:latin typeface="Segoe UI" panose="020B0502040204020203" pitchFamily="34" charset="0"/>
+                <a:cs typeface="Segoe UI" panose="020B0502040204020203" pitchFamily="34" charset="0"/>
+              </a:rPr>
+              <a:t>Before you start building </a:t>
+            </a:r>
+            <a:r>
+              <a:rPr lang="en-US" dirty="0" err="1">
+                <a:latin typeface="Segoe UI" panose="020B0502040204020203" pitchFamily="34" charset="0"/>
+                <a:cs typeface="Segoe UI" panose="020B0502040204020203" pitchFamily="34" charset="0"/>
+              </a:rPr>
+              <a:t>WanderAI's</a:t>
+            </a:r>
+            <a:r>
+              <a:rPr lang="en-US" dirty="0">
+                <a:latin typeface="Segoe UI" panose="020B0502040204020203" pitchFamily="34" charset="0"/>
+                <a:cs typeface="Segoe UI" panose="020B0502040204020203" pitchFamily="34" charset="0"/>
+              </a:rPr>
+              <a:t> AI agents, you need to understand the core concepts that power them. This challenge focuses on building your foundational knowledge of AI agents, the Microsoft Agent Framework, and observability concepts.</a:t>
+            </a:r>
+          </a:p>
+          <a:p>
+            <a:pPr marL="0" indent="0">
+              <a:buNone/>
+            </a:pPr>
+            <a:endParaRPr lang="en-US" dirty="0">
+              <a:latin typeface="Segoe UI" panose="020B0502040204020203" pitchFamily="34" charset="0"/>
+              <a:cs typeface="Segoe UI" panose="020B0502040204020203" pitchFamily="34" charset="0"/>
+            </a:endParaRPr>
+          </a:p>
+          <a:p>
+            <a:pPr marL="0" indent="0">
+              <a:buNone/>
+            </a:pPr>
+            <a:r>
+              <a:rPr lang="en-US" dirty="0">
+                <a:latin typeface="Segoe UI" panose="020B0502040204020203" pitchFamily="34" charset="0"/>
+                <a:cs typeface="Segoe UI" panose="020B0502040204020203" pitchFamily="34" charset="0"/>
+              </a:rPr>
+              <a:t>An AI agent is different from a simple LLM API call. While a direct API call just sends a prompt and receives a response, an agent can reason about problems, decide when to use external tools, and orchestrate multiple steps to accomplish complex tasks. Understanding this distinction is crucial for building effective AI-powered applications.</a:t>
+            </a:r>
+          </a:p>
+          <a:p>
+            <a:pPr marL="0" indent="0">
+              <a:buNone/>
+            </a:pPr>
+            <a:endParaRPr lang="en-US" dirty="0">
+              <a:latin typeface="Segoe UI" panose="020B0502040204020203" pitchFamily="34" charset="0"/>
+              <a:cs typeface="Segoe UI" panose="020B0502040204020203" pitchFamily="34" charset="0"/>
+            </a:endParaRPr>
+          </a:p>
+          <a:p>
+            <a:pPr marL="0" indent="0">
+              <a:buNone/>
+            </a:pPr>
+            <a:r>
+              <a:rPr lang="en-US" dirty="0">
+                <a:latin typeface="Segoe UI" panose="020B0502040204020203" pitchFamily="34" charset="0"/>
+                <a:cs typeface="Segoe UI" panose="020B0502040204020203" pitchFamily="34" charset="0"/>
+              </a:rPr>
+              <a:t>In this challenge, you will study the Microsoft Agent Framework documentation and learn about tool calling, agent lifecycles, and why observability matters for AI systems.</a:t>
+            </a:r>
+          </a:p>
+        </p:txBody>
+      </p:sp>
+      <p:sp>
+        <p:nvSpPr>
+          <p:cNvPr id="4" name="Text Placeholder 3">
+            <a:extLst>
+              <a:ext uri="{FF2B5EF4-FFF2-40B4-BE49-F238E27FC236}">
+                <a16:creationId xmlns:a16="http://schemas.microsoft.com/office/drawing/2014/main" id="{91051B93-082E-F159-F4B6-DDC0E3942FE4}"/>
+              </a:ext>
+            </a:extLst>
+          </p:cNvPr>
+          <p:cNvSpPr>
+            <a:spLocks noGrp="1"/>
+          </p:cNvSpPr>
+          <p:nvPr>
+            <p:ph type="body" sz="quarter" idx="13"/>
+          </p:nvPr>
+        </p:nvSpPr>
+        <p:spPr/>
+        <p:txBody>
+          <a:bodyPr/>
+          <a:lstStyle/>
+          <a:p>
+            <a:r>
+              <a:rPr lang="en-US" sz="3200" b="1" dirty="0">
                 <a:solidFill>
-                  <a:srgbClr val="002060"/>
+                  <a:srgbClr val="7030A0"/>
                 </a:solidFill>
                 <a:latin typeface="Segoe UI" panose="020B0502040204020203" pitchFamily="34" charset="0"/>
                 <a:cs typeface="Segoe UI" panose="020B0502040204020203" pitchFamily="34" charset="0"/>
               </a:rPr>
+              <a:t>Master the Foundations – What makes an AI agent tick?</a:t>
+            </a:r>
+          </a:p>
+        </p:txBody>
+      </p:sp>
+      <p:sp>
+        <p:nvSpPr>
+          <p:cNvPr id="6" name="Title 5">
+            <a:extLst>
+              <a:ext uri="{FF2B5EF4-FFF2-40B4-BE49-F238E27FC236}">
+                <a16:creationId xmlns:a16="http://schemas.microsoft.com/office/drawing/2014/main" id="{C9A2E726-F8FE-9287-6F4A-257C69570E5B}"/>
+              </a:ext>
+            </a:extLst>
+          </p:cNvPr>
+          <p:cNvSpPr>
+            <a:spLocks noGrp="1"/>
+          </p:cNvSpPr>
+          <p:nvPr>
+            <p:ph type="title"/>
+          </p:nvPr>
+        </p:nvSpPr>
+        <p:spPr/>
+        <p:txBody>
+          <a:bodyPr/>
+          <a:lstStyle/>
+          <a:p>
+            <a:r>
+              <a:rPr lang="en-GB" dirty="0"/>
               <a:t>Challenge #1</a:t>
             </a:r>
-            <a:endParaRPr lang="en-US" sz="3200" b="1" dirty="0">
-              <a:solidFill>
-                <a:srgbClr val="7030A0"/>
-              </a:solidFill>
-              <a:latin typeface="Segoe UI" panose="020B0502040204020203" pitchFamily="34" charset="0"/>
-              <a:cs typeface="Segoe UI" panose="020B0502040204020203" pitchFamily="34" charset="0"/>
-            </a:endParaRPr>
-          </a:p>
-        </p:txBody>
-      </p:sp>
-      <p:sp>
-        <p:nvSpPr>
-          <p:cNvPr id="2" name="Text Placeholder 1"/>
-          <p:cNvSpPr>
-            <a:spLocks noGrp="1"/>
-          </p:cNvSpPr>
-          <p:nvPr>
-            <p:ph idx="1"/>
-          </p:nvPr>
-        </p:nvSpPr>
-        <p:spPr/>
-        <p:txBody>
-          <a:bodyPr>
-            <a:normAutofit fontScale="92500" lnSpcReduction="20000"/>
-          </a:bodyPr>
-          <a:lstStyle/>
-          <a:p>
-            <a:pPr marL="0" indent="0">
-              <a:buNone/>
-            </a:pPr>
-            <a:r>
-              <a:rPr lang="en-US" sz="2400" dirty="0">
-                <a:latin typeface="Segoe UI" panose="020B0502040204020203" pitchFamily="34" charset="0"/>
-                <a:cs typeface="Segoe UI" panose="020B0502040204020203" pitchFamily="34" charset="0"/>
-              </a:rPr>
-              <a:t>Your goal is to gain a solid understanding of the following concepts:</a:t>
-            </a:r>
-          </a:p>
-          <a:p>
-            <a:endParaRPr lang="en-US" sz="2400" dirty="0">
-              <a:latin typeface="Segoe UI" panose="020B0502040204020203" pitchFamily="34" charset="0"/>
-              <a:cs typeface="Segoe UI" panose="020B0502040204020203" pitchFamily="34" charset="0"/>
-            </a:endParaRPr>
-          </a:p>
-          <a:p>
-            <a:r>
-              <a:rPr lang="en-US" sz="2400" b="1" dirty="0">
-                <a:solidFill>
-                  <a:srgbClr val="F6C243"/>
-                </a:solidFill>
-                <a:latin typeface="Segoe UI" panose="020B0502040204020203" pitchFamily="34" charset="0"/>
-                <a:cs typeface="Segoe UI" panose="020B0502040204020203" pitchFamily="34" charset="0"/>
-              </a:rPr>
-              <a:t>AI Agents vs. Simple LLM Calls</a:t>
-            </a:r>
-          </a:p>
-          <a:p>
-            <a:pPr lvl="1"/>
-            <a:r>
-              <a:rPr lang="en-US" dirty="0">
-                <a:latin typeface="Segoe UI" panose="020B0502040204020203" pitchFamily="34" charset="0"/>
-                <a:cs typeface="Segoe UI" panose="020B0502040204020203" pitchFamily="34" charset="0"/>
-              </a:rPr>
-              <a:t>Understand what differentiates an agent from a basic chat completion API call</a:t>
-            </a:r>
-          </a:p>
-          <a:p>
-            <a:r>
-              <a:rPr lang="en-US" sz="2400" b="1" dirty="0">
-                <a:solidFill>
-                  <a:srgbClr val="F6C243"/>
-                </a:solidFill>
-                <a:latin typeface="Segoe UI" panose="020B0502040204020203" pitchFamily="34" charset="0"/>
-                <a:cs typeface="Segoe UI" panose="020B0502040204020203" pitchFamily="34" charset="0"/>
-              </a:rPr>
-              <a:t>Tool Calling</a:t>
-            </a:r>
-          </a:p>
-          <a:p>
-            <a:pPr lvl="1"/>
-            <a:r>
-              <a:rPr lang="en-US" dirty="0">
-                <a:latin typeface="Segoe UI" panose="020B0502040204020203" pitchFamily="34" charset="0"/>
-                <a:cs typeface="Segoe UI" panose="020B0502040204020203" pitchFamily="34" charset="0"/>
-              </a:rPr>
-              <a:t>Learn why agents need tools and how they decide when to call them</a:t>
-            </a:r>
-          </a:p>
-          <a:p>
-            <a:r>
-              <a:rPr lang="en-US" sz="2400" b="1" dirty="0">
-                <a:solidFill>
-                  <a:srgbClr val="F6C243"/>
-                </a:solidFill>
-                <a:latin typeface="Segoe UI" panose="020B0502040204020203" pitchFamily="34" charset="0"/>
-                <a:cs typeface="Segoe UI" panose="020B0502040204020203" pitchFamily="34" charset="0"/>
-              </a:rPr>
-              <a:t>Agent-Tool Lifecycle</a:t>
-            </a:r>
-          </a:p>
-          <a:p>
-            <a:pPr lvl="1"/>
-            <a:r>
-              <a:rPr lang="en-US" dirty="0">
-                <a:latin typeface="Segoe UI" panose="020B0502040204020203" pitchFamily="34" charset="0"/>
-                <a:cs typeface="Segoe UI" panose="020B0502040204020203" pitchFamily="34" charset="0"/>
-              </a:rPr>
-              <a:t>Understand the flow from user request through agent reasoning to tool execution and response</a:t>
-            </a:r>
-          </a:p>
-          <a:p>
-            <a:r>
-              <a:rPr lang="en-US" sz="2400" b="1" dirty="0" err="1">
-                <a:solidFill>
-                  <a:srgbClr val="F6C243"/>
-                </a:solidFill>
-                <a:latin typeface="Segoe UI" panose="020B0502040204020203" pitchFamily="34" charset="0"/>
-                <a:cs typeface="Segoe UI" panose="020B0502040204020203" pitchFamily="34" charset="0"/>
-              </a:rPr>
-              <a:t>OpenTelemetry</a:t>
-            </a:r>
-            <a:r>
-              <a:rPr lang="en-US" sz="2400" b="1" dirty="0">
-                <a:solidFill>
-                  <a:srgbClr val="F6C243"/>
-                </a:solidFill>
-                <a:latin typeface="Segoe UI" panose="020B0502040204020203" pitchFamily="34" charset="0"/>
-                <a:cs typeface="Segoe UI" panose="020B0502040204020203" pitchFamily="34" charset="0"/>
-              </a:rPr>
-              <a:t> Basics</a:t>
-            </a:r>
-          </a:p>
-          <a:p>
-            <a:pPr lvl="1"/>
-            <a:r>
-              <a:rPr lang="en-US" dirty="0">
-                <a:latin typeface="Segoe UI" panose="020B0502040204020203" pitchFamily="34" charset="0"/>
-                <a:cs typeface="Segoe UI" panose="020B0502040204020203" pitchFamily="34" charset="0"/>
-              </a:rPr>
-              <a:t>Learn about traces, metrics, and logs and why they matter for AI systems</a:t>
-            </a:r>
-          </a:p>
-          <a:p>
-            <a:r>
-              <a:rPr lang="en-US" sz="2400" b="1" dirty="0">
-                <a:solidFill>
-                  <a:srgbClr val="F6C243"/>
-                </a:solidFill>
-                <a:latin typeface="Segoe UI" panose="020B0502040204020203" pitchFamily="34" charset="0"/>
-                <a:cs typeface="Segoe UI" panose="020B0502040204020203" pitchFamily="34" charset="0"/>
-              </a:rPr>
-              <a:t>Application Architecture</a:t>
-            </a:r>
-          </a:p>
-          <a:p>
-            <a:pPr lvl="1"/>
-            <a:r>
-              <a:rPr lang="en-US" dirty="0">
-                <a:latin typeface="Segoe UI" panose="020B0502040204020203" pitchFamily="34" charset="0"/>
-                <a:cs typeface="Segoe UI" panose="020B0502040204020203" pitchFamily="34" charset="0"/>
-              </a:rPr>
-              <a:t>Understand how a Flask web app integrates with the Microsoft Agent Framework</a:t>
-            </a:r>
-          </a:p>
-        </p:txBody>
-      </p:sp>
-      <p:sp>
-        <p:nvSpPr>
-          <p:cNvPr id="8" name="Text Placeholder 7">
-            <a:extLst>
-              <a:ext uri="{FF2B5EF4-FFF2-40B4-BE49-F238E27FC236}">
-                <a16:creationId xmlns:a16="http://schemas.microsoft.com/office/drawing/2014/main" id="{E3048B16-5BF1-7CB9-7FB4-FEF3812F70B0}"/>
-              </a:ext>
-            </a:extLst>
-          </p:cNvPr>
-          <p:cNvSpPr>
-            <a:spLocks noGrp="1"/>
-          </p:cNvSpPr>
-          <p:nvPr>
-            <p:ph type="body" sz="quarter" idx="13"/>
-          </p:nvPr>
-        </p:nvSpPr>
-        <p:spPr/>
-        <p:txBody>
-          <a:bodyPr/>
-          <a:lstStyle/>
-          <a:p>
-            <a:r>
-              <a:rPr lang="en-US" dirty="0"/>
-              <a:t>Master the Foundations – What makes an AI agent tick?</a:t>
-            </a:r>
-          </a:p>
-        </p:txBody>
-      </p:sp>
-      <p:sp>
-        <p:nvSpPr>
-          <p:cNvPr id="4" name="TextBox 3">
-            <a:extLst>
-              <a:ext uri="{FF2B5EF4-FFF2-40B4-BE49-F238E27FC236}">
-                <a16:creationId xmlns:a16="http://schemas.microsoft.com/office/drawing/2014/main" id="{63CFF63D-04FB-705F-FDE7-615DA747FAC4}"/>
-              </a:ext>
-            </a:extLst>
-          </p:cNvPr>
-          <p:cNvSpPr txBox="1"/>
-          <p:nvPr/>
-        </p:nvSpPr>
-        <p:spPr>
-          <a:xfrm>
-            <a:off x="5034987" y="1307939"/>
-            <a:ext cx="184731" cy="369332"/>
-          </a:xfrm>
-          <a:prstGeom prst="rect">
-            <a:avLst/>
-          </a:prstGeom>
-          <a:noFill/>
-        </p:spPr>
-        <p:txBody>
-          <a:bodyPr wrap="none" rtlCol="0">
-            <a:spAutoFit/>
-          </a:bodyPr>
-          <a:lstStyle/>
-          <a:p>
-            <a:endParaRPr lang="en-US" dirty="0"/>
-          </a:p>
-        </p:txBody>
-      </p:sp>
-      <p:sp>
-        <p:nvSpPr>
-          <p:cNvPr id="6" name="TextBox 5">
-            <a:extLst>
-              <a:ext uri="{FF2B5EF4-FFF2-40B4-BE49-F238E27FC236}">
-                <a16:creationId xmlns:a16="http://schemas.microsoft.com/office/drawing/2014/main" id="{AB9110E3-5DA2-43FD-3338-F621924160AB}"/>
-              </a:ext>
-            </a:extLst>
-          </p:cNvPr>
-          <p:cNvSpPr txBox="1"/>
-          <p:nvPr/>
-        </p:nvSpPr>
-        <p:spPr>
-          <a:xfrm>
-            <a:off x="5775767" y="1088020"/>
-            <a:ext cx="184731" cy="369332"/>
-          </a:xfrm>
-          <a:prstGeom prst="rect">
-            <a:avLst/>
-          </a:prstGeom>
-          <a:noFill/>
-        </p:spPr>
-        <p:txBody>
-          <a:bodyPr wrap="none" rtlCol="0">
-            <a:spAutoFit/>
-          </a:bodyPr>
-          <a:lstStyle/>
-          <a:p>
-            <a:endParaRPr lang="en-US" dirty="0"/>
-          </a:p>
-        </p:txBody>
-      </p:sp>
-      <p:sp>
-        <p:nvSpPr>
-          <p:cNvPr id="7" name="TextBox 6">
-            <a:extLst>
-              <a:ext uri="{FF2B5EF4-FFF2-40B4-BE49-F238E27FC236}">
-                <a16:creationId xmlns:a16="http://schemas.microsoft.com/office/drawing/2014/main" id="{42E1B2F0-C4E0-E0F5-983F-767CA58230D0}"/>
-              </a:ext>
-            </a:extLst>
-          </p:cNvPr>
-          <p:cNvSpPr txBox="1"/>
-          <p:nvPr/>
-        </p:nvSpPr>
-        <p:spPr>
-          <a:xfrm>
-            <a:off x="6111433" y="1157468"/>
-            <a:ext cx="184731" cy="369332"/>
-          </a:xfrm>
-          <a:prstGeom prst="rect">
-            <a:avLst/>
-          </a:prstGeom>
-          <a:noFill/>
-        </p:spPr>
-        <p:txBody>
-          <a:bodyPr wrap="none" rtlCol="0">
-            <a:spAutoFit/>
-          </a:bodyPr>
-          <a:lstStyle/>
-          <a:p>
-            <a:endParaRPr lang="en-US" dirty="0"/>
+            <a:endParaRPr lang="en-DE" dirty="0"/>
           </a:p>
         </p:txBody>
       </p:sp>
     </p:spTree>
     <p:extLst>
       <p:ext uri="{BB962C8B-B14F-4D97-AF65-F5344CB8AC3E}">
-        <p14:creationId xmlns:p14="http://schemas.microsoft.com/office/powerpoint/2010/main" val="2471118552"/>
+        <p14:creationId xmlns:p14="http://schemas.microsoft.com/office/powerpoint/2010/main" val="2240261495"/>
       </p:ext>
     </p:extLst>
   </p:cSld>
@@ -18818,6 +19629,15 @@
 </file>
 
 <file path=customXml/item1.xml><?xml version="1.0" encoding="utf-8"?>
+<?mso-contentType ?>
+<FormTemplates xmlns="http://schemas.microsoft.com/sharepoint/v3/contenttype/forms">
+  <Display>DocumentLibraryForm</Display>
+  <Edit>DocumentLibraryForm</Edit>
+  <New>DocumentLibraryForm</New>
+</FormTemplates>
+</file>
+
+<file path=customXml/item2.xml><?xml version="1.0" encoding="utf-8"?>
 <p:properties xmlns:p="http://schemas.microsoft.com/office/2006/metadata/properties" xmlns:xsi="http://www.w3.org/2001/XMLSchema-instance" xmlns:pc="http://schemas.microsoft.com/office/infopath/2007/PartnerControls">
   <documentManagement>
     <_ip_UnifiedCompliancePolicyUIAction xmlns="http://schemas.microsoft.com/sharepoint/v3" xsi:nil="true"/>
@@ -18829,15 +19649,6 @@
     </lcf76f155ced4ddcb4097134ff3c332f>
   </documentManagement>
 </p:properties>
-</file>
-
-<file path=customXml/item2.xml><?xml version="1.0" encoding="utf-8"?>
-<?mso-contentType ?>
-<FormTemplates xmlns="http://schemas.microsoft.com/sharepoint/v3/contenttype/forms">
-  <Display>DocumentLibraryForm</Display>
-  <Edit>DocumentLibraryForm</Edit>
-  <New>DocumentLibraryForm</New>
-</FormTemplates>
 </file>
 
 <file path=customXml/item3.xml><?xml version="1.0" encoding="utf-8"?>
@@ -19114,6 +19925,14 @@
 </file>
 
 <file path=customXml/itemProps1.xml><?xml version="1.0" encoding="utf-8"?>
+<ds:datastoreItem xmlns:ds="http://schemas.openxmlformats.org/officeDocument/2006/customXml" ds:itemID="{FA84066F-CF25-477A-816A-71B1599BA426}">
+  <ds:schemaRefs>
+    <ds:schemaRef ds:uri="http://schemas.microsoft.com/sharepoint/v3/contenttype/forms"/>
+  </ds:schemaRefs>
+</ds:datastoreItem>
+</file>
+
+<file path=customXml/itemProps2.xml><?xml version="1.0" encoding="utf-8"?>
 <ds:datastoreItem xmlns:ds="http://schemas.openxmlformats.org/officeDocument/2006/customXml" ds:itemID="{FE1AEC35-FA48-4D92-B146-8AAF6D580B36}">
   <ds:schemaRefs>
     <ds:schemaRef ds:uri="http://schemas.microsoft.com/office/2006/documentManagement/types"/>
@@ -19128,14 +19947,6 @@
     <ds:schemaRef ds:uri="d5681aaf-e75d-4680-b6a5-67eaf1333073"/>
     <ds:schemaRef ds:uri="http://schemas.microsoft.com/sharepoint/v3"/>
     <ds:schemaRef ds:uri="http://purl.org/dc/elements/1.1/"/>
-  </ds:schemaRefs>
-</ds:datastoreItem>
-</file>
-
-<file path=customXml/itemProps2.xml><?xml version="1.0" encoding="utf-8"?>
-<ds:datastoreItem xmlns:ds="http://schemas.openxmlformats.org/officeDocument/2006/customXml" ds:itemID="{FA84066F-CF25-477A-816A-71B1599BA426}">
-  <ds:schemaRefs>
-    <ds:schemaRef ds:uri="http://schemas.microsoft.com/sharepoint/v3/contenttype/forms"/>
   </ds:schemaRefs>
 </ds:datastoreItem>
 </file>

</xml_diff>